<commit_message>
fixed the geom dodge
</commit_message>
<xml_diff>
--- a/docs/content/ggplot_1/ggplot_1_lecture.pptx
+++ b/docs/content/ggplot_1/ggplot_1_lecture.pptx
@@ -25,6 +25,7 @@
     <p:sldId id="273" r:id="rId19"/>
     <p:sldId id="274" r:id="rId20"/>
     <p:sldId id="275" r:id="rId21"/>
+    <p:sldId id="276" r:id="rId22"/>
   </p:sldIdLst>
   <p:sldSz cx="9144000" cy="5143500" type="screen16x9"/>
   <p:notesSz cx="6858000" cy="9144000"/>
@@ -3359,7 +3360,7 @@
             </a:pPr>
             <a:r>
               <a:rPr/>
-              <a:t>2026-09-08</a:t>
+              <a:t>2026-09-10</a:t>
             </a:r>
           </a:p>
         </p:txBody>
@@ -3388,42 +3389,12 @@
       </p:grpSpPr>
       <p:sp>
         <p:nvSpPr>
-          <p:cNvPr id="2" name="Title 1"/>
+          <p:cNvPr id="3" name="Text Placeholder 2"/>
           <p:cNvSpPr>
             <a:spLocks noGrp="1"/>
           </p:cNvSpPr>
           <p:nvPr>
-            <p:ph type="title"/>
-          </p:nvPr>
-        </p:nvSpPr>
-        <p:spPr>
-          <a:xfrm>
-            <a:off x="0" y="0"/>
-            <a:ext cx="9144000" cy="582780"/>
-          </a:xfrm>
-        </p:spPr>
-        <p:txBody>
-          <a:bodyPr/>
-          <a:lstStyle/>
-          <a:p>
-            <a:pPr lvl="0" indent="0" marL="0">
-              <a:buNone/>
-            </a:pPr>
-            <a:r>
-              <a:rPr/>
-              <a:t>→ ACTIVITY 3 Parts 1–2 now</a:t>
-            </a:r>
-          </a:p>
-        </p:txBody>
-      </p:sp>
-      <p:sp>
-        <p:nvSpPr>
-          <p:cNvPr id="3" name="Content Placeholder 2"/>
-          <p:cNvSpPr>
-            <a:spLocks noGrp="1"/>
-          </p:cNvSpPr>
-          <p:nvPr>
-            <p:ph idx="1"/>
+            <p:ph idx="1" type="body"/>
           </p:nvPr>
         </p:nvSpPr>
         <p:spPr/>
@@ -3431,41 +3402,1008 @@
           <a:bodyPr/>
           <a:lstStyle/>
           <a:p>
-            <a:pPr lvl="0" indent="0" marL="0">
+            <a:pPr lvl="0" indent="0">
               <a:buNone/>
             </a:pPr>
             <a:r>
+              <a:rPr>
+                <a:solidFill>
+                  <a:srgbClr val="5E5E5E"/>
+                </a:solidFill>
+                <a:latin typeface="Courier"/>
+              </a:rPr>
+              <a:t># scale_fill_manual() assigns exact colors to exact groups</a:t>
+            </a:r>
+            <a:br/>
+            <a:r>
+              <a:rPr>
+                <a:solidFill>
+                  <a:srgbClr val="003B4F"/>
+                </a:solidFill>
+                <a:latin typeface="Courier"/>
+              </a:rPr>
+              <a:t>leaf_df </a:t>
+            </a:r>
+            <a:r>
+              <a:rPr>
+                <a:solidFill>
+                  <a:srgbClr val="5E5E5E"/>
+                </a:solidFill>
+                <a:latin typeface="Courier"/>
+              </a:rPr>
+              <a:t>%&gt;%</a:t>
+            </a:r>
+            <a:br/>
+            <a:r>
+              <a:rPr>
+                <a:solidFill>
+                  <a:srgbClr val="003B4F"/>
+                </a:solidFill>
+                <a:latin typeface="Courier"/>
+              </a:rPr>
+              <a:t>  </a:t>
+            </a:r>
+            <a:r>
+              <a:rPr>
+                <a:solidFill>
+                  <a:srgbClr val="4758AB"/>
+                </a:solidFill>
+                <a:latin typeface="Courier"/>
+              </a:rPr>
+              <a:t>ggplot</a:t>
+            </a:r>
+            <a:r>
+              <a:rPr>
+                <a:solidFill>
+                  <a:srgbClr val="003B4F"/>
+                </a:solidFill>
+                <a:latin typeface="Courier"/>
+              </a:rPr>
+              <a:t>(</a:t>
+            </a:r>
+            <a:r>
+              <a:rPr>
+                <a:solidFill>
+                  <a:srgbClr val="4758AB"/>
+                </a:solidFill>
+                <a:latin typeface="Courier"/>
+              </a:rPr>
+              <a:t>aes</a:t>
+            </a:r>
+            <a:r>
+              <a:rPr>
+                <a:solidFill>
+                  <a:srgbClr val="003B4F"/>
+                </a:solidFill>
+                <a:latin typeface="Courier"/>
+              </a:rPr>
+              <a:t>(</a:t>
+            </a:r>
+            <a:r>
+              <a:rPr>
+                <a:solidFill>
+                  <a:srgbClr val="657422"/>
+                </a:solidFill>
+                <a:latin typeface="Courier"/>
+              </a:rPr>
+              <a:t>x =</a:t>
+            </a:r>
+            <a:r>
+              <a:rPr>
+                <a:solidFill>
+                  <a:srgbClr val="003B4F"/>
+                </a:solidFill>
+                <a:latin typeface="Courier"/>
+              </a:rPr>
+              <a:t> shade, </a:t>
+            </a:r>
+            <a:r>
+              <a:rPr>
+                <a:solidFill>
+                  <a:srgbClr val="657422"/>
+                </a:solidFill>
+                <a:latin typeface="Courier"/>
+              </a:rPr>
+              <a:t>y =</a:t>
+            </a:r>
+            <a:r>
+              <a:rPr>
+                <a:solidFill>
+                  <a:srgbClr val="003B4F"/>
+                </a:solidFill>
+                <a:latin typeface="Courier"/>
+              </a:rPr>
+              <a:t> mass_g, </a:t>
+            </a:r>
+            <a:r>
+              <a:rPr>
+                <a:solidFill>
+                  <a:srgbClr val="657422"/>
+                </a:solidFill>
+                <a:latin typeface="Courier"/>
+              </a:rPr>
+              <a:t>fill =</a:t>
+            </a:r>
+            <a:r>
+              <a:rPr>
+                <a:solidFill>
+                  <a:srgbClr val="003B4F"/>
+                </a:solidFill>
+                <a:latin typeface="Courier"/>
+              </a:rPr>
+              <a:t> shade)) </a:t>
+            </a:r>
+            <a:r>
+              <a:rPr>
+                <a:solidFill>
+                  <a:srgbClr val="5E5E5E"/>
+                </a:solidFill>
+                <a:latin typeface="Courier"/>
+              </a:rPr>
+              <a:t>+</a:t>
+            </a:r>
+            <a:br/>
+            <a:r>
+              <a:rPr>
+                <a:solidFill>
+                  <a:srgbClr val="003B4F"/>
+                </a:solidFill>
+                <a:latin typeface="Courier"/>
+              </a:rPr>
+              <a:t>  </a:t>
+            </a:r>
+            <a:r>
+              <a:rPr>
+                <a:solidFill>
+                  <a:srgbClr val="4758AB"/>
+                </a:solidFill>
+                <a:latin typeface="Courier"/>
+              </a:rPr>
+              <a:t>geom_boxplot</a:t>
+            </a:r>
+            <a:r>
+              <a:rPr>
+                <a:solidFill>
+                  <a:srgbClr val="003B4F"/>
+                </a:solidFill>
+                <a:latin typeface="Courier"/>
+              </a:rPr>
+              <a:t>(</a:t>
+            </a:r>
+            <a:r>
+              <a:rPr>
+                <a:solidFill>
+                  <a:srgbClr val="657422"/>
+                </a:solidFill>
+                <a:latin typeface="Courier"/>
+              </a:rPr>
+              <a:t>alpha =</a:t>
+            </a:r>
+            <a:r>
+              <a:rPr>
+                <a:solidFill>
+                  <a:srgbClr val="003B4F"/>
+                </a:solidFill>
+                <a:latin typeface="Courier"/>
+              </a:rPr>
+              <a:t> </a:t>
+            </a:r>
+            <a:r>
+              <a:rPr>
+                <a:solidFill>
+                  <a:srgbClr val="AD0000"/>
+                </a:solidFill>
+                <a:latin typeface="Courier"/>
+              </a:rPr>
+              <a:t>0.6</a:t>
+            </a:r>
+            <a:r>
+              <a:rPr>
+                <a:solidFill>
+                  <a:srgbClr val="003B4F"/>
+                </a:solidFill>
+                <a:latin typeface="Courier"/>
+              </a:rPr>
+              <a:t>, </a:t>
+            </a:r>
+            <a:r>
+              <a:rPr>
+                <a:solidFill>
+                  <a:srgbClr val="657422"/>
+                </a:solidFill>
+                <a:latin typeface="Courier"/>
+              </a:rPr>
+              <a:t>outlier.shape =</a:t>
+            </a:r>
+            <a:r>
+              <a:rPr>
+                <a:solidFill>
+                  <a:srgbClr val="003B4F"/>
+                </a:solidFill>
+                <a:latin typeface="Courier"/>
+              </a:rPr>
+              <a:t> </a:t>
+            </a:r>
+            <a:r>
+              <a:rPr>
+                <a:solidFill>
+                  <a:srgbClr val="8F5902"/>
+                </a:solidFill>
+                <a:latin typeface="Courier"/>
+              </a:rPr>
+              <a:t>NA</a:t>
+            </a:r>
+            <a:r>
+              <a:rPr>
+                <a:solidFill>
+                  <a:srgbClr val="003B4F"/>
+                </a:solidFill>
+                <a:latin typeface="Courier"/>
+              </a:rPr>
+              <a:t>) </a:t>
+            </a:r>
+            <a:r>
+              <a:rPr>
+                <a:solidFill>
+                  <a:srgbClr val="5E5E5E"/>
+                </a:solidFill>
+                <a:latin typeface="Courier"/>
+              </a:rPr>
+              <a:t>+</a:t>
+            </a:r>
+            <a:br/>
+            <a:r>
+              <a:rPr>
+                <a:solidFill>
+                  <a:srgbClr val="003B4F"/>
+                </a:solidFill>
+                <a:latin typeface="Courier"/>
+              </a:rPr>
+              <a:t>  </a:t>
+            </a:r>
+            <a:r>
+              <a:rPr>
+                <a:solidFill>
+                  <a:srgbClr val="4758AB"/>
+                </a:solidFill>
+                <a:latin typeface="Courier"/>
+              </a:rPr>
+              <a:t>geom_point</a:t>
+            </a:r>
+            <a:r>
+              <a:rPr>
+                <a:solidFill>
+                  <a:srgbClr val="003B4F"/>
+                </a:solidFill>
+                <a:latin typeface="Courier"/>
+              </a:rPr>
+              <a:t>(</a:t>
+            </a:r>
+            <a:r>
+              <a:rPr>
+                <a:solidFill>
+                  <a:srgbClr val="657422"/>
+                </a:solidFill>
+                <a:latin typeface="Courier"/>
+              </a:rPr>
+              <a:t>position =</a:t>
+            </a:r>
+            <a:r>
+              <a:rPr>
+                <a:solidFill>
+                  <a:srgbClr val="003B4F"/>
+                </a:solidFill>
+                <a:latin typeface="Courier"/>
+              </a:rPr>
+              <a:t> jitter_pos, </a:t>
+            </a:r>
+            <a:r>
+              <a:rPr>
+                <a:solidFill>
+                  <a:srgbClr val="657422"/>
+                </a:solidFill>
+                <a:latin typeface="Courier"/>
+              </a:rPr>
+              <a:t>alpha =</a:t>
+            </a:r>
+            <a:r>
+              <a:rPr>
+                <a:solidFill>
+                  <a:srgbClr val="003B4F"/>
+                </a:solidFill>
+                <a:latin typeface="Courier"/>
+              </a:rPr>
+              <a:t> </a:t>
+            </a:r>
+            <a:r>
+              <a:rPr>
+                <a:solidFill>
+                  <a:srgbClr val="AD0000"/>
+                </a:solidFill>
+                <a:latin typeface="Courier"/>
+              </a:rPr>
+              <a:t>0.6</a:t>
+            </a:r>
+            <a:r>
+              <a:rPr>
+                <a:solidFill>
+                  <a:srgbClr val="003B4F"/>
+                </a:solidFill>
+                <a:latin typeface="Courier"/>
+              </a:rPr>
+              <a:t>) </a:t>
+            </a:r>
+            <a:r>
+              <a:rPr>
+                <a:solidFill>
+                  <a:srgbClr val="5E5E5E"/>
+                </a:solidFill>
+                <a:latin typeface="Courier"/>
+              </a:rPr>
+              <a:t>+</a:t>
+            </a:r>
+            <a:br/>
+            <a:r>
+              <a:rPr>
+                <a:solidFill>
+                  <a:srgbClr val="003B4F"/>
+                </a:solidFill>
+                <a:latin typeface="Courier"/>
+              </a:rPr>
+              <a:t>  </a:t>
+            </a:r>
+            <a:r>
+              <a:rPr>
+                <a:solidFill>
+                  <a:srgbClr val="4758AB"/>
+                </a:solidFill>
+                <a:latin typeface="Courier"/>
+              </a:rPr>
+              <a:t>scale_fill_manual</a:t>
+            </a:r>
+            <a:r>
+              <a:rPr>
+                <a:solidFill>
+                  <a:srgbClr val="003B4F"/>
+                </a:solidFill>
+                <a:latin typeface="Courier"/>
+              </a:rPr>
+              <a:t>(</a:t>
+            </a:r>
+            <a:r>
+              <a:rPr>
+                <a:solidFill>
+                  <a:srgbClr val="657422"/>
+                </a:solidFill>
+                <a:latin typeface="Courier"/>
+              </a:rPr>
+              <a:t>values =</a:t>
+            </a:r>
+            <a:r>
+              <a:rPr>
+                <a:solidFill>
+                  <a:srgbClr val="003B4F"/>
+                </a:solidFill>
+                <a:latin typeface="Courier"/>
+              </a:rPr>
+              <a:t> </a:t>
+            </a:r>
+            <a:r>
+              <a:rPr>
+                <a:solidFill>
+                  <a:srgbClr val="4758AB"/>
+                </a:solidFill>
+                <a:latin typeface="Courier"/>
+              </a:rPr>
+              <a:t>c</a:t>
+            </a:r>
+            <a:r>
+              <a:rPr>
+                <a:solidFill>
+                  <a:srgbClr val="003B4F"/>
+                </a:solidFill>
+                <a:latin typeface="Courier"/>
+              </a:rPr>
+              <a:t>(</a:t>
+            </a:r>
+            <a:br/>
+            <a:r>
+              <a:rPr>
+                <a:solidFill>
+                  <a:srgbClr val="003B4F"/>
+                </a:solidFill>
+                <a:latin typeface="Courier"/>
+              </a:rPr>
+              <a:t>    </a:t>
+            </a:r>
+            <a:r>
+              <a:rPr>
+                <a:solidFill>
+                  <a:srgbClr val="20794D"/>
+                </a:solidFill>
+                <a:latin typeface="Courier"/>
+              </a:rPr>
+              <a:t>"sunny"</a:t>
+            </a:r>
+            <a:r>
+              <a:rPr>
+                <a:solidFill>
+                  <a:srgbClr val="003B4F"/>
+                </a:solidFill>
+                <a:latin typeface="Courier"/>
+              </a:rPr>
+              <a:t> = </a:t>
+            </a:r>
+            <a:r>
+              <a:rPr>
+                <a:solidFill>
+                  <a:srgbClr val="20794D"/>
+                </a:solidFill>
+                <a:latin typeface="Courier"/>
+              </a:rPr>
+              <a:t>"goldenrod"</a:t>
+            </a:r>
+            <a:r>
+              <a:rPr>
+                <a:solidFill>
+                  <a:srgbClr val="003B4F"/>
+                </a:solidFill>
+                <a:latin typeface="Courier"/>
+              </a:rPr>
+              <a:t>,</a:t>
+            </a:r>
+            <a:br/>
+            <a:r>
+              <a:rPr>
+                <a:solidFill>
+                  <a:srgbClr val="003B4F"/>
+                </a:solidFill>
+                <a:latin typeface="Courier"/>
+              </a:rPr>
+              <a:t>    </a:t>
+            </a:r>
+            <a:r>
+              <a:rPr>
+                <a:solidFill>
+                  <a:srgbClr val="20794D"/>
+                </a:solidFill>
+                <a:latin typeface="Courier"/>
+              </a:rPr>
+              <a:t>"shady"</a:t>
+            </a:r>
+            <a:r>
+              <a:rPr>
+                <a:solidFill>
+                  <a:srgbClr val="003B4F"/>
+                </a:solidFill>
+                <a:latin typeface="Courier"/>
+              </a:rPr>
+              <a:t> = </a:t>
+            </a:r>
+            <a:r>
+              <a:rPr>
+                <a:solidFill>
+                  <a:srgbClr val="20794D"/>
+                </a:solidFill>
+                <a:latin typeface="Courier"/>
+              </a:rPr>
+              <a:t>"forestgreen"</a:t>
+            </a:r>
+            <a:br/>
+            <a:r>
+              <a:rPr>
+                <a:solidFill>
+                  <a:srgbClr val="003B4F"/>
+                </a:solidFill>
+                <a:latin typeface="Courier"/>
+              </a:rPr>
+              <a:t>  )) </a:t>
+            </a:r>
+            <a:r>
+              <a:rPr>
+                <a:solidFill>
+                  <a:srgbClr val="5E5E5E"/>
+                </a:solidFill>
+                <a:latin typeface="Courier"/>
+              </a:rPr>
+              <a:t>+</a:t>
+            </a:r>
+            <a:br/>
+            <a:r>
+              <a:rPr>
+                <a:solidFill>
+                  <a:srgbClr val="003B4F"/>
+                </a:solidFill>
+                <a:latin typeface="Courier"/>
+              </a:rPr>
+              <a:t>  </a:t>
+            </a:r>
+            <a:r>
+              <a:rPr>
+                <a:solidFill>
+                  <a:srgbClr val="4758AB"/>
+                </a:solidFill>
+                <a:latin typeface="Courier"/>
+              </a:rPr>
+              <a:t>labs</a:t>
+            </a:r>
+            <a:r>
+              <a:rPr>
+                <a:solidFill>
+                  <a:srgbClr val="003B4F"/>
+                </a:solidFill>
+                <a:latin typeface="Courier"/>
+              </a:rPr>
+              <a:t>(</a:t>
+            </a:r>
+            <a:br/>
+            <a:r>
+              <a:rPr>
+                <a:solidFill>
+                  <a:srgbClr val="003B4F"/>
+                </a:solidFill>
+                <a:latin typeface="Courier"/>
+              </a:rPr>
+              <a:t>    </a:t>
+            </a:r>
+            <a:r>
+              <a:rPr>
+                <a:solidFill>
+                  <a:srgbClr val="657422"/>
+                </a:solidFill>
+                <a:latin typeface="Courier"/>
+              </a:rPr>
+              <a:t>title =</a:t>
+            </a:r>
+            <a:r>
+              <a:rPr>
+                <a:solidFill>
+                  <a:srgbClr val="003B4F"/>
+                </a:solidFill>
+                <a:latin typeface="Courier"/>
+              </a:rPr>
+              <a:t> </a:t>
+            </a:r>
+            <a:r>
+              <a:rPr>
+                <a:solidFill>
+                  <a:srgbClr val="20794D"/>
+                </a:solidFill>
+                <a:latin typeface="Courier"/>
+              </a:rPr>
+              <a:t>"Leaf Mass by Shade"</a:t>
+            </a:r>
+            <a:r>
+              <a:rPr>
+                <a:solidFill>
+                  <a:srgbClr val="003B4F"/>
+                </a:solidFill>
+                <a:latin typeface="Courier"/>
+              </a:rPr>
+              <a:t>,</a:t>
+            </a:r>
+            <a:br/>
+            <a:r>
+              <a:rPr>
+                <a:solidFill>
+                  <a:srgbClr val="003B4F"/>
+                </a:solidFill>
+                <a:latin typeface="Courier"/>
+              </a:rPr>
+              <a:t>    </a:t>
+            </a:r>
+            <a:r>
+              <a:rPr>
+                <a:solidFill>
+                  <a:srgbClr val="657422"/>
+                </a:solidFill>
+                <a:latin typeface="Courier"/>
+              </a:rPr>
+              <a:t>x =</a:t>
+            </a:r>
+            <a:r>
+              <a:rPr>
+                <a:solidFill>
+                  <a:srgbClr val="003B4F"/>
+                </a:solidFill>
+                <a:latin typeface="Courier"/>
+              </a:rPr>
+              <a:t> </a:t>
+            </a:r>
+            <a:r>
+              <a:rPr>
+                <a:solidFill>
+                  <a:srgbClr val="20794D"/>
+                </a:solidFill>
+                <a:latin typeface="Courier"/>
+              </a:rPr>
+              <a:t>"Shade"</a:t>
+            </a:r>
+            <a:r>
+              <a:rPr>
+                <a:solidFill>
+                  <a:srgbClr val="003B4F"/>
+                </a:solidFill>
+                <a:latin typeface="Courier"/>
+              </a:rPr>
+              <a:t>,</a:t>
+            </a:r>
+            <a:br/>
+            <a:r>
+              <a:rPr>
+                <a:solidFill>
+                  <a:srgbClr val="003B4F"/>
+                </a:solidFill>
+                <a:latin typeface="Courier"/>
+              </a:rPr>
+              <a:t>    </a:t>
+            </a:r>
+            <a:r>
+              <a:rPr>
+                <a:solidFill>
+                  <a:srgbClr val="657422"/>
+                </a:solidFill>
+                <a:latin typeface="Courier"/>
+              </a:rPr>
+              <a:t>y =</a:t>
+            </a:r>
+            <a:r>
+              <a:rPr>
+                <a:solidFill>
+                  <a:srgbClr val="003B4F"/>
+                </a:solidFill>
+                <a:latin typeface="Courier"/>
+              </a:rPr>
+              <a:t> </a:t>
+            </a:r>
+            <a:r>
+              <a:rPr>
+                <a:solidFill>
+                  <a:srgbClr val="20794D"/>
+                </a:solidFill>
+                <a:latin typeface="Courier"/>
+              </a:rPr>
+              <a:t>"Leaf Mass (g)"</a:t>
+            </a:r>
+            <a:r>
+              <a:rPr>
+                <a:solidFill>
+                  <a:srgbClr val="003B4F"/>
+                </a:solidFill>
+                <a:latin typeface="Courier"/>
+              </a:rPr>
+              <a:t>,</a:t>
+            </a:r>
+            <a:br/>
+            <a:r>
+              <a:rPr>
+                <a:solidFill>
+                  <a:srgbClr val="003B4F"/>
+                </a:solidFill>
+                <a:latin typeface="Courier"/>
+              </a:rPr>
+              <a:t>    </a:t>
+            </a:r>
+            <a:r>
+              <a:rPr>
+                <a:solidFill>
+                  <a:srgbClr val="657422"/>
+                </a:solidFill>
+                <a:latin typeface="Courier"/>
+              </a:rPr>
+              <a:t>fill =</a:t>
+            </a:r>
+            <a:r>
+              <a:rPr>
+                <a:solidFill>
+                  <a:srgbClr val="003B4F"/>
+                </a:solidFill>
+                <a:latin typeface="Courier"/>
+              </a:rPr>
+              <a:t> </a:t>
+            </a:r>
+            <a:r>
+              <a:rPr>
+                <a:solidFill>
+                  <a:srgbClr val="20794D"/>
+                </a:solidFill>
+                <a:latin typeface="Courier"/>
+              </a:rPr>
+              <a:t>"Shade"</a:t>
+            </a:r>
+            <a:br/>
+            <a:r>
+              <a:rPr>
+                <a:solidFill>
+                  <a:srgbClr val="003B4F"/>
+                </a:solidFill>
+                <a:latin typeface="Courier"/>
+              </a:rPr>
+              <a:t>  ) </a:t>
+            </a:r>
+            <a:r>
+              <a:rPr>
+                <a:solidFill>
+                  <a:srgbClr val="5E5E5E"/>
+                </a:solidFill>
+                <a:latin typeface="Courier"/>
+              </a:rPr>
+              <a:t>+</a:t>
+            </a:r>
+            <a:br/>
+            <a:r>
+              <a:rPr>
+                <a:solidFill>
+                  <a:srgbClr val="003B4F"/>
+                </a:solidFill>
+                <a:latin typeface="Courier"/>
+              </a:rPr>
+              <a:t>  </a:t>
+            </a:r>
+            <a:r>
+              <a:rPr>
+                <a:solidFill>
+                  <a:srgbClr val="4758AB"/>
+                </a:solidFill>
+                <a:latin typeface="Courier"/>
+              </a:rPr>
+              <a:t>theme_minimal</a:t>
+            </a:r>
+            <a:r>
+              <a:rPr>
+                <a:solidFill>
+                  <a:srgbClr val="003B4F"/>
+                </a:solidFill>
+                <a:latin typeface="Courier"/>
+              </a:rPr>
+              <a:t>() </a:t>
+            </a:r>
+            <a:r>
+              <a:rPr>
+                <a:solidFill>
+                  <a:srgbClr val="5E5E5E"/>
+                </a:solidFill>
+                <a:latin typeface="Courier"/>
+              </a:rPr>
+              <a:t>+</a:t>
+            </a:r>
+            <a:br/>
+            <a:r>
+              <a:rPr>
+                <a:solidFill>
+                  <a:srgbClr val="003B4F"/>
+                </a:solidFill>
+                <a:latin typeface="Courier"/>
+              </a:rPr>
+              <a:t>  </a:t>
+            </a:r>
+            <a:r>
+              <a:rPr>
+                <a:solidFill>
+                  <a:srgbClr val="4758AB"/>
+                </a:solidFill>
+                <a:latin typeface="Courier"/>
+              </a:rPr>
+              <a:t>theme</a:t>
+            </a:r>
+            <a:r>
+              <a:rPr>
+                <a:solidFill>
+                  <a:srgbClr val="003B4F"/>
+                </a:solidFill>
+                <a:latin typeface="Courier"/>
+              </a:rPr>
+              <a:t>(</a:t>
+            </a:r>
+            <a:r>
+              <a:rPr>
+                <a:solidFill>
+                  <a:srgbClr val="657422"/>
+                </a:solidFill>
+                <a:latin typeface="Courier"/>
+              </a:rPr>
+              <a:t>legend.position =</a:t>
+            </a:r>
+            <a:r>
+              <a:rPr>
+                <a:solidFill>
+                  <a:srgbClr val="003B4F"/>
+                </a:solidFill>
+                <a:latin typeface="Courier"/>
+              </a:rPr>
+              <a:t> </a:t>
+            </a:r>
+            <a:r>
+              <a:rPr>
+                <a:solidFill>
+                  <a:srgbClr val="20794D"/>
+                </a:solidFill>
+                <a:latin typeface="Courier"/>
+              </a:rPr>
+              <a:t>"none"</a:t>
+            </a:r>
+            <a:r>
+              <a:rPr>
+                <a:solidFill>
+                  <a:srgbClr val="003B4F"/>
+                </a:solidFill>
+                <a:latin typeface="Courier"/>
+              </a:rPr>
+              <a:t>)</a:t>
+            </a:r>
+          </a:p>
+        </p:txBody>
+      </p:sp>
+      <p:pic>
+        <p:nvPicPr>
+          <p:cNvPr descr="ggplot_1_lecture_files/figure-pptx/scale-manual-demo-1.png" id="0" name="Picture 1"/>
+          <p:cNvPicPr>
+            <a:picLocks noGrp="1" noChangeAspect="1"/>
+          </p:cNvPicPr>
+          <p:nvPr/>
+        </p:nvPicPr>
+        <p:blipFill>
+          <a:blip r:embed="rId2"/>
+          <a:stretch>
+            <a:fillRect/>
+          </a:stretch>
+        </p:blipFill>
+        <p:spPr bwMode="auto">
+          <a:xfrm>
+            <a:off x="127000" y="1562100"/>
+            <a:ext cx="4432300" cy="2730500"/>
+          </a:xfrm>
+          <a:prstGeom prst="rect">
+            <a:avLst/>
+          </a:prstGeom>
+          <a:noFill/>
+          <a:ln w="9525">
+            <a:noFill/>
+            <a:headEnd/>
+            <a:tailEnd/>
+          </a:ln>
+        </p:spPr>
+      </p:pic>
+      <p:sp>
+        <p:nvSpPr>
+          <p:cNvPr id="5" name="Text Placeholder 4"/>
+          <p:cNvSpPr>
+            <a:spLocks noGrp="1"/>
+          </p:cNvSpPr>
+          <p:nvPr>
+            <p:ph idx="3" sz="quarter" type="body"/>
+          </p:nvPr>
+        </p:nvSpPr>
+        <p:spPr/>
+        <p:txBody>
+          <a:bodyPr/>
+          <a:lstStyle/>
+          <a:p>
+            <a:pPr lvl="0"/>
+            <a:r>
+              <a:rPr>
+                <a:latin typeface="Courier"/>
+              </a:rPr>
+              <a:t>scale_fill_manual()</a:t>
+            </a:r>
+            <a:r>
+              <a:rPr/>
+              <a:t> — for </a:t>
+            </a:r>
+            <a:r>
+              <a:rPr>
+                <a:latin typeface="Courier"/>
+              </a:rPr>
+              <a:t>fill =</a:t>
+            </a:r>
+            <a:r>
+              <a:rPr/>
+              <a:t> aesthetics (boxes, bars, columns)</a:t>
+            </a:r>
+          </a:p>
+          <a:p>
+            <a:pPr lvl="0"/>
+            <a:r>
+              <a:rPr>
+                <a:latin typeface="Courier"/>
+              </a:rPr>
+              <a:t>scale_color_manual()</a:t>
+            </a:r>
+            <a:r>
+              <a:rPr/>
+              <a:t> — for </a:t>
+            </a:r>
+            <a:r>
+              <a:rPr>
+                <a:latin typeface="Courier"/>
+              </a:rPr>
+              <a:t>color =</a:t>
+            </a:r>
+            <a:r>
+              <a:rPr/>
+              <a:t> aesthetics (points, lines)</a:t>
+            </a:r>
+          </a:p>
+          <a:p>
+            <a:pPr lvl="0"/>
+            <a:r>
+              <a:rPr/>
+              <a:t>The </a:t>
+            </a:r>
+            <a:r>
               <a:rPr b="1"/>
-              <a:t>🛑 Do Activity Parts 1–2 now</a:t>
-            </a:r>
-          </a:p>
-          <a:p>
-            <a:pPr lvl="0" indent="0" marL="0">
+              <a:t>names inside </a:t>
+            </a:r>
+            <a:r>
+              <a:rPr b="1">
+                <a:latin typeface="Courier"/>
+              </a:rPr>
+              <a:t>c()</a:t>
+            </a:r>
+            <a:r>
+              <a:rPr b="1"/>
+              <a:t> must exactly match</a:t>
+            </a:r>
+            <a:r>
+              <a:rPr/>
+              <a:t> the values in your data (</a:t>
+            </a:r>
+            <a:r>
+              <a:rPr>
+                <a:latin typeface="Courier"/>
+              </a:rPr>
+              <a:t>"sunny"</a:t>
+            </a:r>
+            <a:r>
+              <a:rPr/>
+              <a:t>, </a:t>
+            </a:r>
+            <a:r>
+              <a:rPr>
+                <a:latin typeface="Courier"/>
+              </a:rPr>
+              <a:t>"shady"</a:t>
+            </a:r>
+            <a:r>
+              <a:rPr/>
+              <a:t>) — case and spelling both count</a:t>
+            </a:r>
+          </a:p>
+          <a:p>
+            <a:pPr lvl="0" indent="0" marL="1270000">
               <a:buNone/>
             </a:pPr>
             <a:r>
-              <a:rPr/>
-              <a:t>Pipe into </a:t>
-            </a:r>
-            <a:r>
-              <a:rPr>
-                <a:latin typeface="Courier"/>
-              </a:rPr>
-              <a:t>ggplot()</a:t>
-            </a:r>
-            <a:r>
-              <a:rPr/>
-              <a:t>, then assign sunny/shady their own colors with </a:t>
-            </a:r>
-            <a:r>
-              <a:rPr>
-                <a:latin typeface="Courier"/>
-              </a:rPr>
-              <a:t>scale_fill_manual()</a:t>
-            </a:r>
-            <a:r>
-              <a:rPr/>
-              <a:t>. Predict, type, run.</a:t>
+              <a:rPr sz="2000" b="1"/>
+              <a:t>Warning</a:t>
+            </a:r>
+          </a:p>
+          <a:p>
+            <a:pPr lvl="0" indent="0" marL="1270000">
+              <a:buNone/>
+            </a:pPr>
+            <a:r>
+              <a:rPr sz="2000" b="1"/>
+              <a:t>⚠️ Watch out!</a:t>
+            </a:r>
+          </a:p>
+          <a:p>
+            <a:pPr lvl="0" indent="0" marL="1270000">
+              <a:buNone/>
+            </a:pPr>
+            <a:r>
+              <a:rPr sz="2000"/>
+              <a:t>If a name in </a:t>
+            </a:r>
+            <a:r>
+              <a:rPr sz="2000">
+                <a:latin typeface="Courier"/>
+              </a:rPr>
+              <a:t>values = c(...)</a:t>
+            </a:r>
+            <a:r>
+              <a:rPr sz="2000"/>
+              <a:t> doesn’t match a value in your data exactly, that group’s color falls back to grey and ggplot prints a warning.</a:t>
             </a:r>
           </a:p>
         </p:txBody>
@@ -3517,7 +4455,7 @@
             </a:pPr>
             <a:r>
               <a:rPr/>
-              <a:t>🧩 Chunk 2 of 3 · Small Multiples with Facets</a:t>
+              <a:t>→ ACTIVITY 3 Parts 1–2 now</a:t>
             </a:r>
           </a:p>
         </p:txBody>
@@ -3542,31 +4480,7 @@
             </a:pPr>
             <a:r>
               <a:rPr b="1"/>
-              <a:t>We will cover:</a:t>
-            </a:r>
-            <a:r>
-              <a:rPr/>
-              <a:t> </a:t>
-            </a:r>
-            <a:r>
-              <a:rPr>
-                <a:latin typeface="Courier"/>
-              </a:rPr>
-              <a:t>facet_wrap()</a:t>
-            </a:r>
-            <a:r>
-              <a:rPr/>
-              <a:t> and </a:t>
-            </a:r>
-            <a:r>
-              <a:rPr>
-                <a:latin typeface="Courier"/>
-              </a:rPr>
-              <a:t>facet_grid()</a:t>
-            </a:r>
-            <a:r>
-              <a:rPr/>
-              <a:t> — splitting one plot into a panel per group.</a:t>
+              <a:t>🛑 Do Activity Parts 1–2 now</a:t>
             </a:r>
           </a:p>
           <a:p>
@@ -3574,8 +4488,28 @@
               <a:buNone/>
             </a:pPr>
             <a:r>
-              <a:rPr b="1"/>
-              <a:t>🛑 After this chunk you will do Activity Part 3.</a:t>
+              <a:rPr/>
+              <a:t>Pipe into </a:t>
+            </a:r>
+            <a:r>
+              <a:rPr>
+                <a:latin typeface="Courier"/>
+              </a:rPr>
+              <a:t>ggplot()</a:t>
+            </a:r>
+            <a:r>
+              <a:rPr/>
+              <a:t>, then assign sunny/shady their own colors with </a:t>
+            </a:r>
+            <a:r>
+              <a:rPr>
+                <a:latin typeface="Courier"/>
+              </a:rPr>
+              <a:t>scale_fill_manual()</a:t>
+            </a:r>
+            <a:r>
+              <a:rPr/>
+              <a:t>. Predict, type, run.</a:t>
             </a:r>
           </a:p>
         </p:txBody>
@@ -3586,6 +4520,116 @@
 </file>
 
 <file path=ppt/slides/slide12.xml><?xml version="1.0" encoding="utf-8"?>
+<p:sld xmlns:a="http://schemas.openxmlformats.org/drawingml/2006/main" xmlns:r="http://schemas.openxmlformats.org/officeDocument/2006/relationships" xmlns:p="http://schemas.openxmlformats.org/presentationml/2006/main">
+  <p:cSld>
+    <p:spTree>
+      <p:nvGrpSpPr>
+        <p:cNvPr id="1" name=""/>
+        <p:cNvGrpSpPr/>
+        <p:nvPr/>
+      </p:nvGrpSpPr>
+      <p:grpSpPr>
+        <a:xfrm>
+          <a:off x="0" y="0"/>
+          <a:ext cx="0" cy="0"/>
+          <a:chOff x="0" y="0"/>
+          <a:chExt cx="0" cy="0"/>
+        </a:xfrm>
+      </p:grpSpPr>
+      <p:sp>
+        <p:nvSpPr>
+          <p:cNvPr id="2" name="Title 1"/>
+          <p:cNvSpPr>
+            <a:spLocks noGrp="1"/>
+          </p:cNvSpPr>
+          <p:nvPr>
+            <p:ph type="title"/>
+          </p:nvPr>
+        </p:nvSpPr>
+        <p:spPr>
+          <a:xfrm>
+            <a:off x="0" y="0"/>
+            <a:ext cx="9144000" cy="582780"/>
+          </a:xfrm>
+        </p:spPr>
+        <p:txBody>
+          <a:bodyPr/>
+          <a:lstStyle/>
+          <a:p>
+            <a:pPr lvl="0" indent="0" marL="0">
+              <a:buNone/>
+            </a:pPr>
+            <a:r>
+              <a:rPr/>
+              <a:t>🧩 Chunk 2 of 3 · Small Multiples with Facets</a:t>
+            </a:r>
+          </a:p>
+        </p:txBody>
+      </p:sp>
+      <p:sp>
+        <p:nvSpPr>
+          <p:cNvPr id="3" name="Content Placeholder 2"/>
+          <p:cNvSpPr>
+            <a:spLocks noGrp="1"/>
+          </p:cNvSpPr>
+          <p:nvPr>
+            <p:ph idx="1"/>
+          </p:nvPr>
+        </p:nvSpPr>
+        <p:spPr/>
+        <p:txBody>
+          <a:bodyPr/>
+          <a:lstStyle/>
+          <a:p>
+            <a:pPr lvl="0" indent="0" marL="0">
+              <a:buNone/>
+            </a:pPr>
+            <a:r>
+              <a:rPr b="1"/>
+              <a:t>We will cover:</a:t>
+            </a:r>
+            <a:r>
+              <a:rPr/>
+              <a:t> </a:t>
+            </a:r>
+            <a:r>
+              <a:rPr>
+                <a:latin typeface="Courier"/>
+              </a:rPr>
+              <a:t>facet_wrap()</a:t>
+            </a:r>
+            <a:r>
+              <a:rPr/>
+              <a:t> and </a:t>
+            </a:r>
+            <a:r>
+              <a:rPr>
+                <a:latin typeface="Courier"/>
+              </a:rPr>
+              <a:t>facet_grid()</a:t>
+            </a:r>
+            <a:r>
+              <a:rPr/>
+              <a:t> — splitting one plot into a panel per group.</a:t>
+            </a:r>
+          </a:p>
+          <a:p>
+            <a:pPr lvl="0" indent="0" marL="0">
+              <a:buNone/>
+            </a:pPr>
+            <a:r>
+              <a:rPr b="1"/>
+              <a:t>🛑 After this chunk you will do Activity Part 3.</a:t>
+            </a:r>
+          </a:p>
+        </p:txBody>
+      </p:sp>
+    </p:spTree>
+  </p:cSld>
+</p:sld>
+</file>
+
+<file path=ppt/slides/slide13.xml><?xml version="1.0" encoding="utf-8"?>
 <p:sld xmlns:a="http://schemas.openxmlformats.org/drawingml/2006/main" xmlns:r="http://schemas.openxmlformats.org/officeDocument/2006/relationships" xmlns:p="http://schemas.openxmlformats.org/presentationml/2006/main">
   <p:cSld>
     <p:spTree>
@@ -4458,7 +5502,7 @@
 </p:sld>
 </file>
 
-<file path=ppt/slides/slide13.xml><?xml version="1.0" encoding="utf-8"?>
+<file path=ppt/slides/slide14.xml><?xml version="1.0" encoding="utf-8"?>
 <p:sld xmlns:a="http://schemas.openxmlformats.org/drawingml/2006/main" xmlns:r="http://schemas.openxmlformats.org/officeDocument/2006/relationships" xmlns:p="http://schemas.openxmlformats.org/presentationml/2006/main">
   <p:cSld>
     <p:spTree>
@@ -5377,112 +6421,6 @@
 </p:sld>
 </file>
 
-<file path=ppt/slides/slide14.xml><?xml version="1.0" encoding="utf-8"?>
-<p:sld xmlns:a="http://schemas.openxmlformats.org/drawingml/2006/main" xmlns:r="http://schemas.openxmlformats.org/officeDocument/2006/relationships" xmlns:p="http://schemas.openxmlformats.org/presentationml/2006/main">
-  <p:cSld>
-    <p:spTree>
-      <p:nvGrpSpPr>
-        <p:cNvPr id="1" name=""/>
-        <p:cNvGrpSpPr/>
-        <p:nvPr/>
-      </p:nvGrpSpPr>
-      <p:grpSpPr>
-        <a:xfrm>
-          <a:off x="0" y="0"/>
-          <a:ext cx="0" cy="0"/>
-          <a:chOff x="0" y="0"/>
-          <a:chExt cx="0" cy="0"/>
-        </a:xfrm>
-      </p:grpSpPr>
-      <p:sp>
-        <p:nvSpPr>
-          <p:cNvPr id="2" name="Title 1"/>
-          <p:cNvSpPr>
-            <a:spLocks noGrp="1"/>
-          </p:cNvSpPr>
-          <p:nvPr>
-            <p:ph type="title"/>
-          </p:nvPr>
-        </p:nvSpPr>
-        <p:spPr>
-          <a:xfrm>
-            <a:off x="0" y="0"/>
-            <a:ext cx="9144000" cy="582780"/>
-          </a:xfrm>
-        </p:spPr>
-        <p:txBody>
-          <a:bodyPr/>
-          <a:lstStyle/>
-          <a:p>
-            <a:pPr lvl="0" indent="0" marL="0">
-              <a:buNone/>
-            </a:pPr>
-            <a:r>
-              <a:rPr/>
-              <a:t>→ ACTIVITY 3 Part 3 now</a:t>
-            </a:r>
-          </a:p>
-        </p:txBody>
-      </p:sp>
-      <p:sp>
-        <p:nvSpPr>
-          <p:cNvPr id="3" name="Content Placeholder 2"/>
-          <p:cNvSpPr>
-            <a:spLocks noGrp="1"/>
-          </p:cNvSpPr>
-          <p:nvPr>
-            <p:ph idx="1"/>
-          </p:nvPr>
-        </p:nvSpPr>
-        <p:spPr/>
-        <p:txBody>
-          <a:bodyPr/>
-          <a:lstStyle/>
-          <a:p>
-            <a:pPr lvl="0" indent="0" marL="0">
-              <a:buNone/>
-            </a:pPr>
-            <a:r>
-              <a:rPr b="1"/>
-              <a:t>🛑 Do Activity Part 3 now</a:t>
-            </a:r>
-          </a:p>
-          <a:p>
-            <a:pPr lvl="0" indent="0" marL="0">
-              <a:buNone/>
-            </a:pPr>
-            <a:r>
-              <a:rPr/>
-              <a:t>Build both a </a:t>
-            </a:r>
-            <a:r>
-              <a:rPr>
-                <a:latin typeface="Courier"/>
-              </a:rPr>
-              <a:t>facet_wrap()</a:t>
-            </a:r>
-            <a:r>
-              <a:rPr/>
-              <a:t> and a </a:t>
-            </a:r>
-            <a:r>
-              <a:rPr>
-                <a:latin typeface="Courier"/>
-              </a:rPr>
-              <a:t>facet_grid()</a:t>
-            </a:r>
-            <a:r>
-              <a:rPr/>
-              <a:t> version of the histogram. Predict, type, run.</a:t>
-            </a:r>
-          </a:p>
-        </p:txBody>
-      </p:sp>
-    </p:spTree>
-  </p:cSld>
-</p:sld>
-</file>
-
 <file path=ppt/slides/slide15.xml><?xml version="1.0" encoding="utf-8"?>
 <p:sld xmlns:a="http://schemas.openxmlformats.org/drawingml/2006/main" xmlns:r="http://schemas.openxmlformats.org/officeDocument/2006/relationships" xmlns:p="http://schemas.openxmlformats.org/presentationml/2006/main">
   <p:cSld>
@@ -5525,13 +6463,7 @@
             </a:pPr>
             <a:r>
               <a:rPr/>
-              <a:t>🧩 Chunk 3 of 3 · Mean ± SE with </a:t>
-            </a:r>
-            <a:r>
-              <a:rPr>
-                <a:latin typeface="Courier"/>
-              </a:rPr>
-              <a:t>stat_summary()</a:t>
+              <a:t>→ ACTIVITY 3 Part 3 now</a:t>
             </a:r>
           </a:p>
         </p:txBody>
@@ -5556,11 +6488,7 @@
             </a:pPr>
             <a:r>
               <a:rPr b="1"/>
-              <a:t>We will cover:</a:t>
-            </a:r>
-            <a:r>
-              <a:rPr/>
-              <a:t> layering a group mean and its standard error directly on top of raw data — no summary table needed.</a:t>
+              <a:t>🛑 Do Activity Part 3 now</a:t>
             </a:r>
           </a:p>
           <a:p>
@@ -5568,8 +6496,28 @@
               <a:buNone/>
             </a:pPr>
             <a:r>
-              <a:rPr b="1"/>
-              <a:t>🛑 After this chunk you will do Activity Parts 4–5.</a:t>
+              <a:rPr/>
+              <a:t>Build both a </a:t>
+            </a:r>
+            <a:r>
+              <a:rPr>
+                <a:latin typeface="Courier"/>
+              </a:rPr>
+              <a:t>facet_wrap()</a:t>
+            </a:r>
+            <a:r>
+              <a:rPr/>
+              <a:t> and a </a:t>
+            </a:r>
+            <a:r>
+              <a:rPr>
+                <a:latin typeface="Courier"/>
+              </a:rPr>
+              <a:t>facet_grid()</a:t>
+            </a:r>
+            <a:r>
+              <a:rPr/>
+              <a:t> version of the histogram. Predict, type, run.</a:t>
             </a:r>
           </a:p>
         </p:txBody>
@@ -5608,6 +6556,102 @@
         </p:nvSpPr>
         <p:spPr>
           <a:xfrm>
+            <a:off x="0" y="0"/>
+            <a:ext cx="9144000" cy="582780"/>
+          </a:xfrm>
+        </p:spPr>
+        <p:txBody>
+          <a:bodyPr/>
+          <a:lstStyle/>
+          <a:p>
+            <a:pPr lvl="0" indent="0" marL="0">
+              <a:buNone/>
+            </a:pPr>
+            <a:r>
+              <a:rPr/>
+              <a:t>🧩 Chunk 3 of 3 · Mean ± SE with </a:t>
+            </a:r>
+            <a:r>
+              <a:rPr>
+                <a:latin typeface="Courier"/>
+              </a:rPr>
+              <a:t>stat_summary()</a:t>
+            </a:r>
+          </a:p>
+        </p:txBody>
+      </p:sp>
+      <p:sp>
+        <p:nvSpPr>
+          <p:cNvPr id="3" name="Content Placeholder 2"/>
+          <p:cNvSpPr>
+            <a:spLocks noGrp="1"/>
+          </p:cNvSpPr>
+          <p:nvPr>
+            <p:ph idx="1"/>
+          </p:nvPr>
+        </p:nvSpPr>
+        <p:spPr/>
+        <p:txBody>
+          <a:bodyPr/>
+          <a:lstStyle/>
+          <a:p>
+            <a:pPr lvl="0" indent="0" marL="0">
+              <a:buNone/>
+            </a:pPr>
+            <a:r>
+              <a:rPr b="1"/>
+              <a:t>We will cover:</a:t>
+            </a:r>
+            <a:r>
+              <a:rPr/>
+              <a:t> layering a group mean and its standard error directly on top of raw data — no summary table needed.</a:t>
+            </a:r>
+          </a:p>
+          <a:p>
+            <a:pPr lvl="0" indent="0" marL="0">
+              <a:buNone/>
+            </a:pPr>
+            <a:r>
+              <a:rPr b="1"/>
+              <a:t>🛑 After this chunk you will do Activity Parts 4–5.</a:t>
+            </a:r>
+          </a:p>
+        </p:txBody>
+      </p:sp>
+    </p:spTree>
+  </p:cSld>
+</p:sld>
+</file>
+
+<file path=ppt/slides/slide17.xml><?xml version="1.0" encoding="utf-8"?>
+<p:sld xmlns:a="http://schemas.openxmlformats.org/drawingml/2006/main" xmlns:r="http://schemas.openxmlformats.org/officeDocument/2006/relationships" xmlns:p="http://schemas.openxmlformats.org/presentationml/2006/main">
+  <p:cSld>
+    <p:spTree>
+      <p:nvGrpSpPr>
+        <p:cNvPr id="1" name=""/>
+        <p:cNvGrpSpPr/>
+        <p:nvPr/>
+      </p:nvGrpSpPr>
+      <p:grpSpPr>
+        <a:xfrm>
+          <a:off x="0" y="0"/>
+          <a:ext cx="0" cy="0"/>
+          <a:chOff x="0" y="0"/>
+          <a:chExt cx="0" cy="0"/>
+        </a:xfrm>
+      </p:grpSpPr>
+      <p:sp>
+        <p:nvSpPr>
+          <p:cNvPr id="2" name="Title 1"/>
+          <p:cNvSpPr>
+            <a:spLocks noGrp="1"/>
+          </p:cNvSpPr>
+          <p:nvPr>
+            <p:ph type="title"/>
+          </p:nvPr>
+        </p:nvSpPr>
+        <p:spPr>
+          <a:xfrm>
             <a:off x="139485" y="78119"/>
             <a:ext cx="8229600" cy="607682"/>
           </a:xfrm>
@@ -5804,7 +6848,7 @@
                 </a:solidFill>
                 <a:latin typeface="Courier"/>
               </a:rPr>
-              <a:t>geom_jitter</a:t>
+              <a:t>geom_point</a:t>
             </a:r>
             <a:r>
               <a:rPr>
@@ -5822,7 +6866,25 @@
                 </a:solidFill>
                 <a:latin typeface="Courier"/>
               </a:rPr>
-              <a:t>width =</a:t>
+              <a:t>position =</a:t>
+            </a:r>
+            <a:r>
+              <a:rPr>
+                <a:solidFill>
+                  <a:srgbClr val="003B4F"/>
+                </a:solidFill>
+                <a:latin typeface="Courier"/>
+              </a:rPr>
+              <a:t> jitter_pos, </a:t>
+            </a:r>
+            <a:r>
+              <a:rPr>
+                <a:solidFill>
+                  <a:srgbClr val="657422"/>
+                </a:solidFill>
+                <a:latin typeface="Courier"/>
+              </a:rPr>
+              <a:t>alpha =</a:t>
             </a:r>
             <a:r>
               <a:rPr>
@@ -5840,7 +6902,7 @@
                 </a:solidFill>
                 <a:latin typeface="Courier"/>
               </a:rPr>
-              <a:t>0.15</a:t>
+              <a:t>0.4</a:t>
             </a:r>
             <a:r>
               <a:rPr>
@@ -5858,7 +6920,7 @@
                 </a:solidFill>
                 <a:latin typeface="Courier"/>
               </a:rPr>
-              <a:t>alpha =</a:t>
+              <a:t>size =</a:t>
             </a:r>
             <a:r>
               <a:rPr>
@@ -5876,7 +6938,98 @@
                 </a:solidFill>
                 <a:latin typeface="Courier"/>
               </a:rPr>
-              <a:t>0.4</a:t>
+              <a:t>2</a:t>
+            </a:r>
+            <a:r>
+              <a:rPr>
+                <a:solidFill>
+                  <a:srgbClr val="003B4F"/>
+                </a:solidFill>
+                <a:latin typeface="Courier"/>
+              </a:rPr>
+              <a:t>) </a:t>
+            </a:r>
+            <a:r>
+              <a:rPr>
+                <a:solidFill>
+                  <a:srgbClr val="5E5E5E"/>
+                </a:solidFill>
+                <a:latin typeface="Courier"/>
+              </a:rPr>
+              <a:t>+</a:t>
+            </a:r>
+            <a:br/>
+            <a:r>
+              <a:rPr>
+                <a:solidFill>
+                  <a:srgbClr val="003B4F"/>
+                </a:solidFill>
+                <a:latin typeface="Courier"/>
+              </a:rPr>
+              <a:t>  </a:t>
+            </a:r>
+            <a:r>
+              <a:rPr>
+                <a:solidFill>
+                  <a:srgbClr val="4758AB"/>
+                </a:solidFill>
+                <a:latin typeface="Courier"/>
+              </a:rPr>
+              <a:t>stat_summary</a:t>
+            </a:r>
+            <a:r>
+              <a:rPr>
+                <a:solidFill>
+                  <a:srgbClr val="003B4F"/>
+                </a:solidFill>
+                <a:latin typeface="Courier"/>
+              </a:rPr>
+              <a:t>(</a:t>
+            </a:r>
+            <a:r>
+              <a:rPr>
+                <a:solidFill>
+                  <a:srgbClr val="657422"/>
+                </a:solidFill>
+                <a:latin typeface="Courier"/>
+              </a:rPr>
+              <a:t>fun =</a:t>
+            </a:r>
+            <a:r>
+              <a:rPr>
+                <a:solidFill>
+                  <a:srgbClr val="003B4F"/>
+                </a:solidFill>
+                <a:latin typeface="Courier"/>
+              </a:rPr>
+              <a:t> mean, </a:t>
+            </a:r>
+            <a:r>
+              <a:rPr>
+                <a:solidFill>
+                  <a:srgbClr val="657422"/>
+                </a:solidFill>
+                <a:latin typeface="Courier"/>
+              </a:rPr>
+              <a:t>geom =</a:t>
+            </a:r>
+            <a:r>
+              <a:rPr>
+                <a:solidFill>
+                  <a:srgbClr val="003B4F"/>
+                </a:solidFill>
+                <a:latin typeface="Courier"/>
+              </a:rPr>
+              <a:t> </a:t>
+            </a:r>
+            <a:r>
+              <a:rPr>
+                <a:solidFill>
+                  <a:srgbClr val="20794D"/>
+                </a:solidFill>
+                <a:latin typeface="Courier"/>
+              </a:rPr>
+              <a:t>"point"</a:t>
             </a:r>
             <a:r>
               <a:rPr>
@@ -5912,25 +7065,52 @@
                 </a:solidFill>
                 <a:latin typeface="Courier"/>
               </a:rPr>
-              <a:t>2</a:t>
-            </a:r>
-            <a:r>
-              <a:rPr>
-                <a:solidFill>
-                  <a:srgbClr val="003B4F"/>
-                </a:solidFill>
-                <a:latin typeface="Courier"/>
-              </a:rPr>
-              <a:t>) </a:t>
-            </a:r>
-            <a:r>
-              <a:rPr>
-                <a:solidFill>
-                  <a:srgbClr val="5E5E5E"/>
-                </a:solidFill>
-                <a:latin typeface="Courier"/>
-              </a:rPr>
-              <a:t>+</a:t>
+              <a:t>4</a:t>
+            </a:r>
+            <a:r>
+              <a:rPr>
+                <a:solidFill>
+                  <a:srgbClr val="003B4F"/>
+                </a:solidFill>
+                <a:latin typeface="Courier"/>
+              </a:rPr>
+              <a:t>, </a:t>
+            </a:r>
+            <a:r>
+              <a:rPr>
+                <a:solidFill>
+                  <a:srgbClr val="657422"/>
+                </a:solidFill>
+                <a:latin typeface="Courier"/>
+              </a:rPr>
+              <a:t>color =</a:t>
+            </a:r>
+            <a:r>
+              <a:rPr>
+                <a:solidFill>
+                  <a:srgbClr val="003B4F"/>
+                </a:solidFill>
+                <a:latin typeface="Courier"/>
+              </a:rPr>
+              <a:t> </a:t>
+            </a:r>
+            <a:r>
+              <a:rPr>
+                <a:solidFill>
+                  <a:srgbClr val="20794D"/>
+                </a:solidFill>
+                <a:latin typeface="Courier"/>
+              </a:rPr>
+              <a:t>"black"</a:t>
+            </a:r>
+            <a:r>
+              <a:rPr>
+                <a:solidFill>
+                  <a:srgbClr val="003B4F"/>
+                </a:solidFill>
+                <a:latin typeface="Courier"/>
+              </a:rPr>
+              <a:t>,</a:t>
             </a:r>
             <a:br/>
             <a:r>
@@ -5940,25 +7120,7 @@
                 </a:solidFill>
                 <a:latin typeface="Courier"/>
               </a:rPr>
-              <a:t>  </a:t>
-            </a:r>
-            <a:r>
-              <a:rPr>
-                <a:solidFill>
-                  <a:srgbClr val="4758AB"/>
-                </a:solidFill>
-                <a:latin typeface="Courier"/>
-              </a:rPr>
-              <a:t>stat_summary</a:t>
-            </a:r>
-            <a:r>
-              <a:rPr>
-                <a:solidFill>
-                  <a:srgbClr val="003B4F"/>
-                </a:solidFill>
-                <a:latin typeface="Courier"/>
-              </a:rPr>
-              <a:t>(</a:t>
+              <a:t>               </a:t>
             </a:r>
             <a:r>
               <a:rPr>
@@ -5967,124 +7129,16 @@
                 </a:solidFill>
                 <a:latin typeface="Courier"/>
               </a:rPr>
-              <a:t>fun =</a:t>
-            </a:r>
-            <a:r>
-              <a:rPr>
-                <a:solidFill>
-                  <a:srgbClr val="003B4F"/>
-                </a:solidFill>
-                <a:latin typeface="Courier"/>
-              </a:rPr>
-              <a:t> mean, </a:t>
-            </a:r>
-            <a:r>
-              <a:rPr>
-                <a:solidFill>
-                  <a:srgbClr val="657422"/>
-                </a:solidFill>
-                <a:latin typeface="Courier"/>
-              </a:rPr>
-              <a:t>geom =</a:t>
-            </a:r>
-            <a:r>
-              <a:rPr>
-                <a:solidFill>
-                  <a:srgbClr val="003B4F"/>
-                </a:solidFill>
-                <a:latin typeface="Courier"/>
-              </a:rPr>
-              <a:t> </a:t>
-            </a:r>
-            <a:r>
-              <a:rPr>
-                <a:solidFill>
-                  <a:srgbClr val="20794D"/>
-                </a:solidFill>
-                <a:latin typeface="Courier"/>
-              </a:rPr>
-              <a:t>"point"</a:t>
-            </a:r>
-            <a:r>
-              <a:rPr>
-                <a:solidFill>
-                  <a:srgbClr val="003B4F"/>
-                </a:solidFill>
-                <a:latin typeface="Courier"/>
-              </a:rPr>
-              <a:t>, </a:t>
-            </a:r>
-            <a:r>
-              <a:rPr>
-                <a:solidFill>
-                  <a:srgbClr val="657422"/>
-                </a:solidFill>
-                <a:latin typeface="Courier"/>
-              </a:rPr>
-              <a:t>size =</a:t>
-            </a:r>
-            <a:r>
-              <a:rPr>
-                <a:solidFill>
-                  <a:srgbClr val="003B4F"/>
-                </a:solidFill>
-                <a:latin typeface="Courier"/>
-              </a:rPr>
-              <a:t> </a:t>
-            </a:r>
-            <a:r>
-              <a:rPr>
-                <a:solidFill>
-                  <a:srgbClr val="AD0000"/>
-                </a:solidFill>
-                <a:latin typeface="Courier"/>
-              </a:rPr>
-              <a:t>4</a:t>
-            </a:r>
-            <a:r>
-              <a:rPr>
-                <a:solidFill>
-                  <a:srgbClr val="003B4F"/>
-                </a:solidFill>
-                <a:latin typeface="Courier"/>
-              </a:rPr>
-              <a:t>, </a:t>
-            </a:r>
-            <a:r>
-              <a:rPr>
-                <a:solidFill>
-                  <a:srgbClr val="657422"/>
-                </a:solidFill>
-                <a:latin typeface="Courier"/>
-              </a:rPr>
-              <a:t>color =</a:t>
-            </a:r>
-            <a:r>
-              <a:rPr>
-                <a:solidFill>
-                  <a:srgbClr val="003B4F"/>
-                </a:solidFill>
-                <a:latin typeface="Courier"/>
-              </a:rPr>
-              <a:t> </a:t>
-            </a:r>
-            <a:r>
-              <a:rPr>
-                <a:solidFill>
-                  <a:srgbClr val="20794D"/>
-                </a:solidFill>
-                <a:latin typeface="Courier"/>
-              </a:rPr>
-              <a:t>"black"</a:t>
-            </a:r>
-            <a:r>
-              <a:rPr>
-                <a:solidFill>
-                  <a:srgbClr val="003B4F"/>
-                </a:solidFill>
-                <a:latin typeface="Courier"/>
-              </a:rPr>
-              <a:t>) </a:t>
+              <a:t>position =</a:t>
+            </a:r>
+            <a:r>
+              <a:rPr>
+                <a:solidFill>
+                  <a:srgbClr val="003B4F"/>
+                </a:solidFill>
+                <a:latin typeface="Courier"/>
+              </a:rPr>
+              <a:t> dodge_pos) </a:t>
             </a:r>
             <a:r>
               <a:rPr>
@@ -6635,17 +7689,17 @@
             <a:pPr lvl="0"/>
             <a:r>
               <a:rPr/>
-              <a:t>Put </a:t>
-            </a:r>
-            <a:r>
-              <a:rPr>
-                <a:latin typeface="Courier"/>
-              </a:rPr>
-              <a:t>geom_jitter()</a:t>
-            </a:r>
-            <a:r>
-              <a:rPr/>
-              <a:t> </a:t>
+              <a:t>Put the raw </a:t>
+            </a:r>
+            <a:r>
+              <a:rPr>
+                <a:latin typeface="Courier"/>
+              </a:rPr>
+              <a:t>geom_point()</a:t>
+            </a:r>
+            <a:r>
+              <a:rPr/>
+              <a:t> layer </a:t>
             </a:r>
             <a:r>
               <a:rPr b="1"/>
@@ -6673,7 +7727,7 @@
 </p:sld>
 </file>
 
-<file path=ppt/slides/slide17.xml><?xml version="1.0" encoding="utf-8"?>
+<file path=ppt/slides/slide18.xml><?xml version="1.0" encoding="utf-8"?>
 <p:sld xmlns:a="http://schemas.openxmlformats.org/drawingml/2006/main" xmlns:r="http://schemas.openxmlformats.org/officeDocument/2006/relationships" xmlns:p="http://schemas.openxmlformats.org/presentationml/2006/main">
   <p:cSld>
     <p:spTree>
@@ -6779,7 +7833,7 @@
 </p:sld>
 </file>
 
-<file path=ppt/slides/slide18.xml><?xml version="1.0" encoding="utf-8"?>
+<file path=ppt/slides/slide19.xml><?xml version="1.0" encoding="utf-8"?>
 <p:sld xmlns:a="http://schemas.openxmlformats.org/drawingml/2006/main" xmlns:r="http://schemas.openxmlformats.org/officeDocument/2006/relationships" xmlns:p="http://schemas.openxmlformats.org/presentationml/2006/main">
   <p:cSld>
     <p:spTree>
@@ -6968,7 +8022,7 @@
                 </a:solidFill>
                 <a:latin typeface="Courier"/>
               </a:rPr>
-              <a:t>geom_jitter</a:t>
+              <a:t>geom_point</a:t>
             </a:r>
             <a:r>
               <a:rPr>
@@ -6986,6 +8040,372 @@
                 </a:solidFill>
                 <a:latin typeface="Courier"/>
               </a:rPr>
+              <a:t>position =</a:t>
+            </a:r>
+            <a:r>
+              <a:rPr>
+                <a:solidFill>
+                  <a:srgbClr val="003B4F"/>
+                </a:solidFill>
+                <a:latin typeface="Courier"/>
+              </a:rPr>
+              <a:t> jitter_pos, </a:t>
+            </a:r>
+            <a:r>
+              <a:rPr>
+                <a:solidFill>
+                  <a:srgbClr val="657422"/>
+                </a:solidFill>
+                <a:latin typeface="Courier"/>
+              </a:rPr>
+              <a:t>alpha =</a:t>
+            </a:r>
+            <a:r>
+              <a:rPr>
+                <a:solidFill>
+                  <a:srgbClr val="003B4F"/>
+                </a:solidFill>
+                <a:latin typeface="Courier"/>
+              </a:rPr>
+              <a:t> </a:t>
+            </a:r>
+            <a:r>
+              <a:rPr>
+                <a:solidFill>
+                  <a:srgbClr val="AD0000"/>
+                </a:solidFill>
+                <a:latin typeface="Courier"/>
+              </a:rPr>
+              <a:t>0.35</a:t>
+            </a:r>
+            <a:r>
+              <a:rPr>
+                <a:solidFill>
+                  <a:srgbClr val="003B4F"/>
+                </a:solidFill>
+                <a:latin typeface="Courier"/>
+              </a:rPr>
+              <a:t>, </a:t>
+            </a:r>
+            <a:r>
+              <a:rPr>
+                <a:solidFill>
+                  <a:srgbClr val="657422"/>
+                </a:solidFill>
+                <a:latin typeface="Courier"/>
+              </a:rPr>
+              <a:t>size =</a:t>
+            </a:r>
+            <a:r>
+              <a:rPr>
+                <a:solidFill>
+                  <a:srgbClr val="003B4F"/>
+                </a:solidFill>
+                <a:latin typeface="Courier"/>
+              </a:rPr>
+              <a:t> </a:t>
+            </a:r>
+            <a:r>
+              <a:rPr>
+                <a:solidFill>
+                  <a:srgbClr val="AD0000"/>
+                </a:solidFill>
+                <a:latin typeface="Courier"/>
+              </a:rPr>
+              <a:t>2</a:t>
+            </a:r>
+            <a:r>
+              <a:rPr>
+                <a:solidFill>
+                  <a:srgbClr val="003B4F"/>
+                </a:solidFill>
+                <a:latin typeface="Courier"/>
+              </a:rPr>
+              <a:t>) </a:t>
+            </a:r>
+            <a:r>
+              <a:rPr>
+                <a:solidFill>
+                  <a:srgbClr val="5E5E5E"/>
+                </a:solidFill>
+                <a:latin typeface="Courier"/>
+              </a:rPr>
+              <a:t>+</a:t>
+            </a:r>
+            <a:br/>
+            <a:r>
+              <a:rPr>
+                <a:solidFill>
+                  <a:srgbClr val="003B4F"/>
+                </a:solidFill>
+                <a:latin typeface="Courier"/>
+              </a:rPr>
+              <a:t>  </a:t>
+            </a:r>
+            <a:r>
+              <a:rPr>
+                <a:solidFill>
+                  <a:srgbClr val="4758AB"/>
+                </a:solidFill>
+                <a:latin typeface="Courier"/>
+              </a:rPr>
+              <a:t>stat_summary</a:t>
+            </a:r>
+            <a:r>
+              <a:rPr>
+                <a:solidFill>
+                  <a:srgbClr val="003B4F"/>
+                </a:solidFill>
+                <a:latin typeface="Courier"/>
+              </a:rPr>
+              <a:t>(</a:t>
+            </a:r>
+            <a:r>
+              <a:rPr>
+                <a:solidFill>
+                  <a:srgbClr val="657422"/>
+                </a:solidFill>
+                <a:latin typeface="Courier"/>
+              </a:rPr>
+              <a:t>fun =</a:t>
+            </a:r>
+            <a:r>
+              <a:rPr>
+                <a:solidFill>
+                  <a:srgbClr val="003B4F"/>
+                </a:solidFill>
+                <a:latin typeface="Courier"/>
+              </a:rPr>
+              <a:t> mean, </a:t>
+            </a:r>
+            <a:r>
+              <a:rPr>
+                <a:solidFill>
+                  <a:srgbClr val="657422"/>
+                </a:solidFill>
+                <a:latin typeface="Courier"/>
+              </a:rPr>
+              <a:t>geom =</a:t>
+            </a:r>
+            <a:r>
+              <a:rPr>
+                <a:solidFill>
+                  <a:srgbClr val="003B4F"/>
+                </a:solidFill>
+                <a:latin typeface="Courier"/>
+              </a:rPr>
+              <a:t> </a:t>
+            </a:r>
+            <a:r>
+              <a:rPr>
+                <a:solidFill>
+                  <a:srgbClr val="20794D"/>
+                </a:solidFill>
+                <a:latin typeface="Courier"/>
+              </a:rPr>
+              <a:t>"point"</a:t>
+            </a:r>
+            <a:r>
+              <a:rPr>
+                <a:solidFill>
+                  <a:srgbClr val="003B4F"/>
+                </a:solidFill>
+                <a:latin typeface="Courier"/>
+              </a:rPr>
+              <a:t>, </a:t>
+            </a:r>
+            <a:r>
+              <a:rPr>
+                <a:solidFill>
+                  <a:srgbClr val="657422"/>
+                </a:solidFill>
+                <a:latin typeface="Courier"/>
+              </a:rPr>
+              <a:t>size =</a:t>
+            </a:r>
+            <a:r>
+              <a:rPr>
+                <a:solidFill>
+                  <a:srgbClr val="003B4F"/>
+                </a:solidFill>
+                <a:latin typeface="Courier"/>
+              </a:rPr>
+              <a:t> </a:t>
+            </a:r>
+            <a:r>
+              <a:rPr>
+                <a:solidFill>
+                  <a:srgbClr val="AD0000"/>
+                </a:solidFill>
+                <a:latin typeface="Courier"/>
+              </a:rPr>
+              <a:t>4</a:t>
+            </a:r>
+            <a:r>
+              <a:rPr>
+                <a:solidFill>
+                  <a:srgbClr val="003B4F"/>
+                </a:solidFill>
+                <a:latin typeface="Courier"/>
+              </a:rPr>
+              <a:t>,</a:t>
+            </a:r>
+            <a:br/>
+            <a:r>
+              <a:rPr>
+                <a:solidFill>
+                  <a:srgbClr val="003B4F"/>
+                </a:solidFill>
+                <a:latin typeface="Courier"/>
+              </a:rPr>
+              <a:t>               </a:t>
+            </a:r>
+            <a:r>
+              <a:rPr>
+                <a:solidFill>
+                  <a:srgbClr val="657422"/>
+                </a:solidFill>
+                <a:latin typeface="Courier"/>
+              </a:rPr>
+              <a:t>position =</a:t>
+            </a:r>
+            <a:r>
+              <a:rPr>
+                <a:solidFill>
+                  <a:srgbClr val="003B4F"/>
+                </a:solidFill>
+                <a:latin typeface="Courier"/>
+              </a:rPr>
+              <a:t> dodge_pos) </a:t>
+            </a:r>
+            <a:r>
+              <a:rPr>
+                <a:solidFill>
+                  <a:srgbClr val="5E5E5E"/>
+                </a:solidFill>
+                <a:latin typeface="Courier"/>
+              </a:rPr>
+              <a:t>+</a:t>
+            </a:r>
+            <a:br/>
+            <a:r>
+              <a:rPr>
+                <a:solidFill>
+                  <a:srgbClr val="003B4F"/>
+                </a:solidFill>
+                <a:latin typeface="Courier"/>
+              </a:rPr>
+              <a:t>  </a:t>
+            </a:r>
+            <a:r>
+              <a:rPr>
+                <a:solidFill>
+                  <a:srgbClr val="4758AB"/>
+                </a:solidFill>
+                <a:latin typeface="Courier"/>
+              </a:rPr>
+              <a:t>stat_summary</a:t>
+            </a:r>
+            <a:r>
+              <a:rPr>
+                <a:solidFill>
+                  <a:srgbClr val="003B4F"/>
+                </a:solidFill>
+                <a:latin typeface="Courier"/>
+              </a:rPr>
+              <a:t>(</a:t>
+            </a:r>
+            <a:br/>
+            <a:r>
+              <a:rPr>
+                <a:solidFill>
+                  <a:srgbClr val="003B4F"/>
+                </a:solidFill>
+                <a:latin typeface="Courier"/>
+              </a:rPr>
+              <a:t>    </a:t>
+            </a:r>
+            <a:r>
+              <a:rPr>
+                <a:solidFill>
+                  <a:srgbClr val="657422"/>
+                </a:solidFill>
+                <a:latin typeface="Courier"/>
+              </a:rPr>
+              <a:t>fun.data =</a:t>
+            </a:r>
+            <a:r>
+              <a:rPr>
+                <a:solidFill>
+                  <a:srgbClr val="003B4F"/>
+                </a:solidFill>
+                <a:latin typeface="Courier"/>
+              </a:rPr>
+              <a:t> mean_se,</a:t>
+            </a:r>
+            <a:br/>
+            <a:r>
+              <a:rPr>
+                <a:solidFill>
+                  <a:srgbClr val="003B4F"/>
+                </a:solidFill>
+                <a:latin typeface="Courier"/>
+              </a:rPr>
+              <a:t>    </a:t>
+            </a:r>
+            <a:r>
+              <a:rPr>
+                <a:solidFill>
+                  <a:srgbClr val="657422"/>
+                </a:solidFill>
+                <a:latin typeface="Courier"/>
+              </a:rPr>
+              <a:t>geom =</a:t>
+            </a:r>
+            <a:r>
+              <a:rPr>
+                <a:solidFill>
+                  <a:srgbClr val="003B4F"/>
+                </a:solidFill>
+                <a:latin typeface="Courier"/>
+              </a:rPr>
+              <a:t> </a:t>
+            </a:r>
+            <a:r>
+              <a:rPr>
+                <a:solidFill>
+                  <a:srgbClr val="20794D"/>
+                </a:solidFill>
+                <a:latin typeface="Courier"/>
+              </a:rPr>
+              <a:t>"errorbar"</a:t>
+            </a:r>
+            <a:r>
+              <a:rPr>
+                <a:solidFill>
+                  <a:srgbClr val="003B4F"/>
+                </a:solidFill>
+                <a:latin typeface="Courier"/>
+              </a:rPr>
+              <a:t>,</a:t>
+            </a:r>
+            <a:br/>
+            <a:r>
+              <a:rPr>
+                <a:solidFill>
+                  <a:srgbClr val="003B4F"/>
+                </a:solidFill>
+                <a:latin typeface="Courier"/>
+              </a:rPr>
+              <a:t>    </a:t>
+            </a:r>
+            <a:r>
+              <a:rPr>
+                <a:solidFill>
+                  <a:srgbClr val="657422"/>
+                </a:solidFill>
+                <a:latin typeface="Courier"/>
+              </a:rPr>
               <a:t>width =</a:t>
             </a:r>
             <a:r>
@@ -7013,7 +8433,17 @@
                 </a:solidFill>
                 <a:latin typeface="Courier"/>
               </a:rPr>
-              <a:t>, </a:t>
+              <a:t>,</a:t>
+            </a:r>
+            <a:br/>
+            <a:r>
+              <a:rPr>
+                <a:solidFill>
+                  <a:srgbClr val="003B4F"/>
+                </a:solidFill>
+                <a:latin typeface="Courier"/>
+              </a:rPr>
+              <a:t>    </a:t>
             </a:r>
             <a:r>
               <a:rPr>
@@ -7022,7 +8452,7 @@
                 </a:solidFill>
                 <a:latin typeface="Courier"/>
               </a:rPr>
-              <a:t>alpha =</a:t>
+              <a:t>linewidth =</a:t>
             </a:r>
             <a:r>
               <a:rPr>
@@ -7040,16 +8470,26 @@
                 </a:solidFill>
                 <a:latin typeface="Courier"/>
               </a:rPr>
-              <a:t>0.35</a:t>
-            </a:r>
-            <a:r>
-              <a:rPr>
-                <a:solidFill>
-                  <a:srgbClr val="003B4F"/>
-                </a:solidFill>
-                <a:latin typeface="Courier"/>
-              </a:rPr>
-              <a:t>, </a:t>
+              <a:t>0.9</a:t>
+            </a:r>
+            <a:r>
+              <a:rPr>
+                <a:solidFill>
+                  <a:srgbClr val="003B4F"/>
+                </a:solidFill>
+                <a:latin typeface="Courier"/>
+              </a:rPr>
+              <a:t>,</a:t>
+            </a:r>
+            <a:br/>
+            <a:r>
+              <a:rPr>
+                <a:solidFill>
+                  <a:srgbClr val="003B4F"/>
+                </a:solidFill>
+                <a:latin typeface="Courier"/>
+              </a:rPr>
+              <a:t>    </a:t>
             </a:r>
             <a:r>
               <a:rPr>
@@ -7058,355 +8498,16 @@
                 </a:solidFill>
                 <a:latin typeface="Courier"/>
               </a:rPr>
-              <a:t>size =</a:t>
-            </a:r>
-            <a:r>
-              <a:rPr>
-                <a:solidFill>
-                  <a:srgbClr val="003B4F"/>
-                </a:solidFill>
-                <a:latin typeface="Courier"/>
-              </a:rPr>
-              <a:t> </a:t>
-            </a:r>
-            <a:r>
-              <a:rPr>
-                <a:solidFill>
-                  <a:srgbClr val="AD0000"/>
-                </a:solidFill>
-                <a:latin typeface="Courier"/>
-              </a:rPr>
-              <a:t>2</a:t>
-            </a:r>
-            <a:r>
-              <a:rPr>
-                <a:solidFill>
-                  <a:srgbClr val="003B4F"/>
-                </a:solidFill>
-                <a:latin typeface="Courier"/>
-              </a:rPr>
-              <a:t>) </a:t>
-            </a:r>
-            <a:r>
-              <a:rPr>
-                <a:solidFill>
-                  <a:srgbClr val="5E5E5E"/>
-                </a:solidFill>
-                <a:latin typeface="Courier"/>
-              </a:rPr>
-              <a:t>+</a:t>
-            </a:r>
-            <a:br/>
-            <a:r>
-              <a:rPr>
-                <a:solidFill>
-                  <a:srgbClr val="003B4F"/>
-                </a:solidFill>
-                <a:latin typeface="Courier"/>
-              </a:rPr>
-              <a:t>  </a:t>
-            </a:r>
-            <a:r>
-              <a:rPr>
-                <a:solidFill>
-                  <a:srgbClr val="4758AB"/>
-                </a:solidFill>
-                <a:latin typeface="Courier"/>
-              </a:rPr>
-              <a:t>stat_summary</a:t>
-            </a:r>
-            <a:r>
-              <a:rPr>
-                <a:solidFill>
-                  <a:srgbClr val="003B4F"/>
-                </a:solidFill>
-                <a:latin typeface="Courier"/>
-              </a:rPr>
-              <a:t>(</a:t>
-            </a:r>
-            <a:r>
-              <a:rPr>
-                <a:solidFill>
-                  <a:srgbClr val="657422"/>
-                </a:solidFill>
-                <a:latin typeface="Courier"/>
-              </a:rPr>
-              <a:t>fun =</a:t>
-            </a:r>
-            <a:r>
-              <a:rPr>
-                <a:solidFill>
-                  <a:srgbClr val="003B4F"/>
-                </a:solidFill>
-                <a:latin typeface="Courier"/>
-              </a:rPr>
-              <a:t> mean, </a:t>
-            </a:r>
-            <a:r>
-              <a:rPr>
-                <a:solidFill>
-                  <a:srgbClr val="657422"/>
-                </a:solidFill>
-                <a:latin typeface="Courier"/>
-              </a:rPr>
-              <a:t>geom =</a:t>
-            </a:r>
-            <a:r>
-              <a:rPr>
-                <a:solidFill>
-                  <a:srgbClr val="003B4F"/>
-                </a:solidFill>
-                <a:latin typeface="Courier"/>
-              </a:rPr>
-              <a:t> </a:t>
-            </a:r>
-            <a:r>
-              <a:rPr>
-                <a:solidFill>
-                  <a:srgbClr val="20794D"/>
-                </a:solidFill>
-                <a:latin typeface="Courier"/>
-              </a:rPr>
-              <a:t>"point"</a:t>
-            </a:r>
-            <a:r>
-              <a:rPr>
-                <a:solidFill>
-                  <a:srgbClr val="003B4F"/>
-                </a:solidFill>
-                <a:latin typeface="Courier"/>
-              </a:rPr>
-              <a:t>, </a:t>
-            </a:r>
-            <a:r>
-              <a:rPr>
-                <a:solidFill>
-                  <a:srgbClr val="657422"/>
-                </a:solidFill>
-                <a:latin typeface="Courier"/>
-              </a:rPr>
-              <a:t>size =</a:t>
-            </a:r>
-            <a:r>
-              <a:rPr>
-                <a:solidFill>
-                  <a:srgbClr val="003B4F"/>
-                </a:solidFill>
-                <a:latin typeface="Courier"/>
-              </a:rPr>
-              <a:t> </a:t>
-            </a:r>
-            <a:r>
-              <a:rPr>
-                <a:solidFill>
-                  <a:srgbClr val="AD0000"/>
-                </a:solidFill>
-                <a:latin typeface="Courier"/>
-              </a:rPr>
-              <a:t>4</a:t>
-            </a:r>
-            <a:r>
-              <a:rPr>
-                <a:solidFill>
-                  <a:srgbClr val="003B4F"/>
-                </a:solidFill>
-                <a:latin typeface="Courier"/>
-              </a:rPr>
-              <a:t>) </a:t>
-            </a:r>
-            <a:r>
-              <a:rPr>
-                <a:solidFill>
-                  <a:srgbClr val="5E5E5E"/>
-                </a:solidFill>
-                <a:latin typeface="Courier"/>
-              </a:rPr>
-              <a:t>+</a:t>
-            </a:r>
-            <a:br/>
-            <a:r>
-              <a:rPr>
-                <a:solidFill>
-                  <a:srgbClr val="003B4F"/>
-                </a:solidFill>
-                <a:latin typeface="Courier"/>
-              </a:rPr>
-              <a:t>  </a:t>
-            </a:r>
-            <a:r>
-              <a:rPr>
-                <a:solidFill>
-                  <a:srgbClr val="4758AB"/>
-                </a:solidFill>
-                <a:latin typeface="Courier"/>
-              </a:rPr>
-              <a:t>stat_summary</a:t>
-            </a:r>
-            <a:r>
-              <a:rPr>
-                <a:solidFill>
-                  <a:srgbClr val="003B4F"/>
-                </a:solidFill>
-                <a:latin typeface="Courier"/>
-              </a:rPr>
-              <a:t>(</a:t>
-            </a:r>
-            <a:br/>
-            <a:r>
-              <a:rPr>
-                <a:solidFill>
-                  <a:srgbClr val="003B4F"/>
-                </a:solidFill>
-                <a:latin typeface="Courier"/>
-              </a:rPr>
-              <a:t>    </a:t>
-            </a:r>
-            <a:r>
-              <a:rPr>
-                <a:solidFill>
-                  <a:srgbClr val="657422"/>
-                </a:solidFill>
-                <a:latin typeface="Courier"/>
-              </a:rPr>
-              <a:t>fun.data =</a:t>
-            </a:r>
-            <a:r>
-              <a:rPr>
-                <a:solidFill>
-                  <a:srgbClr val="003B4F"/>
-                </a:solidFill>
-                <a:latin typeface="Courier"/>
-              </a:rPr>
-              <a:t> mean_se,</a:t>
-            </a:r>
-            <a:br/>
-            <a:r>
-              <a:rPr>
-                <a:solidFill>
-                  <a:srgbClr val="003B4F"/>
-                </a:solidFill>
-                <a:latin typeface="Courier"/>
-              </a:rPr>
-              <a:t>    </a:t>
-            </a:r>
-            <a:r>
-              <a:rPr>
-                <a:solidFill>
-                  <a:srgbClr val="657422"/>
-                </a:solidFill>
-                <a:latin typeface="Courier"/>
-              </a:rPr>
-              <a:t>geom =</a:t>
-            </a:r>
-            <a:r>
-              <a:rPr>
-                <a:solidFill>
-                  <a:srgbClr val="003B4F"/>
-                </a:solidFill>
-                <a:latin typeface="Courier"/>
-              </a:rPr>
-              <a:t> </a:t>
-            </a:r>
-            <a:r>
-              <a:rPr>
-                <a:solidFill>
-                  <a:srgbClr val="20794D"/>
-                </a:solidFill>
-                <a:latin typeface="Courier"/>
-              </a:rPr>
-              <a:t>"errorbar"</a:t>
-            </a:r>
-            <a:r>
-              <a:rPr>
-                <a:solidFill>
-                  <a:srgbClr val="003B4F"/>
-                </a:solidFill>
-                <a:latin typeface="Courier"/>
-              </a:rPr>
-              <a:t>,</a:t>
-            </a:r>
-            <a:br/>
-            <a:r>
-              <a:rPr>
-                <a:solidFill>
-                  <a:srgbClr val="003B4F"/>
-                </a:solidFill>
-                <a:latin typeface="Courier"/>
-              </a:rPr>
-              <a:t>    </a:t>
-            </a:r>
-            <a:r>
-              <a:rPr>
-                <a:solidFill>
-                  <a:srgbClr val="657422"/>
-                </a:solidFill>
-                <a:latin typeface="Courier"/>
-              </a:rPr>
-              <a:t>width =</a:t>
-            </a:r>
-            <a:r>
-              <a:rPr>
-                <a:solidFill>
-                  <a:srgbClr val="003B4F"/>
-                </a:solidFill>
-                <a:latin typeface="Courier"/>
-              </a:rPr>
-              <a:t> </a:t>
-            </a:r>
-            <a:r>
-              <a:rPr>
-                <a:solidFill>
-                  <a:srgbClr val="AD0000"/>
-                </a:solidFill>
-                <a:latin typeface="Courier"/>
-              </a:rPr>
-              <a:t>0.15</a:t>
-            </a:r>
-            <a:r>
-              <a:rPr>
-                <a:solidFill>
-                  <a:srgbClr val="003B4F"/>
-                </a:solidFill>
-                <a:latin typeface="Courier"/>
-              </a:rPr>
-              <a:t>,</a:t>
-            </a:r>
-            <a:br/>
-            <a:r>
-              <a:rPr>
-                <a:solidFill>
-                  <a:srgbClr val="003B4F"/>
-                </a:solidFill>
-                <a:latin typeface="Courier"/>
-              </a:rPr>
-              <a:t>    </a:t>
-            </a:r>
-            <a:r>
-              <a:rPr>
-                <a:solidFill>
-                  <a:srgbClr val="657422"/>
-                </a:solidFill>
-                <a:latin typeface="Courier"/>
-              </a:rPr>
-              <a:t>linewidth =</a:t>
-            </a:r>
-            <a:r>
-              <a:rPr>
-                <a:solidFill>
-                  <a:srgbClr val="003B4F"/>
-                </a:solidFill>
-                <a:latin typeface="Courier"/>
-              </a:rPr>
-              <a:t> </a:t>
-            </a:r>
-            <a:r>
-              <a:rPr>
-                <a:solidFill>
-                  <a:srgbClr val="AD0000"/>
-                </a:solidFill>
-                <a:latin typeface="Courier"/>
-              </a:rPr>
-              <a:t>0.9</a:t>
+              <a:t>position =</a:t>
+            </a:r>
+            <a:r>
+              <a:rPr>
+                <a:solidFill>
+                  <a:srgbClr val="003B4F"/>
+                </a:solidFill>
+                <a:latin typeface="Courier"/>
+              </a:rPr>
+              <a:t> dodge_pos</a:t>
             </a:r>
             <a:br/>
             <a:r>
@@ -8110,6 +9211,61 @@
             </a:r>
           </a:p>
           <a:p>
+            <a:pPr lvl="0"/>
+            <a:r>
+              <a:rPr/>
+              <a:t>The mean point and the error bar share </a:t>
+            </a:r>
+            <a:r>
+              <a:rPr b="1"/>
+              <a:t>one</a:t>
+            </a:r>
+            <a:r>
+              <a:rPr/>
+              <a:t> </a:t>
+            </a:r>
+            <a:r>
+              <a:rPr>
+                <a:latin typeface="Courier"/>
+              </a:rPr>
+              <a:t>position = dodge_pos</a:t>
+            </a:r>
+            <a:r>
+              <a:rPr/>
+              <a:t>, so they always line up. With one group per x it has no visible effect yet — add </a:t>
+            </a:r>
+            <a:r>
+              <a:rPr>
+                <a:latin typeface="Courier"/>
+              </a:rPr>
+              <a:t>color = sex</a:t>
+            </a:r>
+            <a:r>
+              <a:rPr/>
+              <a:t> and the same </a:t>
+            </a:r>
+            <a:r>
+              <a:rPr>
+                <a:latin typeface="Courier"/>
+              </a:rPr>
+              <a:t>dodge_pos</a:t>
+            </a:r>
+            <a:r>
+              <a:rPr/>
+              <a:t> fans the two groups apart, and you’d hang a </a:t>
+            </a:r>
+            <a:r>
+              <a:rPr>
+                <a:latin typeface="Courier"/>
+              </a:rPr>
+              <a:t>geom_line(position = dodge_pos)</a:t>
+            </a:r>
+            <a:r>
+              <a:rPr/>
+              <a:t> off it to connect them</a:t>
+            </a:r>
+          </a:p>
+          <a:p>
             <a:pPr lvl="0" indent="0" marL="0">
               <a:buNone/>
             </a:pPr>
@@ -8120,102 +9276,6 @@
             <a:r>
               <a:rPr i="1"/>
               <a:t>Describing Data</a:t>
-            </a:r>
-          </a:p>
-        </p:txBody>
-      </p:sp>
-    </p:spTree>
-  </p:cSld>
-</p:sld>
-</file>
-
-<file path=ppt/slides/slide19.xml><?xml version="1.0" encoding="utf-8"?>
-<p:sld xmlns:a="http://schemas.openxmlformats.org/drawingml/2006/main" xmlns:r="http://schemas.openxmlformats.org/officeDocument/2006/relationships" xmlns:p="http://schemas.openxmlformats.org/presentationml/2006/main">
-  <p:cSld>
-    <p:spTree>
-      <p:nvGrpSpPr>
-        <p:cNvPr id="1" name=""/>
-        <p:cNvGrpSpPr/>
-        <p:nvPr/>
-      </p:nvGrpSpPr>
-      <p:grpSpPr>
-        <a:xfrm>
-          <a:off x="0" y="0"/>
-          <a:ext cx="0" cy="0"/>
-          <a:chOff x="0" y="0"/>
-          <a:chExt cx="0" cy="0"/>
-        </a:xfrm>
-      </p:grpSpPr>
-      <p:sp>
-        <p:nvSpPr>
-          <p:cNvPr id="2" name="Title 1"/>
-          <p:cNvSpPr>
-            <a:spLocks noGrp="1"/>
-          </p:cNvSpPr>
-          <p:nvPr>
-            <p:ph type="title"/>
-          </p:nvPr>
-        </p:nvSpPr>
-        <p:spPr>
-          <a:xfrm>
-            <a:off x="0" y="0"/>
-            <a:ext cx="9144000" cy="582780"/>
-          </a:xfrm>
-        </p:spPr>
-        <p:txBody>
-          <a:bodyPr/>
-          <a:lstStyle/>
-          <a:p>
-            <a:pPr lvl="0" indent="0" marL="0">
-              <a:buNone/>
-            </a:pPr>
-            <a:r>
-              <a:rPr/>
-              <a:t>→ ACTIVITY 3 Parts 4–5 now</a:t>
-            </a:r>
-          </a:p>
-        </p:txBody>
-      </p:sp>
-      <p:sp>
-        <p:nvSpPr>
-          <p:cNvPr id="3" name="Content Placeholder 2"/>
-          <p:cNvSpPr>
-            <a:spLocks noGrp="1"/>
-          </p:cNvSpPr>
-          <p:nvPr>
-            <p:ph idx="1"/>
-          </p:nvPr>
-        </p:nvSpPr>
-        <p:spPr/>
-        <p:txBody>
-          <a:bodyPr/>
-          <a:lstStyle/>
-          <a:p>
-            <a:pPr lvl="0" indent="0" marL="0">
-              <a:buNone/>
-            </a:pPr>
-            <a:r>
-              <a:rPr b="1"/>
-              <a:t>🛑 Go to Activity 3 — Parts 4–5</a:t>
-            </a:r>
-          </a:p>
-          <a:p>
-            <a:pPr lvl="0" indent="0" marL="0">
-              <a:buNone/>
-            </a:pPr>
-            <a:r>
-              <a:rPr/>
-              <a:t>Close the slides. Build your own mean ± SE plot, then save it to </a:t>
-            </a:r>
-            <a:r>
-              <a:rPr>
-                <a:latin typeface="Courier"/>
-              </a:rPr>
-              <a:t>figures/</a:t>
-            </a:r>
-            <a:r>
-              <a:rPr/>
-              <a:t>.</a:t>
             </a:r>
           </a:p>
         </p:txBody>
@@ -8493,6 +9553,102 @@
         <p:spPr>
           <a:xfrm>
             <a:off x="0" y="0"/>
+            <a:ext cx="9144000" cy="582780"/>
+          </a:xfrm>
+        </p:spPr>
+        <p:txBody>
+          <a:bodyPr/>
+          <a:lstStyle/>
+          <a:p>
+            <a:pPr lvl="0" indent="0" marL="0">
+              <a:buNone/>
+            </a:pPr>
+            <a:r>
+              <a:rPr/>
+              <a:t>→ ACTIVITY 3 Parts 4–5 now</a:t>
+            </a:r>
+          </a:p>
+        </p:txBody>
+      </p:sp>
+      <p:sp>
+        <p:nvSpPr>
+          <p:cNvPr id="3" name="Content Placeholder 2"/>
+          <p:cNvSpPr>
+            <a:spLocks noGrp="1"/>
+          </p:cNvSpPr>
+          <p:nvPr>
+            <p:ph idx="1"/>
+          </p:nvPr>
+        </p:nvSpPr>
+        <p:spPr/>
+        <p:txBody>
+          <a:bodyPr/>
+          <a:lstStyle/>
+          <a:p>
+            <a:pPr lvl="0" indent="0" marL="0">
+              <a:buNone/>
+            </a:pPr>
+            <a:r>
+              <a:rPr b="1"/>
+              <a:t>🛑 Go to Activity 3 — Parts 4–5</a:t>
+            </a:r>
+          </a:p>
+          <a:p>
+            <a:pPr lvl="0" indent="0" marL="0">
+              <a:buNone/>
+            </a:pPr>
+            <a:r>
+              <a:rPr/>
+              <a:t>Close the slides. Build your own mean ± SE plot, then save it to </a:t>
+            </a:r>
+            <a:r>
+              <a:rPr>
+                <a:latin typeface="Courier"/>
+              </a:rPr>
+              <a:t>figures/</a:t>
+            </a:r>
+            <a:r>
+              <a:rPr/>
+              <a:t>.</a:t>
+            </a:r>
+          </a:p>
+        </p:txBody>
+      </p:sp>
+    </p:spTree>
+  </p:cSld>
+</p:sld>
+</file>
+
+<file path=ppt/slides/slide21.xml><?xml version="1.0" encoding="utf-8"?>
+<p:sld xmlns:a="http://schemas.openxmlformats.org/drawingml/2006/main" xmlns:r="http://schemas.openxmlformats.org/officeDocument/2006/relationships" xmlns:p="http://schemas.openxmlformats.org/presentationml/2006/main">
+  <p:cSld>
+    <p:spTree>
+      <p:nvGrpSpPr>
+        <p:cNvPr id="1" name=""/>
+        <p:cNvGrpSpPr/>
+        <p:nvPr/>
+      </p:nvGrpSpPr>
+      <p:grpSpPr>
+        <a:xfrm>
+          <a:off x="0" y="0"/>
+          <a:ext cx="0" cy="0"/>
+          <a:chOff x="0" y="0"/>
+          <a:chExt cx="0" cy="0"/>
+        </a:xfrm>
+      </p:grpSpPr>
+      <p:sp>
+        <p:nvSpPr>
+          <p:cNvPr id="2" name="Title 1"/>
+          <p:cNvSpPr>
+            <a:spLocks noGrp="1"/>
+          </p:cNvSpPr>
+          <p:nvPr>
+            <p:ph type="title"/>
+          </p:nvPr>
+        </p:nvSpPr>
+        <p:spPr>
+          <a:xfrm>
+            <a:off x="0" y="0"/>
             <a:ext cx="9144000" cy="602780"/>
           </a:xfrm>
           <a:solidFill>
@@ -8600,6 +9756,33 @@
             <a:r>
               <a:rPr/>
               <a:t> — mean and mean ± SE, drawn directly from raw data</a:t>
+            </a:r>
+          </a:p>
+          <a:p>
+            <a:pPr lvl="0"/>
+            <a:r>
+              <a:rPr/>
+              <a:t>Positions defined once at the top (</a:t>
+            </a:r>
+            <a:r>
+              <a:rPr>
+                <a:latin typeface="Courier"/>
+              </a:rPr>
+              <a:t>jitter_pos</a:t>
+            </a:r>
+            <a:r>
+              <a:rPr/>
+              <a:t>, </a:t>
+            </a:r>
+            <a:r>
+              <a:rPr>
+                <a:latin typeface="Courier"/>
+              </a:rPr>
+              <a:t>dodge_pos</a:t>
+            </a:r>
+            <a:r>
+              <a:rPr/>
+              <a:t>) and reused on every layer</a:t>
             </a:r>
           </a:p>
         </p:txBody>
@@ -9564,8 +10747,11 @@
         <p:spPr>
           <a:xfrm>
             <a:off x="0" y="0"/>
-            <a:ext cx="9144000" cy="582780"/>
+            <a:ext cx="9144000" cy="602780"/>
           </a:xfrm>
+          <a:solidFill>
+            <a:srgbClr val="1A1A2E"/>
+          </a:solidFill>
         </p:spPr>
         <p:txBody>
           <a:bodyPr/>
@@ -9576,7 +10762,7 @@
             </a:pPr>
             <a:r>
               <a:rPr/>
-              <a:t>🧩 Chunk 1 of 3 · Piping into ggplot, on Purpose</a:t>
+              <a:t>Positions — Define Once, Reuse on Every Layer</a:t>
             </a:r>
           </a:p>
         </p:txBody>
@@ -9588,7 +10774,7 @@
             <a:spLocks noGrp="1"/>
           </p:cNvSpPr>
           <p:nvPr>
-            <p:ph idx="1"/>
+            <p:ph idx="1" sz="half"/>
           </p:nvPr>
         </p:nvSpPr>
         <p:spPr/>
@@ -9596,35 +10782,338 @@
           <a:bodyPr/>
           <a:lstStyle/>
           <a:p>
-            <a:pPr lvl="0" indent="0" marL="0">
+            <a:pPr lvl="0" indent="0">
               <a:buNone/>
             </a:pPr>
             <a:r>
+              <a:rPr>
+                <a:solidFill>
+                  <a:srgbClr val="5E5E5E"/>
+                </a:solidFill>
+                <a:latin typeface="Courier"/>
+              </a:rPr>
+              <a:t># a "position" is HOW a layer nudges its shapes sideways</a:t>
+            </a:r>
+            <a:br/>
+            <a:r>
+              <a:rPr>
+                <a:solidFill>
+                  <a:srgbClr val="5E5E5E"/>
+                </a:solidFill>
+                <a:latin typeface="Courier"/>
+              </a:rPr>
+              <a:t># define each one once, up top, then reuse it on every layer</a:t>
+            </a:r>
+            <a:br/>
+            <a:br/>
+            <a:r>
+              <a:rPr>
+                <a:solidFill>
+                  <a:srgbClr val="5E5E5E"/>
+                </a:solidFill>
+                <a:latin typeface="Courier"/>
+              </a:rPr>
+              <a:t># raw points: scatter them so they don't stack on one line</a:t>
+            </a:r>
+            <a:br/>
+            <a:r>
+              <a:rPr>
+                <a:solidFill>
+                  <a:srgbClr val="003B4F"/>
+                </a:solidFill>
+                <a:latin typeface="Courier"/>
+              </a:rPr>
+              <a:t>jitter_pos &lt;- </a:t>
+            </a:r>
+            <a:r>
+              <a:rPr>
+                <a:solidFill>
+                  <a:srgbClr val="4758AB"/>
+                </a:solidFill>
+                <a:latin typeface="Courier"/>
+              </a:rPr>
+              <a:t>position_jitter</a:t>
+            </a:r>
+            <a:r>
+              <a:rPr>
+                <a:solidFill>
+                  <a:srgbClr val="003B4F"/>
+                </a:solidFill>
+                <a:latin typeface="Courier"/>
+              </a:rPr>
+              <a:t>(</a:t>
+            </a:r>
+            <a:r>
+              <a:rPr>
+                <a:solidFill>
+                  <a:srgbClr val="657422"/>
+                </a:solidFill>
+                <a:latin typeface="Courier"/>
+              </a:rPr>
+              <a:t>width =</a:t>
+            </a:r>
+            <a:r>
+              <a:rPr>
+                <a:solidFill>
+                  <a:srgbClr val="003B4F"/>
+                </a:solidFill>
+                <a:latin typeface="Courier"/>
+              </a:rPr>
+              <a:t> </a:t>
+            </a:r>
+            <a:r>
+              <a:rPr>
+                <a:solidFill>
+                  <a:srgbClr val="AD0000"/>
+                </a:solidFill>
+                <a:latin typeface="Courier"/>
+              </a:rPr>
+              <a:t>0.15</a:t>
+            </a:r>
+            <a:r>
+              <a:rPr>
+                <a:solidFill>
+                  <a:srgbClr val="003B4F"/>
+                </a:solidFill>
+                <a:latin typeface="Courier"/>
+              </a:rPr>
+              <a:t>, </a:t>
+            </a:r>
+            <a:r>
+              <a:rPr>
+                <a:solidFill>
+                  <a:srgbClr val="657422"/>
+                </a:solidFill>
+                <a:latin typeface="Courier"/>
+              </a:rPr>
+              <a:t>seed =</a:t>
+            </a:r>
+            <a:r>
+              <a:rPr>
+                <a:solidFill>
+                  <a:srgbClr val="003B4F"/>
+                </a:solidFill>
+                <a:latin typeface="Courier"/>
+              </a:rPr>
+              <a:t> </a:t>
+            </a:r>
+            <a:r>
+              <a:rPr>
+                <a:solidFill>
+                  <a:srgbClr val="AD0000"/>
+                </a:solidFill>
+                <a:latin typeface="Courier"/>
+              </a:rPr>
+              <a:t>42</a:t>
+            </a:r>
+            <a:r>
+              <a:rPr>
+                <a:solidFill>
+                  <a:srgbClr val="003B4F"/>
+                </a:solidFill>
+                <a:latin typeface="Courier"/>
+              </a:rPr>
+              <a:t>)</a:t>
+            </a:r>
+            <a:br/>
+            <a:br/>
+            <a:r>
+              <a:rPr>
+                <a:solidFill>
+                  <a:srgbClr val="5E5E5E"/>
+                </a:solidFill>
+                <a:latin typeface="Courier"/>
+              </a:rPr>
+              <a:t># grouped summaries / lines: shift the groups side by side</a:t>
+            </a:r>
+            <a:br/>
+            <a:r>
+              <a:rPr>
+                <a:solidFill>
+                  <a:srgbClr val="003B4F"/>
+                </a:solidFill>
+                <a:latin typeface="Courier"/>
+              </a:rPr>
+              <a:t>dodge_pos &lt;- </a:t>
+            </a:r>
+            <a:r>
+              <a:rPr>
+                <a:solidFill>
+                  <a:srgbClr val="4758AB"/>
+                </a:solidFill>
+                <a:latin typeface="Courier"/>
+              </a:rPr>
+              <a:t>position_dodge</a:t>
+            </a:r>
+            <a:r>
+              <a:rPr>
+                <a:solidFill>
+                  <a:srgbClr val="003B4F"/>
+                </a:solidFill>
+                <a:latin typeface="Courier"/>
+              </a:rPr>
+              <a:t>(</a:t>
+            </a:r>
+            <a:r>
+              <a:rPr>
+                <a:solidFill>
+                  <a:srgbClr val="657422"/>
+                </a:solidFill>
+                <a:latin typeface="Courier"/>
+              </a:rPr>
+              <a:t>width =</a:t>
+            </a:r>
+            <a:r>
+              <a:rPr>
+                <a:solidFill>
+                  <a:srgbClr val="003B4F"/>
+                </a:solidFill>
+                <a:latin typeface="Courier"/>
+              </a:rPr>
+              <a:t> </a:t>
+            </a:r>
+            <a:r>
+              <a:rPr>
+                <a:solidFill>
+                  <a:srgbClr val="AD0000"/>
+                </a:solidFill>
+                <a:latin typeface="Courier"/>
+              </a:rPr>
+              <a:t>0.2</a:t>
+            </a:r>
+            <a:r>
+              <a:rPr>
+                <a:solidFill>
+                  <a:srgbClr val="003B4F"/>
+                </a:solidFill>
+                <a:latin typeface="Courier"/>
+              </a:rPr>
+              <a:t>)</a:t>
+            </a:r>
+          </a:p>
+        </p:txBody>
+      </p:sp>
+      <p:sp>
+        <p:nvSpPr>
+          <p:cNvPr id="4" name="Content Placeholder 3"/>
+          <p:cNvSpPr>
+            <a:spLocks noGrp="1"/>
+          </p:cNvSpPr>
+          <p:nvPr>
+            <p:ph idx="2" sz="half"/>
+          </p:nvPr>
+        </p:nvSpPr>
+        <p:spPr/>
+        <p:txBody>
+          <a:bodyPr/>
+          <a:lstStyle/>
+          <a:p>
+            <a:pPr lvl="0"/>
+            <a:r>
+              <a:rPr>
+                <a:latin typeface="Courier"/>
+              </a:rPr>
+              <a:t>position_jitter(width = 0.15)</a:t>
+            </a:r>
+            <a:r>
+              <a:rPr/>
+              <a:t> — random sideways nudge so overlapping points become visible; </a:t>
+            </a:r>
+            <a:r>
+              <a:rPr>
+                <a:latin typeface="Courier"/>
+              </a:rPr>
+              <a:t>seed = 42</a:t>
+            </a:r>
+            <a:r>
+              <a:rPr/>
+              <a:t> freezes that nudge so the figure looks the same every render</a:t>
+            </a:r>
+          </a:p>
+          <a:p>
+            <a:pPr lvl="0"/>
+            <a:r>
+              <a:rPr>
+                <a:latin typeface="Courier"/>
+              </a:rPr>
+              <a:t>position_dodge(width = 0.2)</a:t>
+            </a:r>
+            <a:r>
+              <a:rPr/>
+              <a:t> — shifts groups apart; does nothing with one group per x, but the moment you add a second grouping variable (</a:t>
+            </a:r>
+            <a:r>
+              <a:rPr>
+                <a:latin typeface="Courier"/>
+              </a:rPr>
+              <a:t>color = sex</a:t>
+            </a:r>
+            <a:r>
+              <a:rPr/>
+              <a:t>) it fans the groups out</a:t>
+            </a:r>
+          </a:p>
+          <a:p>
+            <a:pPr lvl="0"/>
+            <a:r>
+              <a:rPr/>
+              <a:t>Reusing </a:t>
+            </a:r>
+            <a:r>
               <a:rPr b="1"/>
-              <a:t>We will cover:</a:t>
-            </a:r>
-            <a:r>
-              <a:rPr/>
-              <a:t> starting a plot with the pipe, and choosing colors with </a:t>
-            </a:r>
-            <a:r>
-              <a:rPr>
-                <a:latin typeface="Courier"/>
-              </a:rPr>
-              <a:t>scale_color_manual()</a:t>
-            </a:r>
-            <a:r>
-              <a:rPr/>
-              <a:t>.</a:t>
-            </a:r>
-          </a:p>
-          <a:p>
-            <a:pPr lvl="0" indent="0" marL="0">
-              <a:buNone/>
-            </a:pPr>
+              <a:t>one</a:t>
+            </a:r>
+            <a:r>
+              <a:rPr/>
+              <a:t> </a:t>
+            </a:r>
+            <a:r>
+              <a:rPr>
+                <a:latin typeface="Courier"/>
+              </a:rPr>
+              <a:t>dodge_pos</a:t>
+            </a:r>
+            <a:r>
+              <a:rPr/>
+              <a:t> on </a:t>
+            </a:r>
+            <a:r>
+              <a:rPr>
+                <a:latin typeface="Courier"/>
+              </a:rPr>
+              <a:t>geom_point()</a:t>
+            </a:r>
+            <a:r>
+              <a:rPr/>
+              <a:t>, </a:t>
+            </a:r>
+            <a:r>
+              <a:rPr>
+                <a:latin typeface="Courier"/>
+              </a:rPr>
+              <a:t>geom_errorbar()</a:t>
+            </a:r>
+            <a:r>
+              <a:rPr/>
+              <a:t>, </a:t>
+            </a:r>
             <a:r>
               <a:rPr b="1"/>
-              <a:t>🛑 After this chunk you will do Activity Parts 1–2.</a:t>
+              <a:t>and</a:t>
+            </a:r>
+            <a:r>
+              <a:rPr/>
+              <a:t> </a:t>
+            </a:r>
+            <a:r>
+              <a:rPr>
+                <a:latin typeface="Courier"/>
+              </a:rPr>
+              <a:t>geom_line()</a:t>
+            </a:r>
+            <a:r>
+              <a:rPr/>
+              <a:t> is what keeps a grouped mean, its error bar, and its connecting line perfectly aligned</a:t>
             </a:r>
           </a:p>
         </p:txBody>
@@ -9663,6 +11152,106 @@
         </p:nvSpPr>
         <p:spPr>
           <a:xfrm>
+            <a:off x="0" y="0"/>
+            <a:ext cx="9144000" cy="582780"/>
+          </a:xfrm>
+        </p:spPr>
+        <p:txBody>
+          <a:bodyPr/>
+          <a:lstStyle/>
+          <a:p>
+            <a:pPr lvl="0" indent="0" marL="0">
+              <a:buNone/>
+            </a:pPr>
+            <a:r>
+              <a:rPr/>
+              <a:t>🧩 Chunk 1 of 3 · Piping into ggplot, on Purpose</a:t>
+            </a:r>
+          </a:p>
+        </p:txBody>
+      </p:sp>
+      <p:sp>
+        <p:nvSpPr>
+          <p:cNvPr id="3" name="Content Placeholder 2"/>
+          <p:cNvSpPr>
+            <a:spLocks noGrp="1"/>
+          </p:cNvSpPr>
+          <p:nvPr>
+            <p:ph idx="1"/>
+          </p:nvPr>
+        </p:nvSpPr>
+        <p:spPr/>
+        <p:txBody>
+          <a:bodyPr/>
+          <a:lstStyle/>
+          <a:p>
+            <a:pPr lvl="0" indent="0" marL="0">
+              <a:buNone/>
+            </a:pPr>
+            <a:r>
+              <a:rPr b="1"/>
+              <a:t>We will cover:</a:t>
+            </a:r>
+            <a:r>
+              <a:rPr/>
+              <a:t> starting a plot with the pipe, and choosing colors with </a:t>
+            </a:r>
+            <a:r>
+              <a:rPr>
+                <a:latin typeface="Courier"/>
+              </a:rPr>
+              <a:t>scale_color_manual()</a:t>
+            </a:r>
+            <a:r>
+              <a:rPr/>
+              <a:t>.</a:t>
+            </a:r>
+          </a:p>
+          <a:p>
+            <a:pPr lvl="0" indent="0" marL="0">
+              <a:buNone/>
+            </a:pPr>
+            <a:r>
+              <a:rPr b="1"/>
+              <a:t>🛑 After this chunk you will do Activity Parts 1–2.</a:t>
+            </a:r>
+          </a:p>
+        </p:txBody>
+      </p:sp>
+    </p:spTree>
+  </p:cSld>
+</p:sld>
+</file>
+
+<file path=ppt/slides/slide8.xml><?xml version="1.0" encoding="utf-8"?>
+<p:sld xmlns:a="http://schemas.openxmlformats.org/drawingml/2006/main" xmlns:r="http://schemas.openxmlformats.org/officeDocument/2006/relationships" xmlns:p="http://schemas.openxmlformats.org/presentationml/2006/main">
+  <p:cSld>
+    <p:spTree>
+      <p:nvGrpSpPr>
+        <p:cNvPr id="1" name=""/>
+        <p:cNvGrpSpPr/>
+        <p:nvPr/>
+      </p:nvGrpSpPr>
+      <p:grpSpPr>
+        <a:xfrm>
+          <a:off x="0" y="0"/>
+          <a:ext cx="0" cy="0"/>
+          <a:chOff x="0" y="0"/>
+          <a:chExt cx="0" cy="0"/>
+        </a:xfrm>
+      </p:grpSpPr>
+      <p:sp>
+        <p:nvSpPr>
+          <p:cNvPr id="2" name="Title 1"/>
+          <p:cNvSpPr>
+            <a:spLocks noGrp="1"/>
+          </p:cNvSpPr>
+          <p:nvPr>
+            <p:ph type="title"/>
+          </p:nvPr>
+        </p:nvSpPr>
+        <p:spPr>
+          <a:xfrm>
             <a:off x="139485" y="78119"/>
             <a:ext cx="8229600" cy="607682"/>
           </a:xfrm>
@@ -9962,7 +11551,7 @@
                 </a:solidFill>
                 <a:latin typeface="Courier"/>
               </a:rPr>
-              <a:t>geom_jitter</a:t>
+              <a:t>geom_point</a:t>
             </a:r>
             <a:r>
               <a:rPr>
@@ -9980,34 +11569,16 @@
                 </a:solidFill>
                 <a:latin typeface="Courier"/>
               </a:rPr>
-              <a:t>width =</a:t>
-            </a:r>
-            <a:r>
-              <a:rPr>
-                <a:solidFill>
-                  <a:srgbClr val="003B4F"/>
-                </a:solidFill>
-                <a:latin typeface="Courier"/>
-              </a:rPr>
-              <a:t> </a:t>
-            </a:r>
-            <a:r>
-              <a:rPr>
-                <a:solidFill>
-                  <a:srgbClr val="AD0000"/>
-                </a:solidFill>
-                <a:latin typeface="Courier"/>
-              </a:rPr>
-              <a:t>0.15</a:t>
-            </a:r>
-            <a:r>
-              <a:rPr>
-                <a:solidFill>
-                  <a:srgbClr val="003B4F"/>
-                </a:solidFill>
-                <a:latin typeface="Courier"/>
-              </a:rPr>
-              <a:t>, </a:t>
+              <a:t>position =</a:t>
+            </a:r>
+            <a:r>
+              <a:rPr>
+                <a:solidFill>
+                  <a:srgbClr val="003B4F"/>
+                </a:solidFill>
+                <a:latin typeface="Courier"/>
+              </a:rPr>
+              <a:t> jitter_pos, </a:t>
             </a:r>
             <a:r>
               <a:rPr>
@@ -10502,7 +12073,7 @@
 </p:sld>
 </file>
 
-<file path=ppt/slides/slide8.xml><?xml version="1.0" encoding="utf-8"?>
+<file path=ppt/slides/slide9.xml><?xml version="1.0" encoding="utf-8"?>
 <p:sld xmlns:a="http://schemas.openxmlformats.org/drawingml/2006/main" xmlns:r="http://schemas.openxmlformats.org/officeDocument/2006/relationships" xmlns:p="http://schemas.openxmlformats.org/presentationml/2006/main">
   <p:cSld>
     <p:spTree>
@@ -10619,1067 +12190,6 @@
             <a:r>
               <a:rPr sz="2000"/>
               <a:t>). How many colors do we need to supply?</a:t>
-            </a:r>
-          </a:p>
-        </p:txBody>
-      </p:sp>
-    </p:spTree>
-  </p:cSld>
-</p:sld>
-</file>
-
-<file path=ppt/slides/slide9.xml><?xml version="1.0" encoding="utf-8"?>
-<p:sld xmlns:a="http://schemas.openxmlformats.org/drawingml/2006/main" xmlns:r="http://schemas.openxmlformats.org/officeDocument/2006/relationships" xmlns:p="http://schemas.openxmlformats.org/presentationml/2006/main">
-  <p:cSld>
-    <p:spTree>
-      <p:nvGrpSpPr>
-        <p:cNvPr id="1" name=""/>
-        <p:cNvGrpSpPr/>
-        <p:nvPr/>
-      </p:nvGrpSpPr>
-      <p:grpSpPr>
-        <a:xfrm>
-          <a:off x="0" y="0"/>
-          <a:ext cx="0" cy="0"/>
-          <a:chOff x="0" y="0"/>
-          <a:chExt cx="0" cy="0"/>
-        </a:xfrm>
-      </p:grpSpPr>
-      <p:sp>
-        <p:nvSpPr>
-          <p:cNvPr id="3" name="Text Placeholder 2"/>
-          <p:cNvSpPr>
-            <a:spLocks noGrp="1"/>
-          </p:cNvSpPr>
-          <p:nvPr>
-            <p:ph idx="1" type="body"/>
-          </p:nvPr>
-        </p:nvSpPr>
-        <p:spPr/>
-        <p:txBody>
-          <a:bodyPr/>
-          <a:lstStyle/>
-          <a:p>
-            <a:pPr lvl="0" indent="0">
-              <a:buNone/>
-            </a:pPr>
-            <a:r>
-              <a:rPr>
-                <a:solidFill>
-                  <a:srgbClr val="5E5E5E"/>
-                </a:solidFill>
-                <a:latin typeface="Courier"/>
-              </a:rPr>
-              <a:t># scale_fill_manual() assigns exact colors to exact groups</a:t>
-            </a:r>
-            <a:br/>
-            <a:r>
-              <a:rPr>
-                <a:solidFill>
-                  <a:srgbClr val="003B4F"/>
-                </a:solidFill>
-                <a:latin typeface="Courier"/>
-              </a:rPr>
-              <a:t>leaf_df </a:t>
-            </a:r>
-            <a:r>
-              <a:rPr>
-                <a:solidFill>
-                  <a:srgbClr val="5E5E5E"/>
-                </a:solidFill>
-                <a:latin typeface="Courier"/>
-              </a:rPr>
-              <a:t>%&gt;%</a:t>
-            </a:r>
-            <a:br/>
-            <a:r>
-              <a:rPr>
-                <a:solidFill>
-                  <a:srgbClr val="003B4F"/>
-                </a:solidFill>
-                <a:latin typeface="Courier"/>
-              </a:rPr>
-              <a:t>  </a:t>
-            </a:r>
-            <a:r>
-              <a:rPr>
-                <a:solidFill>
-                  <a:srgbClr val="4758AB"/>
-                </a:solidFill>
-                <a:latin typeface="Courier"/>
-              </a:rPr>
-              <a:t>ggplot</a:t>
-            </a:r>
-            <a:r>
-              <a:rPr>
-                <a:solidFill>
-                  <a:srgbClr val="003B4F"/>
-                </a:solidFill>
-                <a:latin typeface="Courier"/>
-              </a:rPr>
-              <a:t>(</a:t>
-            </a:r>
-            <a:r>
-              <a:rPr>
-                <a:solidFill>
-                  <a:srgbClr val="4758AB"/>
-                </a:solidFill>
-                <a:latin typeface="Courier"/>
-              </a:rPr>
-              <a:t>aes</a:t>
-            </a:r>
-            <a:r>
-              <a:rPr>
-                <a:solidFill>
-                  <a:srgbClr val="003B4F"/>
-                </a:solidFill>
-                <a:latin typeface="Courier"/>
-              </a:rPr>
-              <a:t>(</a:t>
-            </a:r>
-            <a:r>
-              <a:rPr>
-                <a:solidFill>
-                  <a:srgbClr val="657422"/>
-                </a:solidFill>
-                <a:latin typeface="Courier"/>
-              </a:rPr>
-              <a:t>x =</a:t>
-            </a:r>
-            <a:r>
-              <a:rPr>
-                <a:solidFill>
-                  <a:srgbClr val="003B4F"/>
-                </a:solidFill>
-                <a:latin typeface="Courier"/>
-              </a:rPr>
-              <a:t> shade, </a:t>
-            </a:r>
-            <a:r>
-              <a:rPr>
-                <a:solidFill>
-                  <a:srgbClr val="657422"/>
-                </a:solidFill>
-                <a:latin typeface="Courier"/>
-              </a:rPr>
-              <a:t>y =</a:t>
-            </a:r>
-            <a:r>
-              <a:rPr>
-                <a:solidFill>
-                  <a:srgbClr val="003B4F"/>
-                </a:solidFill>
-                <a:latin typeface="Courier"/>
-              </a:rPr>
-              <a:t> mass_g, </a:t>
-            </a:r>
-            <a:r>
-              <a:rPr>
-                <a:solidFill>
-                  <a:srgbClr val="657422"/>
-                </a:solidFill>
-                <a:latin typeface="Courier"/>
-              </a:rPr>
-              <a:t>fill =</a:t>
-            </a:r>
-            <a:r>
-              <a:rPr>
-                <a:solidFill>
-                  <a:srgbClr val="003B4F"/>
-                </a:solidFill>
-                <a:latin typeface="Courier"/>
-              </a:rPr>
-              <a:t> shade)) </a:t>
-            </a:r>
-            <a:r>
-              <a:rPr>
-                <a:solidFill>
-                  <a:srgbClr val="5E5E5E"/>
-                </a:solidFill>
-                <a:latin typeface="Courier"/>
-              </a:rPr>
-              <a:t>+</a:t>
-            </a:r>
-            <a:br/>
-            <a:r>
-              <a:rPr>
-                <a:solidFill>
-                  <a:srgbClr val="003B4F"/>
-                </a:solidFill>
-                <a:latin typeface="Courier"/>
-              </a:rPr>
-              <a:t>  </a:t>
-            </a:r>
-            <a:r>
-              <a:rPr>
-                <a:solidFill>
-                  <a:srgbClr val="4758AB"/>
-                </a:solidFill>
-                <a:latin typeface="Courier"/>
-              </a:rPr>
-              <a:t>geom_boxplot</a:t>
-            </a:r>
-            <a:r>
-              <a:rPr>
-                <a:solidFill>
-                  <a:srgbClr val="003B4F"/>
-                </a:solidFill>
-                <a:latin typeface="Courier"/>
-              </a:rPr>
-              <a:t>(</a:t>
-            </a:r>
-            <a:r>
-              <a:rPr>
-                <a:solidFill>
-                  <a:srgbClr val="657422"/>
-                </a:solidFill>
-                <a:latin typeface="Courier"/>
-              </a:rPr>
-              <a:t>alpha =</a:t>
-            </a:r>
-            <a:r>
-              <a:rPr>
-                <a:solidFill>
-                  <a:srgbClr val="003B4F"/>
-                </a:solidFill>
-                <a:latin typeface="Courier"/>
-              </a:rPr>
-              <a:t> </a:t>
-            </a:r>
-            <a:r>
-              <a:rPr>
-                <a:solidFill>
-                  <a:srgbClr val="AD0000"/>
-                </a:solidFill>
-                <a:latin typeface="Courier"/>
-              </a:rPr>
-              <a:t>0.6</a:t>
-            </a:r>
-            <a:r>
-              <a:rPr>
-                <a:solidFill>
-                  <a:srgbClr val="003B4F"/>
-                </a:solidFill>
-                <a:latin typeface="Courier"/>
-              </a:rPr>
-              <a:t>, </a:t>
-            </a:r>
-            <a:r>
-              <a:rPr>
-                <a:solidFill>
-                  <a:srgbClr val="657422"/>
-                </a:solidFill>
-                <a:latin typeface="Courier"/>
-              </a:rPr>
-              <a:t>outlier.shape =</a:t>
-            </a:r>
-            <a:r>
-              <a:rPr>
-                <a:solidFill>
-                  <a:srgbClr val="003B4F"/>
-                </a:solidFill>
-                <a:latin typeface="Courier"/>
-              </a:rPr>
-              <a:t> </a:t>
-            </a:r>
-            <a:r>
-              <a:rPr>
-                <a:solidFill>
-                  <a:srgbClr val="8F5902"/>
-                </a:solidFill>
-                <a:latin typeface="Courier"/>
-              </a:rPr>
-              <a:t>NA</a:t>
-            </a:r>
-            <a:r>
-              <a:rPr>
-                <a:solidFill>
-                  <a:srgbClr val="003B4F"/>
-                </a:solidFill>
-                <a:latin typeface="Courier"/>
-              </a:rPr>
-              <a:t>) </a:t>
-            </a:r>
-            <a:r>
-              <a:rPr>
-                <a:solidFill>
-                  <a:srgbClr val="5E5E5E"/>
-                </a:solidFill>
-                <a:latin typeface="Courier"/>
-              </a:rPr>
-              <a:t>+</a:t>
-            </a:r>
-            <a:br/>
-            <a:r>
-              <a:rPr>
-                <a:solidFill>
-                  <a:srgbClr val="003B4F"/>
-                </a:solidFill>
-                <a:latin typeface="Courier"/>
-              </a:rPr>
-              <a:t>  </a:t>
-            </a:r>
-            <a:r>
-              <a:rPr>
-                <a:solidFill>
-                  <a:srgbClr val="4758AB"/>
-                </a:solidFill>
-                <a:latin typeface="Courier"/>
-              </a:rPr>
-              <a:t>geom_jitter</a:t>
-            </a:r>
-            <a:r>
-              <a:rPr>
-                <a:solidFill>
-                  <a:srgbClr val="003B4F"/>
-                </a:solidFill>
-                <a:latin typeface="Courier"/>
-              </a:rPr>
-              <a:t>(</a:t>
-            </a:r>
-            <a:r>
-              <a:rPr>
-                <a:solidFill>
-                  <a:srgbClr val="657422"/>
-                </a:solidFill>
-                <a:latin typeface="Courier"/>
-              </a:rPr>
-              <a:t>width =</a:t>
-            </a:r>
-            <a:r>
-              <a:rPr>
-                <a:solidFill>
-                  <a:srgbClr val="003B4F"/>
-                </a:solidFill>
-                <a:latin typeface="Courier"/>
-              </a:rPr>
-              <a:t> </a:t>
-            </a:r>
-            <a:r>
-              <a:rPr>
-                <a:solidFill>
-                  <a:srgbClr val="AD0000"/>
-                </a:solidFill>
-                <a:latin typeface="Courier"/>
-              </a:rPr>
-              <a:t>0.15</a:t>
-            </a:r>
-            <a:r>
-              <a:rPr>
-                <a:solidFill>
-                  <a:srgbClr val="003B4F"/>
-                </a:solidFill>
-                <a:latin typeface="Courier"/>
-              </a:rPr>
-              <a:t>, </a:t>
-            </a:r>
-            <a:r>
-              <a:rPr>
-                <a:solidFill>
-                  <a:srgbClr val="657422"/>
-                </a:solidFill>
-                <a:latin typeface="Courier"/>
-              </a:rPr>
-              <a:t>alpha =</a:t>
-            </a:r>
-            <a:r>
-              <a:rPr>
-                <a:solidFill>
-                  <a:srgbClr val="003B4F"/>
-                </a:solidFill>
-                <a:latin typeface="Courier"/>
-              </a:rPr>
-              <a:t> </a:t>
-            </a:r>
-            <a:r>
-              <a:rPr>
-                <a:solidFill>
-                  <a:srgbClr val="AD0000"/>
-                </a:solidFill>
-                <a:latin typeface="Courier"/>
-              </a:rPr>
-              <a:t>0.6</a:t>
-            </a:r>
-            <a:r>
-              <a:rPr>
-                <a:solidFill>
-                  <a:srgbClr val="003B4F"/>
-                </a:solidFill>
-                <a:latin typeface="Courier"/>
-              </a:rPr>
-              <a:t>) </a:t>
-            </a:r>
-            <a:r>
-              <a:rPr>
-                <a:solidFill>
-                  <a:srgbClr val="5E5E5E"/>
-                </a:solidFill>
-                <a:latin typeface="Courier"/>
-              </a:rPr>
-              <a:t>+</a:t>
-            </a:r>
-            <a:br/>
-            <a:r>
-              <a:rPr>
-                <a:solidFill>
-                  <a:srgbClr val="003B4F"/>
-                </a:solidFill>
-                <a:latin typeface="Courier"/>
-              </a:rPr>
-              <a:t>  </a:t>
-            </a:r>
-            <a:r>
-              <a:rPr>
-                <a:solidFill>
-                  <a:srgbClr val="4758AB"/>
-                </a:solidFill>
-                <a:latin typeface="Courier"/>
-              </a:rPr>
-              <a:t>scale_fill_manual</a:t>
-            </a:r>
-            <a:r>
-              <a:rPr>
-                <a:solidFill>
-                  <a:srgbClr val="003B4F"/>
-                </a:solidFill>
-                <a:latin typeface="Courier"/>
-              </a:rPr>
-              <a:t>(</a:t>
-            </a:r>
-            <a:r>
-              <a:rPr>
-                <a:solidFill>
-                  <a:srgbClr val="657422"/>
-                </a:solidFill>
-                <a:latin typeface="Courier"/>
-              </a:rPr>
-              <a:t>values =</a:t>
-            </a:r>
-            <a:r>
-              <a:rPr>
-                <a:solidFill>
-                  <a:srgbClr val="003B4F"/>
-                </a:solidFill>
-                <a:latin typeface="Courier"/>
-              </a:rPr>
-              <a:t> </a:t>
-            </a:r>
-            <a:r>
-              <a:rPr>
-                <a:solidFill>
-                  <a:srgbClr val="4758AB"/>
-                </a:solidFill>
-                <a:latin typeface="Courier"/>
-              </a:rPr>
-              <a:t>c</a:t>
-            </a:r>
-            <a:r>
-              <a:rPr>
-                <a:solidFill>
-                  <a:srgbClr val="003B4F"/>
-                </a:solidFill>
-                <a:latin typeface="Courier"/>
-              </a:rPr>
-              <a:t>(</a:t>
-            </a:r>
-            <a:br/>
-            <a:r>
-              <a:rPr>
-                <a:solidFill>
-                  <a:srgbClr val="003B4F"/>
-                </a:solidFill>
-                <a:latin typeface="Courier"/>
-              </a:rPr>
-              <a:t>    </a:t>
-            </a:r>
-            <a:r>
-              <a:rPr>
-                <a:solidFill>
-                  <a:srgbClr val="20794D"/>
-                </a:solidFill>
-                <a:latin typeface="Courier"/>
-              </a:rPr>
-              <a:t>"sunny"</a:t>
-            </a:r>
-            <a:r>
-              <a:rPr>
-                <a:solidFill>
-                  <a:srgbClr val="003B4F"/>
-                </a:solidFill>
-                <a:latin typeface="Courier"/>
-              </a:rPr>
-              <a:t> = </a:t>
-            </a:r>
-            <a:r>
-              <a:rPr>
-                <a:solidFill>
-                  <a:srgbClr val="20794D"/>
-                </a:solidFill>
-                <a:latin typeface="Courier"/>
-              </a:rPr>
-              <a:t>"goldenrod"</a:t>
-            </a:r>
-            <a:r>
-              <a:rPr>
-                <a:solidFill>
-                  <a:srgbClr val="003B4F"/>
-                </a:solidFill>
-                <a:latin typeface="Courier"/>
-              </a:rPr>
-              <a:t>,</a:t>
-            </a:r>
-            <a:br/>
-            <a:r>
-              <a:rPr>
-                <a:solidFill>
-                  <a:srgbClr val="003B4F"/>
-                </a:solidFill>
-                <a:latin typeface="Courier"/>
-              </a:rPr>
-              <a:t>    </a:t>
-            </a:r>
-            <a:r>
-              <a:rPr>
-                <a:solidFill>
-                  <a:srgbClr val="20794D"/>
-                </a:solidFill>
-                <a:latin typeface="Courier"/>
-              </a:rPr>
-              <a:t>"shady"</a:t>
-            </a:r>
-            <a:r>
-              <a:rPr>
-                <a:solidFill>
-                  <a:srgbClr val="003B4F"/>
-                </a:solidFill>
-                <a:latin typeface="Courier"/>
-              </a:rPr>
-              <a:t> = </a:t>
-            </a:r>
-            <a:r>
-              <a:rPr>
-                <a:solidFill>
-                  <a:srgbClr val="20794D"/>
-                </a:solidFill>
-                <a:latin typeface="Courier"/>
-              </a:rPr>
-              <a:t>"forestgreen"</a:t>
-            </a:r>
-            <a:br/>
-            <a:r>
-              <a:rPr>
-                <a:solidFill>
-                  <a:srgbClr val="003B4F"/>
-                </a:solidFill>
-                <a:latin typeface="Courier"/>
-              </a:rPr>
-              <a:t>  )) </a:t>
-            </a:r>
-            <a:r>
-              <a:rPr>
-                <a:solidFill>
-                  <a:srgbClr val="5E5E5E"/>
-                </a:solidFill>
-                <a:latin typeface="Courier"/>
-              </a:rPr>
-              <a:t>+</a:t>
-            </a:r>
-            <a:br/>
-            <a:r>
-              <a:rPr>
-                <a:solidFill>
-                  <a:srgbClr val="003B4F"/>
-                </a:solidFill>
-                <a:latin typeface="Courier"/>
-              </a:rPr>
-              <a:t>  </a:t>
-            </a:r>
-            <a:r>
-              <a:rPr>
-                <a:solidFill>
-                  <a:srgbClr val="4758AB"/>
-                </a:solidFill>
-                <a:latin typeface="Courier"/>
-              </a:rPr>
-              <a:t>labs</a:t>
-            </a:r>
-            <a:r>
-              <a:rPr>
-                <a:solidFill>
-                  <a:srgbClr val="003B4F"/>
-                </a:solidFill>
-                <a:latin typeface="Courier"/>
-              </a:rPr>
-              <a:t>(</a:t>
-            </a:r>
-            <a:br/>
-            <a:r>
-              <a:rPr>
-                <a:solidFill>
-                  <a:srgbClr val="003B4F"/>
-                </a:solidFill>
-                <a:latin typeface="Courier"/>
-              </a:rPr>
-              <a:t>    </a:t>
-            </a:r>
-            <a:r>
-              <a:rPr>
-                <a:solidFill>
-                  <a:srgbClr val="657422"/>
-                </a:solidFill>
-                <a:latin typeface="Courier"/>
-              </a:rPr>
-              <a:t>title =</a:t>
-            </a:r>
-            <a:r>
-              <a:rPr>
-                <a:solidFill>
-                  <a:srgbClr val="003B4F"/>
-                </a:solidFill>
-                <a:latin typeface="Courier"/>
-              </a:rPr>
-              <a:t> </a:t>
-            </a:r>
-            <a:r>
-              <a:rPr>
-                <a:solidFill>
-                  <a:srgbClr val="20794D"/>
-                </a:solidFill>
-                <a:latin typeface="Courier"/>
-              </a:rPr>
-              <a:t>"Leaf Mass by Shade"</a:t>
-            </a:r>
-            <a:r>
-              <a:rPr>
-                <a:solidFill>
-                  <a:srgbClr val="003B4F"/>
-                </a:solidFill>
-                <a:latin typeface="Courier"/>
-              </a:rPr>
-              <a:t>,</a:t>
-            </a:r>
-            <a:br/>
-            <a:r>
-              <a:rPr>
-                <a:solidFill>
-                  <a:srgbClr val="003B4F"/>
-                </a:solidFill>
-                <a:latin typeface="Courier"/>
-              </a:rPr>
-              <a:t>    </a:t>
-            </a:r>
-            <a:r>
-              <a:rPr>
-                <a:solidFill>
-                  <a:srgbClr val="657422"/>
-                </a:solidFill>
-                <a:latin typeface="Courier"/>
-              </a:rPr>
-              <a:t>x =</a:t>
-            </a:r>
-            <a:r>
-              <a:rPr>
-                <a:solidFill>
-                  <a:srgbClr val="003B4F"/>
-                </a:solidFill>
-                <a:latin typeface="Courier"/>
-              </a:rPr>
-              <a:t> </a:t>
-            </a:r>
-            <a:r>
-              <a:rPr>
-                <a:solidFill>
-                  <a:srgbClr val="20794D"/>
-                </a:solidFill>
-                <a:latin typeface="Courier"/>
-              </a:rPr>
-              <a:t>"Shade"</a:t>
-            </a:r>
-            <a:r>
-              <a:rPr>
-                <a:solidFill>
-                  <a:srgbClr val="003B4F"/>
-                </a:solidFill>
-                <a:latin typeface="Courier"/>
-              </a:rPr>
-              <a:t>,</a:t>
-            </a:r>
-            <a:br/>
-            <a:r>
-              <a:rPr>
-                <a:solidFill>
-                  <a:srgbClr val="003B4F"/>
-                </a:solidFill>
-                <a:latin typeface="Courier"/>
-              </a:rPr>
-              <a:t>    </a:t>
-            </a:r>
-            <a:r>
-              <a:rPr>
-                <a:solidFill>
-                  <a:srgbClr val="657422"/>
-                </a:solidFill>
-                <a:latin typeface="Courier"/>
-              </a:rPr>
-              <a:t>y =</a:t>
-            </a:r>
-            <a:r>
-              <a:rPr>
-                <a:solidFill>
-                  <a:srgbClr val="003B4F"/>
-                </a:solidFill>
-                <a:latin typeface="Courier"/>
-              </a:rPr>
-              <a:t> </a:t>
-            </a:r>
-            <a:r>
-              <a:rPr>
-                <a:solidFill>
-                  <a:srgbClr val="20794D"/>
-                </a:solidFill>
-                <a:latin typeface="Courier"/>
-              </a:rPr>
-              <a:t>"Leaf Mass (g)"</a:t>
-            </a:r>
-            <a:r>
-              <a:rPr>
-                <a:solidFill>
-                  <a:srgbClr val="003B4F"/>
-                </a:solidFill>
-                <a:latin typeface="Courier"/>
-              </a:rPr>
-              <a:t>,</a:t>
-            </a:r>
-            <a:br/>
-            <a:r>
-              <a:rPr>
-                <a:solidFill>
-                  <a:srgbClr val="003B4F"/>
-                </a:solidFill>
-                <a:latin typeface="Courier"/>
-              </a:rPr>
-              <a:t>    </a:t>
-            </a:r>
-            <a:r>
-              <a:rPr>
-                <a:solidFill>
-                  <a:srgbClr val="657422"/>
-                </a:solidFill>
-                <a:latin typeface="Courier"/>
-              </a:rPr>
-              <a:t>fill =</a:t>
-            </a:r>
-            <a:r>
-              <a:rPr>
-                <a:solidFill>
-                  <a:srgbClr val="003B4F"/>
-                </a:solidFill>
-                <a:latin typeface="Courier"/>
-              </a:rPr>
-              <a:t> </a:t>
-            </a:r>
-            <a:r>
-              <a:rPr>
-                <a:solidFill>
-                  <a:srgbClr val="20794D"/>
-                </a:solidFill>
-                <a:latin typeface="Courier"/>
-              </a:rPr>
-              <a:t>"Shade"</a:t>
-            </a:r>
-            <a:br/>
-            <a:r>
-              <a:rPr>
-                <a:solidFill>
-                  <a:srgbClr val="003B4F"/>
-                </a:solidFill>
-                <a:latin typeface="Courier"/>
-              </a:rPr>
-              <a:t>  ) </a:t>
-            </a:r>
-            <a:r>
-              <a:rPr>
-                <a:solidFill>
-                  <a:srgbClr val="5E5E5E"/>
-                </a:solidFill>
-                <a:latin typeface="Courier"/>
-              </a:rPr>
-              <a:t>+</a:t>
-            </a:r>
-            <a:br/>
-            <a:r>
-              <a:rPr>
-                <a:solidFill>
-                  <a:srgbClr val="003B4F"/>
-                </a:solidFill>
-                <a:latin typeface="Courier"/>
-              </a:rPr>
-              <a:t>  </a:t>
-            </a:r>
-            <a:r>
-              <a:rPr>
-                <a:solidFill>
-                  <a:srgbClr val="4758AB"/>
-                </a:solidFill>
-                <a:latin typeface="Courier"/>
-              </a:rPr>
-              <a:t>theme_minimal</a:t>
-            </a:r>
-            <a:r>
-              <a:rPr>
-                <a:solidFill>
-                  <a:srgbClr val="003B4F"/>
-                </a:solidFill>
-                <a:latin typeface="Courier"/>
-              </a:rPr>
-              <a:t>() </a:t>
-            </a:r>
-            <a:r>
-              <a:rPr>
-                <a:solidFill>
-                  <a:srgbClr val="5E5E5E"/>
-                </a:solidFill>
-                <a:latin typeface="Courier"/>
-              </a:rPr>
-              <a:t>+</a:t>
-            </a:r>
-            <a:br/>
-            <a:r>
-              <a:rPr>
-                <a:solidFill>
-                  <a:srgbClr val="003B4F"/>
-                </a:solidFill>
-                <a:latin typeface="Courier"/>
-              </a:rPr>
-              <a:t>  </a:t>
-            </a:r>
-            <a:r>
-              <a:rPr>
-                <a:solidFill>
-                  <a:srgbClr val="4758AB"/>
-                </a:solidFill>
-                <a:latin typeface="Courier"/>
-              </a:rPr>
-              <a:t>theme</a:t>
-            </a:r>
-            <a:r>
-              <a:rPr>
-                <a:solidFill>
-                  <a:srgbClr val="003B4F"/>
-                </a:solidFill>
-                <a:latin typeface="Courier"/>
-              </a:rPr>
-              <a:t>(</a:t>
-            </a:r>
-            <a:r>
-              <a:rPr>
-                <a:solidFill>
-                  <a:srgbClr val="657422"/>
-                </a:solidFill>
-                <a:latin typeface="Courier"/>
-              </a:rPr>
-              <a:t>legend.position =</a:t>
-            </a:r>
-            <a:r>
-              <a:rPr>
-                <a:solidFill>
-                  <a:srgbClr val="003B4F"/>
-                </a:solidFill>
-                <a:latin typeface="Courier"/>
-              </a:rPr>
-              <a:t> </a:t>
-            </a:r>
-            <a:r>
-              <a:rPr>
-                <a:solidFill>
-                  <a:srgbClr val="20794D"/>
-                </a:solidFill>
-                <a:latin typeface="Courier"/>
-              </a:rPr>
-              <a:t>"none"</a:t>
-            </a:r>
-            <a:r>
-              <a:rPr>
-                <a:solidFill>
-                  <a:srgbClr val="003B4F"/>
-                </a:solidFill>
-                <a:latin typeface="Courier"/>
-              </a:rPr>
-              <a:t>)</a:t>
-            </a:r>
-          </a:p>
-        </p:txBody>
-      </p:sp>
-      <p:pic>
-        <p:nvPicPr>
-          <p:cNvPr descr="ggplot_1_lecture_files/figure-pptx/scale-manual-demo-1.png" id="0" name="Picture 1"/>
-          <p:cNvPicPr>
-            <a:picLocks noGrp="1" noChangeAspect="1"/>
-          </p:cNvPicPr>
-          <p:nvPr/>
-        </p:nvPicPr>
-        <p:blipFill>
-          <a:blip r:embed="rId2"/>
-          <a:stretch>
-            <a:fillRect/>
-          </a:stretch>
-        </p:blipFill>
-        <p:spPr bwMode="auto">
-          <a:xfrm>
-            <a:off x="127000" y="1562100"/>
-            <a:ext cx="4432300" cy="2730500"/>
-          </a:xfrm>
-          <a:prstGeom prst="rect">
-            <a:avLst/>
-          </a:prstGeom>
-          <a:noFill/>
-          <a:ln w="9525">
-            <a:noFill/>
-            <a:headEnd/>
-            <a:tailEnd/>
-          </a:ln>
-        </p:spPr>
-      </p:pic>
-      <p:sp>
-        <p:nvSpPr>
-          <p:cNvPr id="5" name="Text Placeholder 4"/>
-          <p:cNvSpPr>
-            <a:spLocks noGrp="1"/>
-          </p:cNvSpPr>
-          <p:nvPr>
-            <p:ph idx="3" sz="quarter" type="body"/>
-          </p:nvPr>
-        </p:nvSpPr>
-        <p:spPr/>
-        <p:txBody>
-          <a:bodyPr/>
-          <a:lstStyle/>
-          <a:p>
-            <a:pPr lvl="0"/>
-            <a:r>
-              <a:rPr>
-                <a:latin typeface="Courier"/>
-              </a:rPr>
-              <a:t>scale_fill_manual()</a:t>
-            </a:r>
-            <a:r>
-              <a:rPr/>
-              <a:t> — for </a:t>
-            </a:r>
-            <a:r>
-              <a:rPr>
-                <a:latin typeface="Courier"/>
-              </a:rPr>
-              <a:t>fill =</a:t>
-            </a:r>
-            <a:r>
-              <a:rPr/>
-              <a:t> aesthetics (boxes, bars, columns)</a:t>
-            </a:r>
-          </a:p>
-          <a:p>
-            <a:pPr lvl="0"/>
-            <a:r>
-              <a:rPr>
-                <a:latin typeface="Courier"/>
-              </a:rPr>
-              <a:t>scale_color_manual()</a:t>
-            </a:r>
-            <a:r>
-              <a:rPr/>
-              <a:t> — for </a:t>
-            </a:r>
-            <a:r>
-              <a:rPr>
-                <a:latin typeface="Courier"/>
-              </a:rPr>
-              <a:t>color =</a:t>
-            </a:r>
-            <a:r>
-              <a:rPr/>
-              <a:t> aesthetics (points, lines)</a:t>
-            </a:r>
-          </a:p>
-          <a:p>
-            <a:pPr lvl="0"/>
-            <a:r>
-              <a:rPr/>
-              <a:t>The </a:t>
-            </a:r>
-            <a:r>
-              <a:rPr b="1"/>
-              <a:t>names inside </a:t>
-            </a:r>
-            <a:r>
-              <a:rPr b="1">
-                <a:latin typeface="Courier"/>
-              </a:rPr>
-              <a:t>c()</a:t>
-            </a:r>
-            <a:r>
-              <a:rPr b="1"/>
-              <a:t> must exactly match</a:t>
-            </a:r>
-            <a:r>
-              <a:rPr/>
-              <a:t> the values in your data (</a:t>
-            </a:r>
-            <a:r>
-              <a:rPr>
-                <a:latin typeface="Courier"/>
-              </a:rPr>
-              <a:t>"sunny"</a:t>
-            </a:r>
-            <a:r>
-              <a:rPr/>
-              <a:t>, </a:t>
-            </a:r>
-            <a:r>
-              <a:rPr>
-                <a:latin typeface="Courier"/>
-              </a:rPr>
-              <a:t>"shady"</a:t>
-            </a:r>
-            <a:r>
-              <a:rPr/>
-              <a:t>) — case and spelling both count</a:t>
-            </a:r>
-          </a:p>
-          <a:p>
-            <a:pPr lvl="0" indent="0" marL="1270000">
-              <a:buNone/>
-            </a:pPr>
-            <a:r>
-              <a:rPr sz="2000" b="1"/>
-              <a:t>Warning</a:t>
-            </a:r>
-          </a:p>
-          <a:p>
-            <a:pPr lvl="0" indent="0" marL="1270000">
-              <a:buNone/>
-            </a:pPr>
-            <a:r>
-              <a:rPr sz="2000" b="1"/>
-              <a:t>⚠️ Watch out!</a:t>
-            </a:r>
-          </a:p>
-          <a:p>
-            <a:pPr lvl="0" indent="0" marL="1270000">
-              <a:buNone/>
-            </a:pPr>
-            <a:r>
-              <a:rPr sz="2000"/>
-              <a:t>If a name in </a:t>
-            </a:r>
-            <a:r>
-              <a:rPr sz="2000">
-                <a:latin typeface="Courier"/>
-              </a:rPr>
-              <a:t>values = c(...)</a:t>
-            </a:r>
-            <a:r>
-              <a:rPr sz="2000"/>
-              <a:t> doesn’t match a value in your data exactly, that group’s color falls back to grey and ggplot prints a warning.</a:t>
             </a:r>
           </a:p>
         </p:txBody>

</xml_diff>

<commit_message>
goign to fix the ggplot 2
</commit_message>
<xml_diff>
--- a/docs/content/ggplot_1/ggplot_1_lecture.pptx
+++ b/docs/content/ggplot_1/ggplot_1_lecture.pptx
@@ -25,7 +25,6 @@
     <p:sldId id="273" r:id="rId19"/>
     <p:sldId id="274" r:id="rId20"/>
     <p:sldId id="275" r:id="rId21"/>
-    <p:sldId id="276" r:id="rId22"/>
   </p:sldIdLst>
   <p:sldSz cx="9144000" cy="5143500" type="screen16x9"/>
   <p:notesSz cx="6858000" cy="9144000"/>
@@ -3360,7 +3359,7 @@
             </a:pPr>
             <a:r>
               <a:rPr/>
-              <a:t>2026-09-10</a:t>
+              <a:t>2026-09-14</a:t>
             </a:r>
           </a:p>
         </p:txBody>
@@ -3389,12 +3388,42 @@
       </p:grpSpPr>
       <p:sp>
         <p:nvSpPr>
-          <p:cNvPr id="3" name="Text Placeholder 2"/>
+          <p:cNvPr id="2" name="Title 1"/>
           <p:cNvSpPr>
             <a:spLocks noGrp="1"/>
           </p:cNvSpPr>
           <p:nvPr>
-            <p:ph idx="1" type="body"/>
+            <p:ph type="title"/>
+          </p:nvPr>
+        </p:nvSpPr>
+        <p:spPr>
+          <a:xfrm>
+            <a:off x="0" y="0"/>
+            <a:ext cx="9144000" cy="582780"/>
+          </a:xfrm>
+        </p:spPr>
+        <p:txBody>
+          <a:bodyPr/>
+          <a:lstStyle/>
+          <a:p>
+            <a:pPr lvl="0" indent="0" marL="0">
+              <a:buNone/>
+            </a:pPr>
+            <a:r>
+              <a:rPr/>
+              <a:t>→ ACTIVITY 3 Parts 1–2 now</a:t>
+            </a:r>
+          </a:p>
+        </p:txBody>
+      </p:sp>
+      <p:sp>
+        <p:nvSpPr>
+          <p:cNvPr id="3" name="Content Placeholder 2"/>
+          <p:cNvSpPr>
+            <a:spLocks noGrp="1"/>
+          </p:cNvSpPr>
+          <p:nvPr>
+            <p:ph idx="1"/>
           </p:nvPr>
         </p:nvSpPr>
         <p:spPr/>
@@ -3402,884 +3431,32 @@
           <a:bodyPr/>
           <a:lstStyle/>
           <a:p>
-            <a:pPr lvl="0" indent="0">
+            <a:pPr lvl="0" indent="0" marL="0">
               <a:buNone/>
             </a:pPr>
             <a:r>
-              <a:rPr>
-                <a:solidFill>
-                  <a:srgbClr val="5E5E5E"/>
-                </a:solidFill>
-                <a:latin typeface="Courier"/>
-              </a:rPr>
-              <a:t># scale_fill_manual() assigns exact colors to exact groups</a:t>
-            </a:r>
-            <a:br/>
-            <a:r>
-              <a:rPr>
-                <a:solidFill>
-                  <a:srgbClr val="003B4F"/>
-                </a:solidFill>
-                <a:latin typeface="Courier"/>
-              </a:rPr>
-              <a:t>leaf_df </a:t>
-            </a:r>
-            <a:r>
-              <a:rPr>
-                <a:solidFill>
-                  <a:srgbClr val="5E5E5E"/>
-                </a:solidFill>
-                <a:latin typeface="Courier"/>
-              </a:rPr>
-              <a:t>%&gt;%</a:t>
-            </a:r>
-            <a:br/>
-            <a:r>
-              <a:rPr>
-                <a:solidFill>
-                  <a:srgbClr val="003B4F"/>
-                </a:solidFill>
-                <a:latin typeface="Courier"/>
-              </a:rPr>
-              <a:t>  </a:t>
-            </a:r>
-            <a:r>
-              <a:rPr>
-                <a:solidFill>
-                  <a:srgbClr val="4758AB"/>
-                </a:solidFill>
-                <a:latin typeface="Courier"/>
-              </a:rPr>
-              <a:t>ggplot</a:t>
-            </a:r>
-            <a:r>
-              <a:rPr>
-                <a:solidFill>
-                  <a:srgbClr val="003B4F"/>
-                </a:solidFill>
-                <a:latin typeface="Courier"/>
-              </a:rPr>
-              <a:t>(</a:t>
-            </a:r>
-            <a:r>
-              <a:rPr>
-                <a:solidFill>
-                  <a:srgbClr val="4758AB"/>
-                </a:solidFill>
-                <a:latin typeface="Courier"/>
-              </a:rPr>
-              <a:t>aes</a:t>
-            </a:r>
-            <a:r>
-              <a:rPr>
-                <a:solidFill>
-                  <a:srgbClr val="003B4F"/>
-                </a:solidFill>
-                <a:latin typeface="Courier"/>
-              </a:rPr>
-              <a:t>(</a:t>
-            </a:r>
-            <a:r>
-              <a:rPr>
-                <a:solidFill>
-                  <a:srgbClr val="657422"/>
-                </a:solidFill>
-                <a:latin typeface="Courier"/>
-              </a:rPr>
-              <a:t>x =</a:t>
-            </a:r>
-            <a:r>
-              <a:rPr>
-                <a:solidFill>
-                  <a:srgbClr val="003B4F"/>
-                </a:solidFill>
-                <a:latin typeface="Courier"/>
-              </a:rPr>
-              <a:t> shade, </a:t>
-            </a:r>
-            <a:r>
-              <a:rPr>
-                <a:solidFill>
-                  <a:srgbClr val="657422"/>
-                </a:solidFill>
-                <a:latin typeface="Courier"/>
-              </a:rPr>
-              <a:t>y =</a:t>
-            </a:r>
-            <a:r>
-              <a:rPr>
-                <a:solidFill>
-                  <a:srgbClr val="003B4F"/>
-                </a:solidFill>
-                <a:latin typeface="Courier"/>
-              </a:rPr>
-              <a:t> mass_g, </a:t>
-            </a:r>
-            <a:r>
-              <a:rPr>
-                <a:solidFill>
-                  <a:srgbClr val="657422"/>
-                </a:solidFill>
-                <a:latin typeface="Courier"/>
-              </a:rPr>
-              <a:t>fill =</a:t>
-            </a:r>
-            <a:r>
-              <a:rPr>
-                <a:solidFill>
-                  <a:srgbClr val="003B4F"/>
-                </a:solidFill>
-                <a:latin typeface="Courier"/>
-              </a:rPr>
-              <a:t> shade)) </a:t>
-            </a:r>
-            <a:r>
-              <a:rPr>
-                <a:solidFill>
-                  <a:srgbClr val="5E5E5E"/>
-                </a:solidFill>
-                <a:latin typeface="Courier"/>
-              </a:rPr>
-              <a:t>+</a:t>
-            </a:r>
-            <a:br/>
-            <a:r>
-              <a:rPr>
-                <a:solidFill>
-                  <a:srgbClr val="003B4F"/>
-                </a:solidFill>
-                <a:latin typeface="Courier"/>
-              </a:rPr>
-              <a:t>  </a:t>
-            </a:r>
-            <a:r>
-              <a:rPr>
-                <a:solidFill>
-                  <a:srgbClr val="4758AB"/>
-                </a:solidFill>
-                <a:latin typeface="Courier"/>
-              </a:rPr>
-              <a:t>geom_boxplot</a:t>
-            </a:r>
-            <a:r>
-              <a:rPr>
-                <a:solidFill>
-                  <a:srgbClr val="003B4F"/>
-                </a:solidFill>
-                <a:latin typeface="Courier"/>
-              </a:rPr>
-              <a:t>(</a:t>
-            </a:r>
-            <a:r>
-              <a:rPr>
-                <a:solidFill>
-                  <a:srgbClr val="657422"/>
-                </a:solidFill>
-                <a:latin typeface="Courier"/>
-              </a:rPr>
-              <a:t>alpha =</a:t>
-            </a:r>
-            <a:r>
-              <a:rPr>
-                <a:solidFill>
-                  <a:srgbClr val="003B4F"/>
-                </a:solidFill>
-                <a:latin typeface="Courier"/>
-              </a:rPr>
-              <a:t> </a:t>
-            </a:r>
-            <a:r>
-              <a:rPr>
-                <a:solidFill>
-                  <a:srgbClr val="AD0000"/>
-                </a:solidFill>
-                <a:latin typeface="Courier"/>
-              </a:rPr>
-              <a:t>0.6</a:t>
-            </a:r>
-            <a:r>
-              <a:rPr>
-                <a:solidFill>
-                  <a:srgbClr val="003B4F"/>
-                </a:solidFill>
-                <a:latin typeface="Courier"/>
-              </a:rPr>
-              <a:t>, </a:t>
-            </a:r>
-            <a:r>
-              <a:rPr>
-                <a:solidFill>
-                  <a:srgbClr val="657422"/>
-                </a:solidFill>
-                <a:latin typeface="Courier"/>
-              </a:rPr>
-              <a:t>outlier.shape =</a:t>
-            </a:r>
-            <a:r>
-              <a:rPr>
-                <a:solidFill>
-                  <a:srgbClr val="003B4F"/>
-                </a:solidFill>
-                <a:latin typeface="Courier"/>
-              </a:rPr>
-              <a:t> </a:t>
-            </a:r>
-            <a:r>
-              <a:rPr>
-                <a:solidFill>
-                  <a:srgbClr val="8F5902"/>
-                </a:solidFill>
-                <a:latin typeface="Courier"/>
-              </a:rPr>
-              <a:t>NA</a:t>
-            </a:r>
-            <a:r>
-              <a:rPr>
-                <a:solidFill>
-                  <a:srgbClr val="003B4F"/>
-                </a:solidFill>
-                <a:latin typeface="Courier"/>
-              </a:rPr>
-              <a:t>) </a:t>
-            </a:r>
-            <a:r>
-              <a:rPr>
-                <a:solidFill>
-                  <a:srgbClr val="5E5E5E"/>
-                </a:solidFill>
-                <a:latin typeface="Courier"/>
-              </a:rPr>
-              <a:t>+</a:t>
-            </a:r>
-            <a:br/>
-            <a:r>
-              <a:rPr>
-                <a:solidFill>
-                  <a:srgbClr val="003B4F"/>
-                </a:solidFill>
-                <a:latin typeface="Courier"/>
-              </a:rPr>
-              <a:t>  </a:t>
-            </a:r>
-            <a:r>
-              <a:rPr>
-                <a:solidFill>
-                  <a:srgbClr val="4758AB"/>
-                </a:solidFill>
-                <a:latin typeface="Courier"/>
-              </a:rPr>
-              <a:t>geom_point</a:t>
-            </a:r>
-            <a:r>
-              <a:rPr>
-                <a:solidFill>
-                  <a:srgbClr val="003B4F"/>
-                </a:solidFill>
-                <a:latin typeface="Courier"/>
-              </a:rPr>
-              <a:t>(</a:t>
-            </a:r>
-            <a:r>
-              <a:rPr>
-                <a:solidFill>
-                  <a:srgbClr val="657422"/>
-                </a:solidFill>
-                <a:latin typeface="Courier"/>
-              </a:rPr>
-              <a:t>position =</a:t>
-            </a:r>
-            <a:r>
-              <a:rPr>
-                <a:solidFill>
-                  <a:srgbClr val="003B4F"/>
-                </a:solidFill>
-                <a:latin typeface="Courier"/>
-              </a:rPr>
-              <a:t> jitter_pos, </a:t>
-            </a:r>
-            <a:r>
-              <a:rPr>
-                <a:solidFill>
-                  <a:srgbClr val="657422"/>
-                </a:solidFill>
-                <a:latin typeface="Courier"/>
-              </a:rPr>
-              <a:t>alpha =</a:t>
-            </a:r>
-            <a:r>
-              <a:rPr>
-                <a:solidFill>
-                  <a:srgbClr val="003B4F"/>
-                </a:solidFill>
-                <a:latin typeface="Courier"/>
-              </a:rPr>
-              <a:t> </a:t>
-            </a:r>
-            <a:r>
-              <a:rPr>
-                <a:solidFill>
-                  <a:srgbClr val="AD0000"/>
-                </a:solidFill>
-                <a:latin typeface="Courier"/>
-              </a:rPr>
-              <a:t>0.6</a:t>
-            </a:r>
-            <a:r>
-              <a:rPr>
-                <a:solidFill>
-                  <a:srgbClr val="003B4F"/>
-                </a:solidFill>
-                <a:latin typeface="Courier"/>
-              </a:rPr>
-              <a:t>) </a:t>
-            </a:r>
-            <a:r>
-              <a:rPr>
-                <a:solidFill>
-                  <a:srgbClr val="5E5E5E"/>
-                </a:solidFill>
-                <a:latin typeface="Courier"/>
-              </a:rPr>
-              <a:t>+</a:t>
-            </a:r>
-            <a:br/>
-            <a:r>
-              <a:rPr>
-                <a:solidFill>
-                  <a:srgbClr val="003B4F"/>
-                </a:solidFill>
-                <a:latin typeface="Courier"/>
-              </a:rPr>
-              <a:t>  </a:t>
-            </a:r>
-            <a:r>
-              <a:rPr>
-                <a:solidFill>
-                  <a:srgbClr val="4758AB"/>
-                </a:solidFill>
-                <a:latin typeface="Courier"/>
-              </a:rPr>
-              <a:t>scale_fill_manual</a:t>
-            </a:r>
-            <a:r>
-              <a:rPr>
-                <a:solidFill>
-                  <a:srgbClr val="003B4F"/>
-                </a:solidFill>
-                <a:latin typeface="Courier"/>
-              </a:rPr>
-              <a:t>(</a:t>
-            </a:r>
-            <a:r>
-              <a:rPr>
-                <a:solidFill>
-                  <a:srgbClr val="657422"/>
-                </a:solidFill>
-                <a:latin typeface="Courier"/>
-              </a:rPr>
-              <a:t>values =</a:t>
-            </a:r>
-            <a:r>
-              <a:rPr>
-                <a:solidFill>
-                  <a:srgbClr val="003B4F"/>
-                </a:solidFill>
-                <a:latin typeface="Courier"/>
-              </a:rPr>
-              <a:t> </a:t>
-            </a:r>
-            <a:r>
-              <a:rPr>
-                <a:solidFill>
-                  <a:srgbClr val="4758AB"/>
-                </a:solidFill>
-                <a:latin typeface="Courier"/>
-              </a:rPr>
-              <a:t>c</a:t>
-            </a:r>
-            <a:r>
-              <a:rPr>
-                <a:solidFill>
-                  <a:srgbClr val="003B4F"/>
-                </a:solidFill>
-                <a:latin typeface="Courier"/>
-              </a:rPr>
-              <a:t>(</a:t>
-            </a:r>
-            <a:br/>
-            <a:r>
-              <a:rPr>
-                <a:solidFill>
-                  <a:srgbClr val="003B4F"/>
-                </a:solidFill>
-                <a:latin typeface="Courier"/>
-              </a:rPr>
-              <a:t>    </a:t>
-            </a:r>
-            <a:r>
-              <a:rPr>
-                <a:solidFill>
-                  <a:srgbClr val="20794D"/>
-                </a:solidFill>
-                <a:latin typeface="Courier"/>
-              </a:rPr>
-              <a:t>"sunny"</a:t>
-            </a:r>
-            <a:r>
-              <a:rPr>
-                <a:solidFill>
-                  <a:srgbClr val="003B4F"/>
-                </a:solidFill>
-                <a:latin typeface="Courier"/>
-              </a:rPr>
-              <a:t> = </a:t>
-            </a:r>
-            <a:r>
-              <a:rPr>
-                <a:solidFill>
-                  <a:srgbClr val="20794D"/>
-                </a:solidFill>
-                <a:latin typeface="Courier"/>
-              </a:rPr>
-              <a:t>"goldenrod"</a:t>
-            </a:r>
-            <a:r>
-              <a:rPr>
-                <a:solidFill>
-                  <a:srgbClr val="003B4F"/>
-                </a:solidFill>
-                <a:latin typeface="Courier"/>
-              </a:rPr>
-              <a:t>,</a:t>
-            </a:r>
-            <a:br/>
-            <a:r>
-              <a:rPr>
-                <a:solidFill>
-                  <a:srgbClr val="003B4F"/>
-                </a:solidFill>
-                <a:latin typeface="Courier"/>
-              </a:rPr>
-              <a:t>    </a:t>
-            </a:r>
-            <a:r>
-              <a:rPr>
-                <a:solidFill>
-                  <a:srgbClr val="20794D"/>
-                </a:solidFill>
-                <a:latin typeface="Courier"/>
-              </a:rPr>
-              <a:t>"shady"</a:t>
-            </a:r>
-            <a:r>
-              <a:rPr>
-                <a:solidFill>
-                  <a:srgbClr val="003B4F"/>
-                </a:solidFill>
-                <a:latin typeface="Courier"/>
-              </a:rPr>
-              <a:t> = </a:t>
-            </a:r>
-            <a:r>
-              <a:rPr>
-                <a:solidFill>
-                  <a:srgbClr val="20794D"/>
-                </a:solidFill>
-                <a:latin typeface="Courier"/>
-              </a:rPr>
-              <a:t>"forestgreen"</a:t>
-            </a:r>
-            <a:br/>
-            <a:r>
-              <a:rPr>
-                <a:solidFill>
-                  <a:srgbClr val="003B4F"/>
-                </a:solidFill>
-                <a:latin typeface="Courier"/>
-              </a:rPr>
-              <a:t>  )) </a:t>
-            </a:r>
-            <a:r>
-              <a:rPr>
-                <a:solidFill>
-                  <a:srgbClr val="5E5E5E"/>
-                </a:solidFill>
-                <a:latin typeface="Courier"/>
-              </a:rPr>
-              <a:t>+</a:t>
-            </a:r>
-            <a:br/>
-            <a:r>
-              <a:rPr>
-                <a:solidFill>
-                  <a:srgbClr val="003B4F"/>
-                </a:solidFill>
-                <a:latin typeface="Courier"/>
-              </a:rPr>
-              <a:t>  </a:t>
-            </a:r>
-            <a:r>
-              <a:rPr>
-                <a:solidFill>
-                  <a:srgbClr val="4758AB"/>
-                </a:solidFill>
-                <a:latin typeface="Courier"/>
-              </a:rPr>
-              <a:t>labs</a:t>
-            </a:r>
-            <a:r>
-              <a:rPr>
-                <a:solidFill>
-                  <a:srgbClr val="003B4F"/>
-                </a:solidFill>
-                <a:latin typeface="Courier"/>
-              </a:rPr>
-              <a:t>(</a:t>
-            </a:r>
-            <a:br/>
-            <a:r>
-              <a:rPr>
-                <a:solidFill>
-                  <a:srgbClr val="003B4F"/>
-                </a:solidFill>
-                <a:latin typeface="Courier"/>
-              </a:rPr>
-              <a:t>    </a:t>
-            </a:r>
-            <a:r>
-              <a:rPr>
-                <a:solidFill>
-                  <a:srgbClr val="657422"/>
-                </a:solidFill>
-                <a:latin typeface="Courier"/>
-              </a:rPr>
-              <a:t>title =</a:t>
-            </a:r>
-            <a:r>
-              <a:rPr>
-                <a:solidFill>
-                  <a:srgbClr val="003B4F"/>
-                </a:solidFill>
-                <a:latin typeface="Courier"/>
-              </a:rPr>
-              <a:t> </a:t>
-            </a:r>
-            <a:r>
-              <a:rPr>
-                <a:solidFill>
-                  <a:srgbClr val="20794D"/>
-                </a:solidFill>
-                <a:latin typeface="Courier"/>
-              </a:rPr>
-              <a:t>"Leaf Mass by Shade"</a:t>
-            </a:r>
-            <a:r>
-              <a:rPr>
-                <a:solidFill>
-                  <a:srgbClr val="003B4F"/>
-                </a:solidFill>
-                <a:latin typeface="Courier"/>
-              </a:rPr>
-              <a:t>,</a:t>
-            </a:r>
-            <a:br/>
-            <a:r>
-              <a:rPr>
-                <a:solidFill>
-                  <a:srgbClr val="003B4F"/>
-                </a:solidFill>
-                <a:latin typeface="Courier"/>
-              </a:rPr>
-              <a:t>    </a:t>
-            </a:r>
-            <a:r>
-              <a:rPr>
-                <a:solidFill>
-                  <a:srgbClr val="657422"/>
-                </a:solidFill>
-                <a:latin typeface="Courier"/>
-              </a:rPr>
-              <a:t>x =</a:t>
-            </a:r>
-            <a:r>
-              <a:rPr>
-                <a:solidFill>
-                  <a:srgbClr val="003B4F"/>
-                </a:solidFill>
-                <a:latin typeface="Courier"/>
-              </a:rPr>
-              <a:t> </a:t>
-            </a:r>
-            <a:r>
-              <a:rPr>
-                <a:solidFill>
-                  <a:srgbClr val="20794D"/>
-                </a:solidFill>
-                <a:latin typeface="Courier"/>
-              </a:rPr>
-              <a:t>"Shade"</a:t>
-            </a:r>
-            <a:r>
-              <a:rPr>
-                <a:solidFill>
-                  <a:srgbClr val="003B4F"/>
-                </a:solidFill>
-                <a:latin typeface="Courier"/>
-              </a:rPr>
-              <a:t>,</a:t>
-            </a:r>
-            <a:br/>
-            <a:r>
-              <a:rPr>
-                <a:solidFill>
-                  <a:srgbClr val="003B4F"/>
-                </a:solidFill>
-                <a:latin typeface="Courier"/>
-              </a:rPr>
-              <a:t>    </a:t>
-            </a:r>
-            <a:r>
-              <a:rPr>
-                <a:solidFill>
-                  <a:srgbClr val="657422"/>
-                </a:solidFill>
-                <a:latin typeface="Courier"/>
-              </a:rPr>
-              <a:t>y =</a:t>
-            </a:r>
-            <a:r>
-              <a:rPr>
-                <a:solidFill>
-                  <a:srgbClr val="003B4F"/>
-                </a:solidFill>
-                <a:latin typeface="Courier"/>
-              </a:rPr>
-              <a:t> </a:t>
-            </a:r>
-            <a:r>
-              <a:rPr>
-                <a:solidFill>
-                  <a:srgbClr val="20794D"/>
-                </a:solidFill>
-                <a:latin typeface="Courier"/>
-              </a:rPr>
-              <a:t>"Leaf Mass (g)"</a:t>
-            </a:r>
-            <a:r>
-              <a:rPr>
-                <a:solidFill>
-                  <a:srgbClr val="003B4F"/>
-                </a:solidFill>
-                <a:latin typeface="Courier"/>
-              </a:rPr>
-              <a:t>,</a:t>
-            </a:r>
-            <a:br/>
-            <a:r>
-              <a:rPr>
-                <a:solidFill>
-                  <a:srgbClr val="003B4F"/>
-                </a:solidFill>
-                <a:latin typeface="Courier"/>
-              </a:rPr>
-              <a:t>    </a:t>
-            </a:r>
-            <a:r>
-              <a:rPr>
-                <a:solidFill>
-                  <a:srgbClr val="657422"/>
-                </a:solidFill>
-                <a:latin typeface="Courier"/>
-              </a:rPr>
-              <a:t>fill =</a:t>
-            </a:r>
-            <a:r>
-              <a:rPr>
-                <a:solidFill>
-                  <a:srgbClr val="003B4F"/>
-                </a:solidFill>
-                <a:latin typeface="Courier"/>
-              </a:rPr>
-              <a:t> </a:t>
-            </a:r>
-            <a:r>
-              <a:rPr>
-                <a:solidFill>
-                  <a:srgbClr val="20794D"/>
-                </a:solidFill>
-                <a:latin typeface="Courier"/>
-              </a:rPr>
-              <a:t>"Shade"</a:t>
-            </a:r>
-            <a:br/>
-            <a:r>
-              <a:rPr>
-                <a:solidFill>
-                  <a:srgbClr val="003B4F"/>
-                </a:solidFill>
-                <a:latin typeface="Courier"/>
-              </a:rPr>
-              <a:t>  ) </a:t>
-            </a:r>
-            <a:r>
-              <a:rPr>
-                <a:solidFill>
-                  <a:srgbClr val="5E5E5E"/>
-                </a:solidFill>
-                <a:latin typeface="Courier"/>
-              </a:rPr>
-              <a:t>+</a:t>
-            </a:r>
-            <a:br/>
-            <a:r>
-              <a:rPr>
-                <a:solidFill>
-                  <a:srgbClr val="003B4F"/>
-                </a:solidFill>
-                <a:latin typeface="Courier"/>
-              </a:rPr>
-              <a:t>  </a:t>
-            </a:r>
-            <a:r>
-              <a:rPr>
-                <a:solidFill>
-                  <a:srgbClr val="4758AB"/>
-                </a:solidFill>
-                <a:latin typeface="Courier"/>
-              </a:rPr>
-              <a:t>theme_minimal</a:t>
-            </a:r>
-            <a:r>
-              <a:rPr>
-                <a:solidFill>
-                  <a:srgbClr val="003B4F"/>
-                </a:solidFill>
-                <a:latin typeface="Courier"/>
-              </a:rPr>
-              <a:t>() </a:t>
-            </a:r>
-            <a:r>
-              <a:rPr>
-                <a:solidFill>
-                  <a:srgbClr val="5E5E5E"/>
-                </a:solidFill>
-                <a:latin typeface="Courier"/>
-              </a:rPr>
-              <a:t>+</a:t>
-            </a:r>
-            <a:br/>
-            <a:r>
-              <a:rPr>
-                <a:solidFill>
-                  <a:srgbClr val="003B4F"/>
-                </a:solidFill>
-                <a:latin typeface="Courier"/>
-              </a:rPr>
-              <a:t>  </a:t>
-            </a:r>
-            <a:r>
-              <a:rPr>
-                <a:solidFill>
-                  <a:srgbClr val="4758AB"/>
-                </a:solidFill>
-                <a:latin typeface="Courier"/>
-              </a:rPr>
-              <a:t>theme</a:t>
-            </a:r>
-            <a:r>
-              <a:rPr>
-                <a:solidFill>
-                  <a:srgbClr val="003B4F"/>
-                </a:solidFill>
-                <a:latin typeface="Courier"/>
-              </a:rPr>
-              <a:t>(</a:t>
-            </a:r>
-            <a:r>
-              <a:rPr>
-                <a:solidFill>
-                  <a:srgbClr val="657422"/>
-                </a:solidFill>
-                <a:latin typeface="Courier"/>
-              </a:rPr>
-              <a:t>legend.position =</a:t>
-            </a:r>
-            <a:r>
-              <a:rPr>
-                <a:solidFill>
-                  <a:srgbClr val="003B4F"/>
-                </a:solidFill>
-                <a:latin typeface="Courier"/>
-              </a:rPr>
-              <a:t> </a:t>
-            </a:r>
-            <a:r>
-              <a:rPr>
-                <a:solidFill>
-                  <a:srgbClr val="20794D"/>
-                </a:solidFill>
-                <a:latin typeface="Courier"/>
-              </a:rPr>
-              <a:t>"none"</a:t>
-            </a:r>
-            <a:r>
-              <a:rPr>
-                <a:solidFill>
-                  <a:srgbClr val="003B4F"/>
-                </a:solidFill>
-                <a:latin typeface="Courier"/>
-              </a:rPr>
-              <a:t>)</a:t>
-            </a:r>
-          </a:p>
-        </p:txBody>
-      </p:sp>
-      <p:pic>
-        <p:nvPicPr>
-          <p:cNvPr descr="ggplot_1_lecture_files/figure-pptx/scale-manual-demo-1.png" id="0" name="Picture 1"/>
-          <p:cNvPicPr>
-            <a:picLocks noGrp="1" noChangeAspect="1"/>
-          </p:cNvPicPr>
-          <p:nvPr/>
-        </p:nvPicPr>
-        <p:blipFill>
-          <a:blip r:embed="rId2"/>
-          <a:stretch>
-            <a:fillRect/>
-          </a:stretch>
-        </p:blipFill>
-        <p:spPr bwMode="auto">
-          <a:xfrm>
-            <a:off x="127000" y="1562100"/>
-            <a:ext cx="4432300" cy="2730500"/>
-          </a:xfrm>
-          <a:prstGeom prst="rect">
-            <a:avLst/>
-          </a:prstGeom>
-          <a:noFill/>
-          <a:ln w="9525">
-            <a:noFill/>
-            <a:headEnd/>
-            <a:tailEnd/>
-          </a:ln>
-        </p:spPr>
-      </p:pic>
-      <p:sp>
-        <p:nvSpPr>
-          <p:cNvPr id="5" name="Text Placeholder 4"/>
-          <p:cNvSpPr>
-            <a:spLocks noGrp="1"/>
-          </p:cNvSpPr>
-          <p:nvPr>
-            <p:ph idx="3" sz="quarter" type="body"/>
-          </p:nvPr>
-        </p:nvSpPr>
-        <p:spPr/>
-        <p:txBody>
-          <a:bodyPr/>
-          <a:lstStyle/>
-          <a:p>
-            <a:pPr lvl="0"/>
+              <a:rPr b="1"/>
+              <a:t>🛑 Do Activity Parts 1–2 now</a:t>
+            </a:r>
+          </a:p>
+          <a:p>
+            <a:pPr lvl="0" indent="0" marL="0">
+              <a:buNone/>
+            </a:pPr>
+            <a:r>
+              <a:rPr/>
+              <a:t>Pipe into </a:t>
+            </a:r>
+            <a:r>
+              <a:rPr>
+                <a:latin typeface="Courier"/>
+              </a:rPr>
+              <a:t>ggplot()</a:t>
+            </a:r>
+            <a:r>
+              <a:rPr/>
+              <a:t>, then assign sunny/shady their own colors with </a:t>
+            </a:r>
             <a:r>
               <a:rPr>
                 <a:latin typeface="Courier"/>
@@ -4288,122 +3465,7 @@
             </a:r>
             <a:r>
               <a:rPr/>
-              <a:t> — for </a:t>
-            </a:r>
-            <a:r>
-              <a:rPr>
-                <a:latin typeface="Courier"/>
-              </a:rPr>
-              <a:t>fill =</a:t>
-            </a:r>
-            <a:r>
-              <a:rPr/>
-              <a:t> aesthetics (boxes, bars, columns)</a:t>
-            </a:r>
-          </a:p>
-          <a:p>
-            <a:pPr lvl="0"/>
-            <a:r>
-              <a:rPr>
-                <a:latin typeface="Courier"/>
-              </a:rPr>
-              <a:t>scale_color_manual()</a:t>
-            </a:r>
-            <a:r>
-              <a:rPr/>
-              <a:t> — for </a:t>
-            </a:r>
-            <a:r>
-              <a:rPr>
-                <a:latin typeface="Courier"/>
-              </a:rPr>
-              <a:t>color =</a:t>
-            </a:r>
-            <a:r>
-              <a:rPr/>
-              <a:t> aesthetics (points, lines)</a:t>
-            </a:r>
-          </a:p>
-          <a:p>
-            <a:pPr lvl="0"/>
-            <a:r>
-              <a:rPr/>
-              <a:t>The </a:t>
-            </a:r>
-            <a:r>
-              <a:rPr b="1"/>
-              <a:t>names inside </a:t>
-            </a:r>
-            <a:r>
-              <a:rPr b="1">
-                <a:latin typeface="Courier"/>
-              </a:rPr>
-              <a:t>c()</a:t>
-            </a:r>
-            <a:r>
-              <a:rPr b="1"/>
-              <a:t> must exactly match</a:t>
-            </a:r>
-            <a:r>
-              <a:rPr/>
-              <a:t> the values in your data (</a:t>
-            </a:r>
-            <a:r>
-              <a:rPr>
-                <a:latin typeface="Courier"/>
-              </a:rPr>
-              <a:t>"sunny"</a:t>
-            </a:r>
-            <a:r>
-              <a:rPr/>
-              <a:t>, </a:t>
-            </a:r>
-            <a:r>
-              <a:rPr>
-                <a:latin typeface="Courier"/>
-              </a:rPr>
-              <a:t>"shady"</a:t>
-            </a:r>
-            <a:r>
-              <a:rPr/>
-              <a:t>) — case and spelling both count</a:t>
-            </a:r>
-          </a:p>
-          <a:p>
-            <a:pPr lvl="0" indent="0" marL="1270000">
-              <a:buNone/>
-            </a:pPr>
-            <a:r>
-              <a:rPr sz="2000" b="1"/>
-              <a:t>Warning</a:t>
-            </a:r>
-          </a:p>
-          <a:p>
-            <a:pPr lvl="0" indent="0" marL="1270000">
-              <a:buNone/>
-            </a:pPr>
-            <a:r>
-              <a:rPr sz="2000" b="1"/>
-              <a:t>⚠️ Watch out!</a:t>
-            </a:r>
-          </a:p>
-          <a:p>
-            <a:pPr lvl="0" indent="0" marL="1270000">
-              <a:buNone/>
-            </a:pPr>
-            <a:r>
-              <a:rPr sz="2000"/>
-              <a:t>If a name in </a:t>
-            </a:r>
-            <a:r>
-              <a:rPr sz="2000">
-                <a:latin typeface="Courier"/>
-              </a:rPr>
-              <a:t>values = c(...)</a:t>
-            </a:r>
-            <a:r>
-              <a:rPr sz="2000"/>
-              <a:t> doesn’t match a value in your data exactly, that group’s color falls back to grey and ggplot prints a warning.</a:t>
+              <a:t>. Predict, type, run.</a:t>
             </a:r>
           </a:p>
         </p:txBody>
@@ -4455,7 +3517,7 @@
             </a:pPr>
             <a:r>
               <a:rPr/>
-              <a:t>→ ACTIVITY 3 Parts 1–2 now</a:t>
+              <a:t>🧩 Chunk 2 of 3 · Small Multiples with Facets</a:t>
             </a:r>
           </a:p>
         </p:txBody>
@@ -4480,7 +3542,31 @@
             </a:pPr>
             <a:r>
               <a:rPr b="1"/>
-              <a:t>🛑 Do Activity Parts 1–2 now</a:t>
+              <a:t>We will cover:</a:t>
+            </a:r>
+            <a:r>
+              <a:rPr/>
+              <a:t> </a:t>
+            </a:r>
+            <a:r>
+              <a:rPr>
+                <a:latin typeface="Courier"/>
+              </a:rPr>
+              <a:t>facet_wrap()</a:t>
+            </a:r>
+            <a:r>
+              <a:rPr/>
+              <a:t> and </a:t>
+            </a:r>
+            <a:r>
+              <a:rPr>
+                <a:latin typeface="Courier"/>
+              </a:rPr>
+              <a:t>facet_grid()</a:t>
+            </a:r>
+            <a:r>
+              <a:rPr/>
+              <a:t> — splitting one plot into a panel per group.</a:t>
             </a:r>
           </a:p>
           <a:p>
@@ -4488,28 +3574,8 @@
               <a:buNone/>
             </a:pPr>
             <a:r>
-              <a:rPr/>
-              <a:t>Pipe into </a:t>
-            </a:r>
-            <a:r>
-              <a:rPr>
-                <a:latin typeface="Courier"/>
-              </a:rPr>
-              <a:t>ggplot()</a:t>
-            </a:r>
-            <a:r>
-              <a:rPr/>
-              <a:t>, then assign sunny/shady their own colors with </a:t>
-            </a:r>
-            <a:r>
-              <a:rPr>
-                <a:latin typeface="Courier"/>
-              </a:rPr>
-              <a:t>scale_fill_manual()</a:t>
-            </a:r>
-            <a:r>
-              <a:rPr/>
-              <a:t>. Predict, type, run.</a:t>
+              <a:rPr b="1"/>
+              <a:t>🛑 After this chunk you will do Activity Part 3.</a:t>
             </a:r>
           </a:p>
         </p:txBody>
@@ -4520,116 +3586,6 @@
 </file>
 
 <file path=ppt/slides/slide12.xml><?xml version="1.0" encoding="utf-8"?>
-<p:sld xmlns:a="http://schemas.openxmlformats.org/drawingml/2006/main" xmlns:r="http://schemas.openxmlformats.org/officeDocument/2006/relationships" xmlns:p="http://schemas.openxmlformats.org/presentationml/2006/main">
-  <p:cSld>
-    <p:spTree>
-      <p:nvGrpSpPr>
-        <p:cNvPr id="1" name=""/>
-        <p:cNvGrpSpPr/>
-        <p:nvPr/>
-      </p:nvGrpSpPr>
-      <p:grpSpPr>
-        <a:xfrm>
-          <a:off x="0" y="0"/>
-          <a:ext cx="0" cy="0"/>
-          <a:chOff x="0" y="0"/>
-          <a:chExt cx="0" cy="0"/>
-        </a:xfrm>
-      </p:grpSpPr>
-      <p:sp>
-        <p:nvSpPr>
-          <p:cNvPr id="2" name="Title 1"/>
-          <p:cNvSpPr>
-            <a:spLocks noGrp="1"/>
-          </p:cNvSpPr>
-          <p:nvPr>
-            <p:ph type="title"/>
-          </p:nvPr>
-        </p:nvSpPr>
-        <p:spPr>
-          <a:xfrm>
-            <a:off x="0" y="0"/>
-            <a:ext cx="9144000" cy="582780"/>
-          </a:xfrm>
-        </p:spPr>
-        <p:txBody>
-          <a:bodyPr/>
-          <a:lstStyle/>
-          <a:p>
-            <a:pPr lvl="0" indent="0" marL="0">
-              <a:buNone/>
-            </a:pPr>
-            <a:r>
-              <a:rPr/>
-              <a:t>🧩 Chunk 2 of 3 · Small Multiples with Facets</a:t>
-            </a:r>
-          </a:p>
-        </p:txBody>
-      </p:sp>
-      <p:sp>
-        <p:nvSpPr>
-          <p:cNvPr id="3" name="Content Placeholder 2"/>
-          <p:cNvSpPr>
-            <a:spLocks noGrp="1"/>
-          </p:cNvSpPr>
-          <p:nvPr>
-            <p:ph idx="1"/>
-          </p:nvPr>
-        </p:nvSpPr>
-        <p:spPr/>
-        <p:txBody>
-          <a:bodyPr/>
-          <a:lstStyle/>
-          <a:p>
-            <a:pPr lvl="0" indent="0" marL="0">
-              <a:buNone/>
-            </a:pPr>
-            <a:r>
-              <a:rPr b="1"/>
-              <a:t>We will cover:</a:t>
-            </a:r>
-            <a:r>
-              <a:rPr/>
-              <a:t> </a:t>
-            </a:r>
-            <a:r>
-              <a:rPr>
-                <a:latin typeface="Courier"/>
-              </a:rPr>
-              <a:t>facet_wrap()</a:t>
-            </a:r>
-            <a:r>
-              <a:rPr/>
-              <a:t> and </a:t>
-            </a:r>
-            <a:r>
-              <a:rPr>
-                <a:latin typeface="Courier"/>
-              </a:rPr>
-              <a:t>facet_grid()</a:t>
-            </a:r>
-            <a:r>
-              <a:rPr/>
-              <a:t> — splitting one plot into a panel per group.</a:t>
-            </a:r>
-          </a:p>
-          <a:p>
-            <a:pPr lvl="0" indent="0" marL="0">
-              <a:buNone/>
-            </a:pPr>
-            <a:r>
-              <a:rPr b="1"/>
-              <a:t>🛑 After this chunk you will do Activity Part 3.</a:t>
-            </a:r>
-          </a:p>
-        </p:txBody>
-      </p:sp>
-    </p:spTree>
-  </p:cSld>
-</p:sld>
-</file>
-
-<file path=ppt/slides/slide13.xml><?xml version="1.0" encoding="utf-8"?>
 <p:sld xmlns:a="http://schemas.openxmlformats.org/drawingml/2006/main" xmlns:r="http://schemas.openxmlformats.org/officeDocument/2006/relationships" xmlns:p="http://schemas.openxmlformats.org/presentationml/2006/main">
   <p:cSld>
     <p:spTree>
@@ -5502,7 +4458,7 @@
 </p:sld>
 </file>
 
-<file path=ppt/slides/slide14.xml><?xml version="1.0" encoding="utf-8"?>
+<file path=ppt/slides/slide13.xml><?xml version="1.0" encoding="utf-8"?>
 <p:sld xmlns:a="http://schemas.openxmlformats.org/drawingml/2006/main" xmlns:r="http://schemas.openxmlformats.org/officeDocument/2006/relationships" xmlns:p="http://schemas.openxmlformats.org/presentationml/2006/main">
   <p:cSld>
     <p:spTree>
@@ -6421,6 +5377,112 @@
 </p:sld>
 </file>
 
+<file path=ppt/slides/slide14.xml><?xml version="1.0" encoding="utf-8"?>
+<p:sld xmlns:a="http://schemas.openxmlformats.org/drawingml/2006/main" xmlns:r="http://schemas.openxmlformats.org/officeDocument/2006/relationships" xmlns:p="http://schemas.openxmlformats.org/presentationml/2006/main">
+  <p:cSld>
+    <p:spTree>
+      <p:nvGrpSpPr>
+        <p:cNvPr id="1" name=""/>
+        <p:cNvGrpSpPr/>
+        <p:nvPr/>
+      </p:nvGrpSpPr>
+      <p:grpSpPr>
+        <a:xfrm>
+          <a:off x="0" y="0"/>
+          <a:ext cx="0" cy="0"/>
+          <a:chOff x="0" y="0"/>
+          <a:chExt cx="0" cy="0"/>
+        </a:xfrm>
+      </p:grpSpPr>
+      <p:sp>
+        <p:nvSpPr>
+          <p:cNvPr id="2" name="Title 1"/>
+          <p:cNvSpPr>
+            <a:spLocks noGrp="1"/>
+          </p:cNvSpPr>
+          <p:nvPr>
+            <p:ph type="title"/>
+          </p:nvPr>
+        </p:nvSpPr>
+        <p:spPr>
+          <a:xfrm>
+            <a:off x="0" y="0"/>
+            <a:ext cx="9144000" cy="582780"/>
+          </a:xfrm>
+        </p:spPr>
+        <p:txBody>
+          <a:bodyPr/>
+          <a:lstStyle/>
+          <a:p>
+            <a:pPr lvl="0" indent="0" marL="0">
+              <a:buNone/>
+            </a:pPr>
+            <a:r>
+              <a:rPr/>
+              <a:t>→ ACTIVITY 3 Part 3 now</a:t>
+            </a:r>
+          </a:p>
+        </p:txBody>
+      </p:sp>
+      <p:sp>
+        <p:nvSpPr>
+          <p:cNvPr id="3" name="Content Placeholder 2"/>
+          <p:cNvSpPr>
+            <a:spLocks noGrp="1"/>
+          </p:cNvSpPr>
+          <p:nvPr>
+            <p:ph idx="1"/>
+          </p:nvPr>
+        </p:nvSpPr>
+        <p:spPr/>
+        <p:txBody>
+          <a:bodyPr/>
+          <a:lstStyle/>
+          <a:p>
+            <a:pPr lvl="0" indent="0" marL="0">
+              <a:buNone/>
+            </a:pPr>
+            <a:r>
+              <a:rPr b="1"/>
+              <a:t>🛑 Do Activity Part 3 now</a:t>
+            </a:r>
+          </a:p>
+          <a:p>
+            <a:pPr lvl="0" indent="0" marL="0">
+              <a:buNone/>
+            </a:pPr>
+            <a:r>
+              <a:rPr/>
+              <a:t>Build both a </a:t>
+            </a:r>
+            <a:r>
+              <a:rPr>
+                <a:latin typeface="Courier"/>
+              </a:rPr>
+              <a:t>facet_wrap()</a:t>
+            </a:r>
+            <a:r>
+              <a:rPr/>
+              <a:t> and a </a:t>
+            </a:r>
+            <a:r>
+              <a:rPr>
+                <a:latin typeface="Courier"/>
+              </a:rPr>
+              <a:t>facet_grid()</a:t>
+            </a:r>
+            <a:r>
+              <a:rPr/>
+              <a:t> version of the histogram. Predict, type, run.</a:t>
+            </a:r>
+          </a:p>
+        </p:txBody>
+      </p:sp>
+    </p:spTree>
+  </p:cSld>
+</p:sld>
+</file>
+
 <file path=ppt/slides/slide15.xml><?xml version="1.0" encoding="utf-8"?>
 <p:sld xmlns:a="http://schemas.openxmlformats.org/drawingml/2006/main" xmlns:r="http://schemas.openxmlformats.org/officeDocument/2006/relationships" xmlns:p="http://schemas.openxmlformats.org/presentationml/2006/main">
   <p:cSld>
@@ -6463,7 +5525,13 @@
             </a:pPr>
             <a:r>
               <a:rPr/>
-              <a:t>→ ACTIVITY 3 Part 3 now</a:t>
+              <a:t>🧩 Chunk 3 of 3 · Mean ± SE with </a:t>
+            </a:r>
+            <a:r>
+              <a:rPr>
+                <a:latin typeface="Courier"/>
+              </a:rPr>
+              <a:t>stat_summary()</a:t>
             </a:r>
           </a:p>
         </p:txBody>
@@ -6488,7 +5556,11 @@
             </a:pPr>
             <a:r>
               <a:rPr b="1"/>
-              <a:t>🛑 Do Activity Part 3 now</a:t>
+              <a:t>We will cover:</a:t>
+            </a:r>
+            <a:r>
+              <a:rPr/>
+              <a:t> layering a group mean and its standard error directly on top of raw data — no summary table needed.</a:t>
             </a:r>
           </a:p>
           <a:p>
@@ -6496,28 +5568,8 @@
               <a:buNone/>
             </a:pPr>
             <a:r>
-              <a:rPr/>
-              <a:t>Build both a </a:t>
-            </a:r>
-            <a:r>
-              <a:rPr>
-                <a:latin typeface="Courier"/>
-              </a:rPr>
-              <a:t>facet_wrap()</a:t>
-            </a:r>
-            <a:r>
-              <a:rPr/>
-              <a:t> and a </a:t>
-            </a:r>
-            <a:r>
-              <a:rPr>
-                <a:latin typeface="Courier"/>
-              </a:rPr>
-              <a:t>facet_grid()</a:t>
-            </a:r>
-            <a:r>
-              <a:rPr/>
-              <a:t> version of the histogram. Predict, type, run.</a:t>
+              <a:rPr b="1"/>
+              <a:t>🛑 After this chunk you will do Activity Parts 4–5.</a:t>
             </a:r>
           </a:p>
         </p:txBody>
@@ -6556,102 +5608,6 @@
         </p:nvSpPr>
         <p:spPr>
           <a:xfrm>
-            <a:off x="0" y="0"/>
-            <a:ext cx="9144000" cy="582780"/>
-          </a:xfrm>
-        </p:spPr>
-        <p:txBody>
-          <a:bodyPr/>
-          <a:lstStyle/>
-          <a:p>
-            <a:pPr lvl="0" indent="0" marL="0">
-              <a:buNone/>
-            </a:pPr>
-            <a:r>
-              <a:rPr/>
-              <a:t>🧩 Chunk 3 of 3 · Mean ± SE with </a:t>
-            </a:r>
-            <a:r>
-              <a:rPr>
-                <a:latin typeface="Courier"/>
-              </a:rPr>
-              <a:t>stat_summary()</a:t>
-            </a:r>
-          </a:p>
-        </p:txBody>
-      </p:sp>
-      <p:sp>
-        <p:nvSpPr>
-          <p:cNvPr id="3" name="Content Placeholder 2"/>
-          <p:cNvSpPr>
-            <a:spLocks noGrp="1"/>
-          </p:cNvSpPr>
-          <p:nvPr>
-            <p:ph idx="1"/>
-          </p:nvPr>
-        </p:nvSpPr>
-        <p:spPr/>
-        <p:txBody>
-          <a:bodyPr/>
-          <a:lstStyle/>
-          <a:p>
-            <a:pPr lvl="0" indent="0" marL="0">
-              <a:buNone/>
-            </a:pPr>
-            <a:r>
-              <a:rPr b="1"/>
-              <a:t>We will cover:</a:t>
-            </a:r>
-            <a:r>
-              <a:rPr/>
-              <a:t> layering a group mean and its standard error directly on top of raw data — no summary table needed.</a:t>
-            </a:r>
-          </a:p>
-          <a:p>
-            <a:pPr lvl="0" indent="0" marL="0">
-              <a:buNone/>
-            </a:pPr>
-            <a:r>
-              <a:rPr b="1"/>
-              <a:t>🛑 After this chunk you will do Activity Parts 4–5.</a:t>
-            </a:r>
-          </a:p>
-        </p:txBody>
-      </p:sp>
-    </p:spTree>
-  </p:cSld>
-</p:sld>
-</file>
-
-<file path=ppt/slides/slide17.xml><?xml version="1.0" encoding="utf-8"?>
-<p:sld xmlns:a="http://schemas.openxmlformats.org/drawingml/2006/main" xmlns:r="http://schemas.openxmlformats.org/officeDocument/2006/relationships" xmlns:p="http://schemas.openxmlformats.org/presentationml/2006/main">
-  <p:cSld>
-    <p:spTree>
-      <p:nvGrpSpPr>
-        <p:cNvPr id="1" name=""/>
-        <p:cNvGrpSpPr/>
-        <p:nvPr/>
-      </p:nvGrpSpPr>
-      <p:grpSpPr>
-        <a:xfrm>
-          <a:off x="0" y="0"/>
-          <a:ext cx="0" cy="0"/>
-          <a:chOff x="0" y="0"/>
-          <a:chExt cx="0" cy="0"/>
-        </a:xfrm>
-      </p:grpSpPr>
-      <p:sp>
-        <p:nvSpPr>
-          <p:cNvPr id="2" name="Title 1"/>
-          <p:cNvSpPr>
-            <a:spLocks noGrp="1"/>
-          </p:cNvSpPr>
-          <p:nvPr>
-            <p:ph type="title"/>
-          </p:nvPr>
-        </p:nvSpPr>
-        <p:spPr>
-          <a:xfrm>
             <a:off x="139485" y="78119"/>
             <a:ext cx="8229600" cy="607682"/>
           </a:xfrm>
@@ -6848,7 +5804,7 @@
                 </a:solidFill>
                 <a:latin typeface="Courier"/>
               </a:rPr>
-              <a:t>geom_point</a:t>
+              <a:t>geom_jitter</a:t>
             </a:r>
             <a:r>
               <a:rPr>
@@ -6866,16 +5822,34 @@
                 </a:solidFill>
                 <a:latin typeface="Courier"/>
               </a:rPr>
-              <a:t>position =</a:t>
-            </a:r>
-            <a:r>
-              <a:rPr>
-                <a:solidFill>
-                  <a:srgbClr val="003B4F"/>
-                </a:solidFill>
-                <a:latin typeface="Courier"/>
-              </a:rPr>
-              <a:t> jitter_pos, </a:t>
+              <a:t>width =</a:t>
+            </a:r>
+            <a:r>
+              <a:rPr>
+                <a:solidFill>
+                  <a:srgbClr val="003B4F"/>
+                </a:solidFill>
+                <a:latin typeface="Courier"/>
+              </a:rPr>
+              <a:t> </a:t>
+            </a:r>
+            <a:r>
+              <a:rPr>
+                <a:solidFill>
+                  <a:srgbClr val="AD0000"/>
+                </a:solidFill>
+                <a:latin typeface="Courier"/>
+              </a:rPr>
+              <a:t>0.15</a:t>
+            </a:r>
+            <a:r>
+              <a:rPr>
+                <a:solidFill>
+                  <a:srgbClr val="003B4F"/>
+                </a:solidFill>
+                <a:latin typeface="Courier"/>
+              </a:rPr>
+              <a:t>, </a:t>
             </a:r>
             <a:r>
               <a:rPr>
@@ -7110,35 +6084,7 @@
                 </a:solidFill>
                 <a:latin typeface="Courier"/>
               </a:rPr>
-              <a:t>,</a:t>
-            </a:r>
-            <a:br/>
-            <a:r>
-              <a:rPr>
-                <a:solidFill>
-                  <a:srgbClr val="003B4F"/>
-                </a:solidFill>
-                <a:latin typeface="Courier"/>
-              </a:rPr>
-              <a:t>               </a:t>
-            </a:r>
-            <a:r>
-              <a:rPr>
-                <a:solidFill>
-                  <a:srgbClr val="657422"/>
-                </a:solidFill>
-                <a:latin typeface="Courier"/>
-              </a:rPr>
-              <a:t>position =</a:t>
-            </a:r>
-            <a:r>
-              <a:rPr>
-                <a:solidFill>
-                  <a:srgbClr val="003B4F"/>
-                </a:solidFill>
-                <a:latin typeface="Courier"/>
-              </a:rPr>
-              <a:t> dodge_pos) </a:t>
+              <a:t>) </a:t>
             </a:r>
             <a:r>
               <a:rPr>
@@ -7689,17 +6635,17 @@
             <a:pPr lvl="0"/>
             <a:r>
               <a:rPr/>
-              <a:t>Put the raw </a:t>
-            </a:r>
-            <a:r>
-              <a:rPr>
-                <a:latin typeface="Courier"/>
-              </a:rPr>
-              <a:t>geom_point()</a:t>
-            </a:r>
-            <a:r>
-              <a:rPr/>
-              <a:t> layer </a:t>
+              <a:t>Put </a:t>
+            </a:r>
+            <a:r>
+              <a:rPr>
+                <a:latin typeface="Courier"/>
+              </a:rPr>
+              <a:t>geom_jitter()</a:t>
+            </a:r>
+            <a:r>
+              <a:rPr/>
+              <a:t> </a:t>
             </a:r>
             <a:r>
               <a:rPr b="1"/>
@@ -7727,7 +6673,7 @@
 </p:sld>
 </file>
 
-<file path=ppt/slides/slide18.xml><?xml version="1.0" encoding="utf-8"?>
+<file path=ppt/slides/slide17.xml><?xml version="1.0" encoding="utf-8"?>
 <p:sld xmlns:a="http://schemas.openxmlformats.org/drawingml/2006/main" xmlns:r="http://schemas.openxmlformats.org/officeDocument/2006/relationships" xmlns:p="http://schemas.openxmlformats.org/presentationml/2006/main">
   <p:cSld>
     <p:spTree>
@@ -7833,7 +6779,7 @@
 </p:sld>
 </file>
 
-<file path=ppt/slides/slide19.xml><?xml version="1.0" encoding="utf-8"?>
+<file path=ppt/slides/slide18.xml><?xml version="1.0" encoding="utf-8"?>
 <p:sld xmlns:a="http://schemas.openxmlformats.org/drawingml/2006/main" xmlns:r="http://schemas.openxmlformats.org/officeDocument/2006/relationships" xmlns:p="http://schemas.openxmlformats.org/presentationml/2006/main">
   <p:cSld>
     <p:spTree>
@@ -8022,7 +6968,7 @@
                 </a:solidFill>
                 <a:latin typeface="Courier"/>
               </a:rPr>
-              <a:t>geom_point</a:t>
+              <a:t>geom_jitter</a:t>
             </a:r>
             <a:r>
               <a:rPr>
@@ -8040,16 +6986,34 @@
                 </a:solidFill>
                 <a:latin typeface="Courier"/>
               </a:rPr>
-              <a:t>position =</a:t>
-            </a:r>
-            <a:r>
-              <a:rPr>
-                <a:solidFill>
-                  <a:srgbClr val="003B4F"/>
-                </a:solidFill>
-                <a:latin typeface="Courier"/>
-              </a:rPr>
-              <a:t> jitter_pos, </a:t>
+              <a:t>width =</a:t>
+            </a:r>
+            <a:r>
+              <a:rPr>
+                <a:solidFill>
+                  <a:srgbClr val="003B4F"/>
+                </a:solidFill>
+                <a:latin typeface="Courier"/>
+              </a:rPr>
+              <a:t> </a:t>
+            </a:r>
+            <a:r>
+              <a:rPr>
+                <a:solidFill>
+                  <a:srgbClr val="AD0000"/>
+                </a:solidFill>
+                <a:latin typeface="Courier"/>
+              </a:rPr>
+              <a:t>0.15</a:t>
+            </a:r>
+            <a:r>
+              <a:rPr>
+                <a:solidFill>
+                  <a:srgbClr val="003B4F"/>
+                </a:solidFill>
+                <a:latin typeface="Courier"/>
+              </a:rPr>
+              <a:t>, </a:t>
             </a:r>
             <a:r>
               <a:rPr>
@@ -8248,6 +7212,117 @@
                 </a:solidFill>
                 <a:latin typeface="Courier"/>
               </a:rPr>
+              <a:t>) </a:t>
+            </a:r>
+            <a:r>
+              <a:rPr>
+                <a:solidFill>
+                  <a:srgbClr val="5E5E5E"/>
+                </a:solidFill>
+                <a:latin typeface="Courier"/>
+              </a:rPr>
+              <a:t>+</a:t>
+            </a:r>
+            <a:br/>
+            <a:r>
+              <a:rPr>
+                <a:solidFill>
+                  <a:srgbClr val="003B4F"/>
+                </a:solidFill>
+                <a:latin typeface="Courier"/>
+              </a:rPr>
+              <a:t>  </a:t>
+            </a:r>
+            <a:r>
+              <a:rPr>
+                <a:solidFill>
+                  <a:srgbClr val="4758AB"/>
+                </a:solidFill>
+                <a:latin typeface="Courier"/>
+              </a:rPr>
+              <a:t>stat_summary</a:t>
+            </a:r>
+            <a:r>
+              <a:rPr>
+                <a:solidFill>
+                  <a:srgbClr val="003B4F"/>
+                </a:solidFill>
+                <a:latin typeface="Courier"/>
+              </a:rPr>
+              <a:t>(</a:t>
+            </a:r>
+            <a:br/>
+            <a:r>
+              <a:rPr>
+                <a:solidFill>
+                  <a:srgbClr val="003B4F"/>
+                </a:solidFill>
+                <a:latin typeface="Courier"/>
+              </a:rPr>
+              <a:t>    </a:t>
+            </a:r>
+            <a:r>
+              <a:rPr>
+                <a:solidFill>
+                  <a:srgbClr val="657422"/>
+                </a:solidFill>
+                <a:latin typeface="Courier"/>
+              </a:rPr>
+              <a:t>fun.data =</a:t>
+            </a:r>
+            <a:r>
+              <a:rPr>
+                <a:solidFill>
+                  <a:srgbClr val="003B4F"/>
+                </a:solidFill>
+                <a:latin typeface="Courier"/>
+              </a:rPr>
+              <a:t> mean_se,</a:t>
+            </a:r>
+            <a:br/>
+            <a:r>
+              <a:rPr>
+                <a:solidFill>
+                  <a:srgbClr val="003B4F"/>
+                </a:solidFill>
+                <a:latin typeface="Courier"/>
+              </a:rPr>
+              <a:t>    </a:t>
+            </a:r>
+            <a:r>
+              <a:rPr>
+                <a:solidFill>
+                  <a:srgbClr val="657422"/>
+                </a:solidFill>
+                <a:latin typeface="Courier"/>
+              </a:rPr>
+              <a:t>geom =</a:t>
+            </a:r>
+            <a:r>
+              <a:rPr>
+                <a:solidFill>
+                  <a:srgbClr val="003B4F"/>
+                </a:solidFill>
+                <a:latin typeface="Courier"/>
+              </a:rPr>
+              <a:t> </a:t>
+            </a:r>
+            <a:r>
+              <a:rPr>
+                <a:solidFill>
+                  <a:srgbClr val="20794D"/>
+                </a:solidFill>
+                <a:latin typeface="Courier"/>
+              </a:rPr>
+              <a:t>"errorbar"</a:t>
+            </a:r>
+            <a:r>
+              <a:rPr>
+                <a:solidFill>
+                  <a:srgbClr val="003B4F"/>
+                </a:solidFill>
+                <a:latin typeface="Courier"/>
+              </a:rPr>
               <a:t>,</a:t>
             </a:r>
             <a:br/>
@@ -8258,7 +7333,7 @@
                 </a:solidFill>
                 <a:latin typeface="Courier"/>
               </a:rPr>
-              <a:t>               </a:t>
+              <a:t>    </a:t>
             </a:r>
             <a:r>
               <a:rPr>
@@ -8267,25 +7342,34 @@
                 </a:solidFill>
                 <a:latin typeface="Courier"/>
               </a:rPr>
-              <a:t>position =</a:t>
-            </a:r>
-            <a:r>
-              <a:rPr>
-                <a:solidFill>
-                  <a:srgbClr val="003B4F"/>
-                </a:solidFill>
-                <a:latin typeface="Courier"/>
-              </a:rPr>
-              <a:t> dodge_pos) </a:t>
-            </a:r>
-            <a:r>
-              <a:rPr>
-                <a:solidFill>
-                  <a:srgbClr val="5E5E5E"/>
-                </a:solidFill>
-                <a:latin typeface="Courier"/>
-              </a:rPr>
-              <a:t>+</a:t>
+              <a:t>width =</a:t>
+            </a:r>
+            <a:r>
+              <a:rPr>
+                <a:solidFill>
+                  <a:srgbClr val="003B4F"/>
+                </a:solidFill>
+                <a:latin typeface="Courier"/>
+              </a:rPr>
+              <a:t> </a:t>
+            </a:r>
+            <a:r>
+              <a:rPr>
+                <a:solidFill>
+                  <a:srgbClr val="AD0000"/>
+                </a:solidFill>
+                <a:latin typeface="Courier"/>
+              </a:rPr>
+              <a:t>0.15</a:t>
+            </a:r>
+            <a:r>
+              <a:rPr>
+                <a:solidFill>
+                  <a:srgbClr val="003B4F"/>
+                </a:solidFill>
+                <a:latin typeface="Courier"/>
+              </a:rPr>
+              <a:t>,</a:t>
             </a:r>
             <a:br/>
             <a:r>
@@ -8295,34 +7379,6 @@
                 </a:solidFill>
                 <a:latin typeface="Courier"/>
               </a:rPr>
-              <a:t>  </a:t>
-            </a:r>
-            <a:r>
-              <a:rPr>
-                <a:solidFill>
-                  <a:srgbClr val="4758AB"/>
-                </a:solidFill>
-                <a:latin typeface="Courier"/>
-              </a:rPr>
-              <a:t>stat_summary</a:t>
-            </a:r>
-            <a:r>
-              <a:rPr>
-                <a:solidFill>
-                  <a:srgbClr val="003B4F"/>
-                </a:solidFill>
-                <a:latin typeface="Courier"/>
-              </a:rPr>
-              <a:t>(</a:t>
-            </a:r>
-            <a:br/>
-            <a:r>
-              <a:rPr>
-                <a:solidFill>
-                  <a:srgbClr val="003B4F"/>
-                </a:solidFill>
-                <a:latin typeface="Courier"/>
-              </a:rPr>
               <a:t>    </a:t>
             </a:r>
             <a:r>
@@ -8332,35 +7388,7 @@
                 </a:solidFill>
                 <a:latin typeface="Courier"/>
               </a:rPr>
-              <a:t>fun.data =</a:t>
-            </a:r>
-            <a:r>
-              <a:rPr>
-                <a:solidFill>
-                  <a:srgbClr val="003B4F"/>
-                </a:solidFill>
-                <a:latin typeface="Courier"/>
-              </a:rPr>
-              <a:t> mean_se,</a:t>
-            </a:r>
-            <a:br/>
-            <a:r>
-              <a:rPr>
-                <a:solidFill>
-                  <a:srgbClr val="003B4F"/>
-                </a:solidFill>
-                <a:latin typeface="Courier"/>
-              </a:rPr>
-              <a:t>    </a:t>
-            </a:r>
-            <a:r>
-              <a:rPr>
-                <a:solidFill>
-                  <a:srgbClr val="657422"/>
-                </a:solidFill>
-                <a:latin typeface="Courier"/>
-              </a:rPr>
-              <a:t>geom =</a:t>
+              <a:t>linewidth =</a:t>
             </a:r>
             <a:r>
               <a:rPr>
@@ -8374,140 +7402,11 @@
             <a:r>
               <a:rPr>
                 <a:solidFill>
-                  <a:srgbClr val="20794D"/>
-                </a:solidFill>
-                <a:latin typeface="Courier"/>
-              </a:rPr>
-              <a:t>"errorbar"</a:t>
-            </a:r>
-            <a:r>
-              <a:rPr>
-                <a:solidFill>
-                  <a:srgbClr val="003B4F"/>
-                </a:solidFill>
-                <a:latin typeface="Courier"/>
-              </a:rPr>
-              <a:t>,</a:t>
-            </a:r>
-            <a:br/>
-            <a:r>
-              <a:rPr>
-                <a:solidFill>
-                  <a:srgbClr val="003B4F"/>
-                </a:solidFill>
-                <a:latin typeface="Courier"/>
-              </a:rPr>
-              <a:t>    </a:t>
-            </a:r>
-            <a:r>
-              <a:rPr>
-                <a:solidFill>
-                  <a:srgbClr val="657422"/>
-                </a:solidFill>
-                <a:latin typeface="Courier"/>
-              </a:rPr>
-              <a:t>width =</a:t>
-            </a:r>
-            <a:r>
-              <a:rPr>
-                <a:solidFill>
-                  <a:srgbClr val="003B4F"/>
-                </a:solidFill>
-                <a:latin typeface="Courier"/>
-              </a:rPr>
-              <a:t> </a:t>
-            </a:r>
-            <a:r>
-              <a:rPr>
-                <a:solidFill>
                   <a:srgbClr val="AD0000"/>
                 </a:solidFill>
                 <a:latin typeface="Courier"/>
               </a:rPr>
-              <a:t>0.15</a:t>
-            </a:r>
-            <a:r>
-              <a:rPr>
-                <a:solidFill>
-                  <a:srgbClr val="003B4F"/>
-                </a:solidFill>
-                <a:latin typeface="Courier"/>
-              </a:rPr>
-              <a:t>,</a:t>
-            </a:r>
-            <a:br/>
-            <a:r>
-              <a:rPr>
-                <a:solidFill>
-                  <a:srgbClr val="003B4F"/>
-                </a:solidFill>
-                <a:latin typeface="Courier"/>
-              </a:rPr>
-              <a:t>    </a:t>
-            </a:r>
-            <a:r>
-              <a:rPr>
-                <a:solidFill>
-                  <a:srgbClr val="657422"/>
-                </a:solidFill>
-                <a:latin typeface="Courier"/>
-              </a:rPr>
-              <a:t>linewidth =</a:t>
-            </a:r>
-            <a:r>
-              <a:rPr>
-                <a:solidFill>
-                  <a:srgbClr val="003B4F"/>
-                </a:solidFill>
-                <a:latin typeface="Courier"/>
-              </a:rPr>
-              <a:t> </a:t>
-            </a:r>
-            <a:r>
-              <a:rPr>
-                <a:solidFill>
-                  <a:srgbClr val="AD0000"/>
-                </a:solidFill>
-                <a:latin typeface="Courier"/>
-              </a:rPr>
               <a:t>0.9</a:t>
-            </a:r>
-            <a:r>
-              <a:rPr>
-                <a:solidFill>
-                  <a:srgbClr val="003B4F"/>
-                </a:solidFill>
-                <a:latin typeface="Courier"/>
-              </a:rPr>
-              <a:t>,</a:t>
-            </a:r>
-            <a:br/>
-            <a:r>
-              <a:rPr>
-                <a:solidFill>
-                  <a:srgbClr val="003B4F"/>
-                </a:solidFill>
-                <a:latin typeface="Courier"/>
-              </a:rPr>
-              <a:t>    </a:t>
-            </a:r>
-            <a:r>
-              <a:rPr>
-                <a:solidFill>
-                  <a:srgbClr val="657422"/>
-                </a:solidFill>
-                <a:latin typeface="Courier"/>
-              </a:rPr>
-              <a:t>position =</a:t>
-            </a:r>
-            <a:r>
-              <a:rPr>
-                <a:solidFill>
-                  <a:srgbClr val="003B4F"/>
-                </a:solidFill>
-                <a:latin typeface="Courier"/>
-              </a:rPr>
-              <a:t> dodge_pos</a:t>
             </a:r>
             <a:br/>
             <a:r>
@@ -9211,61 +8110,6 @@
             </a:r>
           </a:p>
           <a:p>
-            <a:pPr lvl="0"/>
-            <a:r>
-              <a:rPr/>
-              <a:t>The mean point and the error bar share </a:t>
-            </a:r>
-            <a:r>
-              <a:rPr b="1"/>
-              <a:t>one</a:t>
-            </a:r>
-            <a:r>
-              <a:rPr/>
-              <a:t> </a:t>
-            </a:r>
-            <a:r>
-              <a:rPr>
-                <a:latin typeface="Courier"/>
-              </a:rPr>
-              <a:t>position = dodge_pos</a:t>
-            </a:r>
-            <a:r>
-              <a:rPr/>
-              <a:t>, so they always line up. With one group per x it has no visible effect yet — add </a:t>
-            </a:r>
-            <a:r>
-              <a:rPr>
-                <a:latin typeface="Courier"/>
-              </a:rPr>
-              <a:t>color = sex</a:t>
-            </a:r>
-            <a:r>
-              <a:rPr/>
-              <a:t> and the same </a:t>
-            </a:r>
-            <a:r>
-              <a:rPr>
-                <a:latin typeface="Courier"/>
-              </a:rPr>
-              <a:t>dodge_pos</a:t>
-            </a:r>
-            <a:r>
-              <a:rPr/>
-              <a:t> fans the two groups apart, and you’d hang a </a:t>
-            </a:r>
-            <a:r>
-              <a:rPr>
-                <a:latin typeface="Courier"/>
-              </a:rPr>
-              <a:t>geom_line(position = dodge_pos)</a:t>
-            </a:r>
-            <a:r>
-              <a:rPr/>
-              <a:t> off it to connect them</a:t>
-            </a:r>
-          </a:p>
-          <a:p>
             <a:pPr lvl="0" indent="0" marL="0">
               <a:buNone/>
             </a:pPr>
@@ -9276,6 +8120,102 @@
             <a:r>
               <a:rPr i="1"/>
               <a:t>Describing Data</a:t>
+            </a:r>
+          </a:p>
+        </p:txBody>
+      </p:sp>
+    </p:spTree>
+  </p:cSld>
+</p:sld>
+</file>
+
+<file path=ppt/slides/slide19.xml><?xml version="1.0" encoding="utf-8"?>
+<p:sld xmlns:a="http://schemas.openxmlformats.org/drawingml/2006/main" xmlns:r="http://schemas.openxmlformats.org/officeDocument/2006/relationships" xmlns:p="http://schemas.openxmlformats.org/presentationml/2006/main">
+  <p:cSld>
+    <p:spTree>
+      <p:nvGrpSpPr>
+        <p:cNvPr id="1" name=""/>
+        <p:cNvGrpSpPr/>
+        <p:nvPr/>
+      </p:nvGrpSpPr>
+      <p:grpSpPr>
+        <a:xfrm>
+          <a:off x="0" y="0"/>
+          <a:ext cx="0" cy="0"/>
+          <a:chOff x="0" y="0"/>
+          <a:chExt cx="0" cy="0"/>
+        </a:xfrm>
+      </p:grpSpPr>
+      <p:sp>
+        <p:nvSpPr>
+          <p:cNvPr id="2" name="Title 1"/>
+          <p:cNvSpPr>
+            <a:spLocks noGrp="1"/>
+          </p:cNvSpPr>
+          <p:nvPr>
+            <p:ph type="title"/>
+          </p:nvPr>
+        </p:nvSpPr>
+        <p:spPr>
+          <a:xfrm>
+            <a:off x="0" y="0"/>
+            <a:ext cx="9144000" cy="582780"/>
+          </a:xfrm>
+        </p:spPr>
+        <p:txBody>
+          <a:bodyPr/>
+          <a:lstStyle/>
+          <a:p>
+            <a:pPr lvl="0" indent="0" marL="0">
+              <a:buNone/>
+            </a:pPr>
+            <a:r>
+              <a:rPr/>
+              <a:t>→ ACTIVITY 3 Parts 4–5 now</a:t>
+            </a:r>
+          </a:p>
+        </p:txBody>
+      </p:sp>
+      <p:sp>
+        <p:nvSpPr>
+          <p:cNvPr id="3" name="Content Placeholder 2"/>
+          <p:cNvSpPr>
+            <a:spLocks noGrp="1"/>
+          </p:cNvSpPr>
+          <p:nvPr>
+            <p:ph idx="1"/>
+          </p:nvPr>
+        </p:nvSpPr>
+        <p:spPr/>
+        <p:txBody>
+          <a:bodyPr/>
+          <a:lstStyle/>
+          <a:p>
+            <a:pPr lvl="0" indent="0" marL="0">
+              <a:buNone/>
+            </a:pPr>
+            <a:r>
+              <a:rPr b="1"/>
+              <a:t>🛑 Go to Activity 3 — Parts 4–5</a:t>
+            </a:r>
+          </a:p>
+          <a:p>
+            <a:pPr lvl="0" indent="0" marL="0">
+              <a:buNone/>
+            </a:pPr>
+            <a:r>
+              <a:rPr/>
+              <a:t>Close the slides. Build your own mean ± SE plot, then save it to </a:t>
+            </a:r>
+            <a:r>
+              <a:rPr>
+                <a:latin typeface="Courier"/>
+              </a:rPr>
+              <a:t>figures/</a:t>
+            </a:r>
+            <a:r>
+              <a:rPr/>
+              <a:t>.</a:t>
             </a:r>
           </a:p>
         </p:txBody>
@@ -9553,102 +8493,6 @@
         <p:spPr>
           <a:xfrm>
             <a:off x="0" y="0"/>
-            <a:ext cx="9144000" cy="582780"/>
-          </a:xfrm>
-        </p:spPr>
-        <p:txBody>
-          <a:bodyPr/>
-          <a:lstStyle/>
-          <a:p>
-            <a:pPr lvl="0" indent="0" marL="0">
-              <a:buNone/>
-            </a:pPr>
-            <a:r>
-              <a:rPr/>
-              <a:t>→ ACTIVITY 3 Parts 4–5 now</a:t>
-            </a:r>
-          </a:p>
-        </p:txBody>
-      </p:sp>
-      <p:sp>
-        <p:nvSpPr>
-          <p:cNvPr id="3" name="Content Placeholder 2"/>
-          <p:cNvSpPr>
-            <a:spLocks noGrp="1"/>
-          </p:cNvSpPr>
-          <p:nvPr>
-            <p:ph idx="1"/>
-          </p:nvPr>
-        </p:nvSpPr>
-        <p:spPr/>
-        <p:txBody>
-          <a:bodyPr/>
-          <a:lstStyle/>
-          <a:p>
-            <a:pPr lvl="0" indent="0" marL="0">
-              <a:buNone/>
-            </a:pPr>
-            <a:r>
-              <a:rPr b="1"/>
-              <a:t>🛑 Go to Activity 3 — Parts 4–5</a:t>
-            </a:r>
-          </a:p>
-          <a:p>
-            <a:pPr lvl="0" indent="0" marL="0">
-              <a:buNone/>
-            </a:pPr>
-            <a:r>
-              <a:rPr/>
-              <a:t>Close the slides. Build your own mean ± SE plot, then save it to </a:t>
-            </a:r>
-            <a:r>
-              <a:rPr>
-                <a:latin typeface="Courier"/>
-              </a:rPr>
-              <a:t>figures/</a:t>
-            </a:r>
-            <a:r>
-              <a:rPr/>
-              <a:t>.</a:t>
-            </a:r>
-          </a:p>
-        </p:txBody>
-      </p:sp>
-    </p:spTree>
-  </p:cSld>
-</p:sld>
-</file>
-
-<file path=ppt/slides/slide21.xml><?xml version="1.0" encoding="utf-8"?>
-<p:sld xmlns:a="http://schemas.openxmlformats.org/drawingml/2006/main" xmlns:r="http://schemas.openxmlformats.org/officeDocument/2006/relationships" xmlns:p="http://schemas.openxmlformats.org/presentationml/2006/main">
-  <p:cSld>
-    <p:spTree>
-      <p:nvGrpSpPr>
-        <p:cNvPr id="1" name=""/>
-        <p:cNvGrpSpPr/>
-        <p:nvPr/>
-      </p:nvGrpSpPr>
-      <p:grpSpPr>
-        <a:xfrm>
-          <a:off x="0" y="0"/>
-          <a:ext cx="0" cy="0"/>
-          <a:chOff x="0" y="0"/>
-          <a:chExt cx="0" cy="0"/>
-        </a:xfrm>
-      </p:grpSpPr>
-      <p:sp>
-        <p:nvSpPr>
-          <p:cNvPr id="2" name="Title 1"/>
-          <p:cNvSpPr>
-            <a:spLocks noGrp="1"/>
-          </p:cNvSpPr>
-          <p:nvPr>
-            <p:ph type="title"/>
-          </p:nvPr>
-        </p:nvSpPr>
-        <p:spPr>
-          <a:xfrm>
-            <a:off x="0" y="0"/>
             <a:ext cx="9144000" cy="602780"/>
           </a:xfrm>
           <a:solidFill>
@@ -9756,33 +8600,6 @@
             <a:r>
               <a:rPr/>
               <a:t> — mean and mean ± SE, drawn directly from raw data</a:t>
-            </a:r>
-          </a:p>
-          <a:p>
-            <a:pPr lvl="0"/>
-            <a:r>
-              <a:rPr/>
-              <a:t>Positions defined once at the top (</a:t>
-            </a:r>
-            <a:r>
-              <a:rPr>
-                <a:latin typeface="Courier"/>
-              </a:rPr>
-              <a:t>jitter_pos</a:t>
-            </a:r>
-            <a:r>
-              <a:rPr/>
-              <a:t>, </a:t>
-            </a:r>
-            <a:r>
-              <a:rPr>
-                <a:latin typeface="Courier"/>
-              </a:rPr>
-              <a:t>dodge_pos</a:t>
-            </a:r>
-            <a:r>
-              <a:rPr/>
-              <a:t>) and reused on every layer</a:t>
             </a:r>
           </a:p>
         </p:txBody>
@@ -10747,11 +9564,8 @@
         <p:spPr>
           <a:xfrm>
             <a:off x="0" y="0"/>
-            <a:ext cx="9144000" cy="602780"/>
+            <a:ext cx="9144000" cy="582780"/>
           </a:xfrm>
-          <a:solidFill>
-            <a:srgbClr val="1A1A2E"/>
-          </a:solidFill>
         </p:spPr>
         <p:txBody>
           <a:bodyPr/>
@@ -10762,7 +9576,7 @@
             </a:pPr>
             <a:r>
               <a:rPr/>
-              <a:t>Positions — Define Once, Reuse on Every Layer</a:t>
+              <a:t>🧩 Chunk 1 of 3 · Piping into ggplot, on Purpose</a:t>
             </a:r>
           </a:p>
         </p:txBody>
@@ -10774,7 +9588,7 @@
             <a:spLocks noGrp="1"/>
           </p:cNvSpPr>
           <p:nvPr>
-            <p:ph idx="1" sz="half"/>
+            <p:ph idx="1"/>
           </p:nvPr>
         </p:nvSpPr>
         <p:spPr/>
@@ -10782,338 +9596,35 @@
           <a:bodyPr/>
           <a:lstStyle/>
           <a:p>
-            <a:pPr lvl="0" indent="0">
+            <a:pPr lvl="0" indent="0" marL="0">
               <a:buNone/>
             </a:pPr>
             <a:r>
-              <a:rPr>
-                <a:solidFill>
-                  <a:srgbClr val="5E5E5E"/>
-                </a:solidFill>
-                <a:latin typeface="Courier"/>
-              </a:rPr>
-              <a:t># a "position" is HOW a layer nudges its shapes sideways</a:t>
-            </a:r>
-            <a:br/>
-            <a:r>
-              <a:rPr>
-                <a:solidFill>
-                  <a:srgbClr val="5E5E5E"/>
-                </a:solidFill>
-                <a:latin typeface="Courier"/>
-              </a:rPr>
-              <a:t># define each one once, up top, then reuse it on every layer</a:t>
-            </a:r>
-            <a:br/>
-            <a:br/>
-            <a:r>
-              <a:rPr>
-                <a:solidFill>
-                  <a:srgbClr val="5E5E5E"/>
-                </a:solidFill>
-                <a:latin typeface="Courier"/>
-              </a:rPr>
-              <a:t># raw points: scatter them so they don't stack on one line</a:t>
-            </a:r>
-            <a:br/>
-            <a:r>
-              <a:rPr>
-                <a:solidFill>
-                  <a:srgbClr val="003B4F"/>
-                </a:solidFill>
-                <a:latin typeface="Courier"/>
-              </a:rPr>
-              <a:t>jitter_pos &lt;- </a:t>
-            </a:r>
-            <a:r>
-              <a:rPr>
-                <a:solidFill>
-                  <a:srgbClr val="4758AB"/>
-                </a:solidFill>
-                <a:latin typeface="Courier"/>
-              </a:rPr>
-              <a:t>position_jitter</a:t>
-            </a:r>
-            <a:r>
-              <a:rPr>
-                <a:solidFill>
-                  <a:srgbClr val="003B4F"/>
-                </a:solidFill>
-                <a:latin typeface="Courier"/>
-              </a:rPr>
-              <a:t>(</a:t>
-            </a:r>
-            <a:r>
-              <a:rPr>
-                <a:solidFill>
-                  <a:srgbClr val="657422"/>
-                </a:solidFill>
-                <a:latin typeface="Courier"/>
-              </a:rPr>
-              <a:t>width =</a:t>
-            </a:r>
-            <a:r>
-              <a:rPr>
-                <a:solidFill>
-                  <a:srgbClr val="003B4F"/>
-                </a:solidFill>
-                <a:latin typeface="Courier"/>
-              </a:rPr>
-              <a:t> </a:t>
-            </a:r>
-            <a:r>
-              <a:rPr>
-                <a:solidFill>
-                  <a:srgbClr val="AD0000"/>
-                </a:solidFill>
-                <a:latin typeface="Courier"/>
-              </a:rPr>
-              <a:t>0.15</a:t>
-            </a:r>
-            <a:r>
-              <a:rPr>
-                <a:solidFill>
-                  <a:srgbClr val="003B4F"/>
-                </a:solidFill>
-                <a:latin typeface="Courier"/>
-              </a:rPr>
-              <a:t>, </a:t>
-            </a:r>
-            <a:r>
-              <a:rPr>
-                <a:solidFill>
-                  <a:srgbClr val="657422"/>
-                </a:solidFill>
-                <a:latin typeface="Courier"/>
-              </a:rPr>
-              <a:t>seed =</a:t>
-            </a:r>
-            <a:r>
-              <a:rPr>
-                <a:solidFill>
-                  <a:srgbClr val="003B4F"/>
-                </a:solidFill>
-                <a:latin typeface="Courier"/>
-              </a:rPr>
-              <a:t> </a:t>
-            </a:r>
-            <a:r>
-              <a:rPr>
-                <a:solidFill>
-                  <a:srgbClr val="AD0000"/>
-                </a:solidFill>
-                <a:latin typeface="Courier"/>
-              </a:rPr>
-              <a:t>42</a:t>
-            </a:r>
-            <a:r>
-              <a:rPr>
-                <a:solidFill>
-                  <a:srgbClr val="003B4F"/>
-                </a:solidFill>
-                <a:latin typeface="Courier"/>
-              </a:rPr>
-              <a:t>)</a:t>
-            </a:r>
-            <a:br/>
-            <a:br/>
-            <a:r>
-              <a:rPr>
-                <a:solidFill>
-                  <a:srgbClr val="5E5E5E"/>
-                </a:solidFill>
-                <a:latin typeface="Courier"/>
-              </a:rPr>
-              <a:t># grouped summaries / lines: shift the groups side by side</a:t>
-            </a:r>
-            <a:br/>
-            <a:r>
-              <a:rPr>
-                <a:solidFill>
-                  <a:srgbClr val="003B4F"/>
-                </a:solidFill>
-                <a:latin typeface="Courier"/>
-              </a:rPr>
-              <a:t>dodge_pos &lt;- </a:t>
-            </a:r>
-            <a:r>
-              <a:rPr>
-                <a:solidFill>
-                  <a:srgbClr val="4758AB"/>
-                </a:solidFill>
-                <a:latin typeface="Courier"/>
-              </a:rPr>
-              <a:t>position_dodge</a:t>
-            </a:r>
-            <a:r>
-              <a:rPr>
-                <a:solidFill>
-                  <a:srgbClr val="003B4F"/>
-                </a:solidFill>
-                <a:latin typeface="Courier"/>
-              </a:rPr>
-              <a:t>(</a:t>
-            </a:r>
-            <a:r>
-              <a:rPr>
-                <a:solidFill>
-                  <a:srgbClr val="657422"/>
-                </a:solidFill>
-                <a:latin typeface="Courier"/>
-              </a:rPr>
-              <a:t>width =</a:t>
-            </a:r>
-            <a:r>
-              <a:rPr>
-                <a:solidFill>
-                  <a:srgbClr val="003B4F"/>
-                </a:solidFill>
-                <a:latin typeface="Courier"/>
-              </a:rPr>
-              <a:t> </a:t>
-            </a:r>
-            <a:r>
-              <a:rPr>
-                <a:solidFill>
-                  <a:srgbClr val="AD0000"/>
-                </a:solidFill>
-                <a:latin typeface="Courier"/>
-              </a:rPr>
-              <a:t>0.2</a:t>
-            </a:r>
-            <a:r>
-              <a:rPr>
-                <a:solidFill>
-                  <a:srgbClr val="003B4F"/>
-                </a:solidFill>
-                <a:latin typeface="Courier"/>
-              </a:rPr>
-              <a:t>)</a:t>
-            </a:r>
-          </a:p>
-        </p:txBody>
-      </p:sp>
-      <p:sp>
-        <p:nvSpPr>
-          <p:cNvPr id="4" name="Content Placeholder 3"/>
-          <p:cNvSpPr>
-            <a:spLocks noGrp="1"/>
-          </p:cNvSpPr>
-          <p:nvPr>
-            <p:ph idx="2" sz="half"/>
-          </p:nvPr>
-        </p:nvSpPr>
-        <p:spPr/>
-        <p:txBody>
-          <a:bodyPr/>
-          <a:lstStyle/>
-          <a:p>
-            <a:pPr lvl="0"/>
-            <a:r>
-              <a:rPr>
-                <a:latin typeface="Courier"/>
-              </a:rPr>
-              <a:t>position_jitter(width = 0.15)</a:t>
-            </a:r>
-            <a:r>
-              <a:rPr/>
-              <a:t> — random sideways nudge so overlapping points become visible; </a:t>
-            </a:r>
-            <a:r>
-              <a:rPr>
-                <a:latin typeface="Courier"/>
-              </a:rPr>
-              <a:t>seed = 42</a:t>
-            </a:r>
-            <a:r>
-              <a:rPr/>
-              <a:t> freezes that nudge so the figure looks the same every render</a:t>
-            </a:r>
-          </a:p>
-          <a:p>
-            <a:pPr lvl="0"/>
-            <a:r>
-              <a:rPr>
-                <a:latin typeface="Courier"/>
-              </a:rPr>
-              <a:t>position_dodge(width = 0.2)</a:t>
-            </a:r>
-            <a:r>
-              <a:rPr/>
-              <a:t> — shifts groups apart; does nothing with one group per x, but the moment you add a second grouping variable (</a:t>
-            </a:r>
-            <a:r>
-              <a:rPr>
-                <a:latin typeface="Courier"/>
-              </a:rPr>
-              <a:t>color = sex</a:t>
-            </a:r>
-            <a:r>
-              <a:rPr/>
-              <a:t>) it fans the groups out</a:t>
-            </a:r>
-          </a:p>
-          <a:p>
-            <a:pPr lvl="0"/>
-            <a:r>
-              <a:rPr/>
-              <a:t>Reusing </a:t>
-            </a:r>
-            <a:r>
               <a:rPr b="1"/>
-              <a:t>one</a:t>
-            </a:r>
-            <a:r>
-              <a:rPr/>
-              <a:t> </a:t>
-            </a:r>
-            <a:r>
-              <a:rPr>
-                <a:latin typeface="Courier"/>
-              </a:rPr>
-              <a:t>dodge_pos</a:t>
-            </a:r>
-            <a:r>
-              <a:rPr/>
-              <a:t> on </a:t>
-            </a:r>
-            <a:r>
-              <a:rPr>
-                <a:latin typeface="Courier"/>
-              </a:rPr>
-              <a:t>geom_point()</a:t>
-            </a:r>
-            <a:r>
-              <a:rPr/>
-              <a:t>, </a:t>
-            </a:r>
-            <a:r>
-              <a:rPr>
-                <a:latin typeface="Courier"/>
-              </a:rPr>
-              <a:t>geom_errorbar()</a:t>
-            </a:r>
-            <a:r>
-              <a:rPr/>
-              <a:t>, </a:t>
-            </a:r>
+              <a:t>We will cover:</a:t>
+            </a:r>
+            <a:r>
+              <a:rPr/>
+              <a:t> starting a plot with the pipe, and choosing colors with </a:t>
+            </a:r>
+            <a:r>
+              <a:rPr>
+                <a:latin typeface="Courier"/>
+              </a:rPr>
+              <a:t>scale_color_manual()</a:t>
+            </a:r>
+            <a:r>
+              <a:rPr/>
+              <a:t>.</a:t>
+            </a:r>
+          </a:p>
+          <a:p>
+            <a:pPr lvl="0" indent="0" marL="0">
+              <a:buNone/>
+            </a:pPr>
             <a:r>
               <a:rPr b="1"/>
-              <a:t>and</a:t>
-            </a:r>
-            <a:r>
-              <a:rPr/>
-              <a:t> </a:t>
-            </a:r>
-            <a:r>
-              <a:rPr>
-                <a:latin typeface="Courier"/>
-              </a:rPr>
-              <a:t>geom_line()</a:t>
-            </a:r>
-            <a:r>
-              <a:rPr/>
-              <a:t> is what keeps a grouped mean, its error bar, and its connecting line perfectly aligned</a:t>
+              <a:t>🛑 After this chunk you will do Activity Parts 1–2.</a:t>
             </a:r>
           </a:p>
         </p:txBody>
@@ -11152,106 +9663,6 @@
         </p:nvSpPr>
         <p:spPr>
           <a:xfrm>
-            <a:off x="0" y="0"/>
-            <a:ext cx="9144000" cy="582780"/>
-          </a:xfrm>
-        </p:spPr>
-        <p:txBody>
-          <a:bodyPr/>
-          <a:lstStyle/>
-          <a:p>
-            <a:pPr lvl="0" indent="0" marL="0">
-              <a:buNone/>
-            </a:pPr>
-            <a:r>
-              <a:rPr/>
-              <a:t>🧩 Chunk 1 of 3 · Piping into ggplot, on Purpose</a:t>
-            </a:r>
-          </a:p>
-        </p:txBody>
-      </p:sp>
-      <p:sp>
-        <p:nvSpPr>
-          <p:cNvPr id="3" name="Content Placeholder 2"/>
-          <p:cNvSpPr>
-            <a:spLocks noGrp="1"/>
-          </p:cNvSpPr>
-          <p:nvPr>
-            <p:ph idx="1"/>
-          </p:nvPr>
-        </p:nvSpPr>
-        <p:spPr/>
-        <p:txBody>
-          <a:bodyPr/>
-          <a:lstStyle/>
-          <a:p>
-            <a:pPr lvl="0" indent="0" marL="0">
-              <a:buNone/>
-            </a:pPr>
-            <a:r>
-              <a:rPr b="1"/>
-              <a:t>We will cover:</a:t>
-            </a:r>
-            <a:r>
-              <a:rPr/>
-              <a:t> starting a plot with the pipe, and choosing colors with </a:t>
-            </a:r>
-            <a:r>
-              <a:rPr>
-                <a:latin typeface="Courier"/>
-              </a:rPr>
-              <a:t>scale_color_manual()</a:t>
-            </a:r>
-            <a:r>
-              <a:rPr/>
-              <a:t>.</a:t>
-            </a:r>
-          </a:p>
-          <a:p>
-            <a:pPr lvl="0" indent="0" marL="0">
-              <a:buNone/>
-            </a:pPr>
-            <a:r>
-              <a:rPr b="1"/>
-              <a:t>🛑 After this chunk you will do Activity Parts 1–2.</a:t>
-            </a:r>
-          </a:p>
-        </p:txBody>
-      </p:sp>
-    </p:spTree>
-  </p:cSld>
-</p:sld>
-</file>
-
-<file path=ppt/slides/slide8.xml><?xml version="1.0" encoding="utf-8"?>
-<p:sld xmlns:a="http://schemas.openxmlformats.org/drawingml/2006/main" xmlns:r="http://schemas.openxmlformats.org/officeDocument/2006/relationships" xmlns:p="http://schemas.openxmlformats.org/presentationml/2006/main">
-  <p:cSld>
-    <p:spTree>
-      <p:nvGrpSpPr>
-        <p:cNvPr id="1" name=""/>
-        <p:cNvGrpSpPr/>
-        <p:nvPr/>
-      </p:nvGrpSpPr>
-      <p:grpSpPr>
-        <a:xfrm>
-          <a:off x="0" y="0"/>
-          <a:ext cx="0" cy="0"/>
-          <a:chOff x="0" y="0"/>
-          <a:chExt cx="0" cy="0"/>
-        </a:xfrm>
-      </p:grpSpPr>
-      <p:sp>
-        <p:nvSpPr>
-          <p:cNvPr id="2" name="Title 1"/>
-          <p:cNvSpPr>
-            <a:spLocks noGrp="1"/>
-          </p:cNvSpPr>
-          <p:nvPr>
-            <p:ph type="title"/>
-          </p:nvPr>
-        </p:nvSpPr>
-        <p:spPr>
-          <a:xfrm>
             <a:off x="139485" y="78119"/>
             <a:ext cx="8229600" cy="607682"/>
           </a:xfrm>
@@ -11551,7 +9962,7 @@
                 </a:solidFill>
                 <a:latin typeface="Courier"/>
               </a:rPr>
-              <a:t>geom_point</a:t>
+              <a:t>geom_jitter</a:t>
             </a:r>
             <a:r>
               <a:rPr>
@@ -11569,16 +9980,34 @@
                 </a:solidFill>
                 <a:latin typeface="Courier"/>
               </a:rPr>
-              <a:t>position =</a:t>
-            </a:r>
-            <a:r>
-              <a:rPr>
-                <a:solidFill>
-                  <a:srgbClr val="003B4F"/>
-                </a:solidFill>
-                <a:latin typeface="Courier"/>
-              </a:rPr>
-              <a:t> jitter_pos, </a:t>
+              <a:t>width =</a:t>
+            </a:r>
+            <a:r>
+              <a:rPr>
+                <a:solidFill>
+                  <a:srgbClr val="003B4F"/>
+                </a:solidFill>
+                <a:latin typeface="Courier"/>
+              </a:rPr>
+              <a:t> </a:t>
+            </a:r>
+            <a:r>
+              <a:rPr>
+                <a:solidFill>
+                  <a:srgbClr val="AD0000"/>
+                </a:solidFill>
+                <a:latin typeface="Courier"/>
+              </a:rPr>
+              <a:t>0.15</a:t>
+            </a:r>
+            <a:r>
+              <a:rPr>
+                <a:solidFill>
+                  <a:srgbClr val="003B4F"/>
+                </a:solidFill>
+                <a:latin typeface="Courier"/>
+              </a:rPr>
+              <a:t>, </a:t>
             </a:r>
             <a:r>
               <a:rPr>
@@ -12073,7 +10502,7 @@
 </p:sld>
 </file>
 
-<file path=ppt/slides/slide9.xml><?xml version="1.0" encoding="utf-8"?>
+<file path=ppt/slides/slide8.xml><?xml version="1.0" encoding="utf-8"?>
 <p:sld xmlns:a="http://schemas.openxmlformats.org/drawingml/2006/main" xmlns:r="http://schemas.openxmlformats.org/officeDocument/2006/relationships" xmlns:p="http://schemas.openxmlformats.org/presentationml/2006/main">
   <p:cSld>
     <p:spTree>
@@ -12190,6 +10619,1067 @@
             <a:r>
               <a:rPr sz="2000"/>
               <a:t>). How many colors do we need to supply?</a:t>
+            </a:r>
+          </a:p>
+        </p:txBody>
+      </p:sp>
+    </p:spTree>
+  </p:cSld>
+</p:sld>
+</file>
+
+<file path=ppt/slides/slide9.xml><?xml version="1.0" encoding="utf-8"?>
+<p:sld xmlns:a="http://schemas.openxmlformats.org/drawingml/2006/main" xmlns:r="http://schemas.openxmlformats.org/officeDocument/2006/relationships" xmlns:p="http://schemas.openxmlformats.org/presentationml/2006/main">
+  <p:cSld>
+    <p:spTree>
+      <p:nvGrpSpPr>
+        <p:cNvPr id="1" name=""/>
+        <p:cNvGrpSpPr/>
+        <p:nvPr/>
+      </p:nvGrpSpPr>
+      <p:grpSpPr>
+        <a:xfrm>
+          <a:off x="0" y="0"/>
+          <a:ext cx="0" cy="0"/>
+          <a:chOff x="0" y="0"/>
+          <a:chExt cx="0" cy="0"/>
+        </a:xfrm>
+      </p:grpSpPr>
+      <p:sp>
+        <p:nvSpPr>
+          <p:cNvPr id="3" name="Text Placeholder 2"/>
+          <p:cNvSpPr>
+            <a:spLocks noGrp="1"/>
+          </p:cNvSpPr>
+          <p:nvPr>
+            <p:ph idx="1" type="body"/>
+          </p:nvPr>
+        </p:nvSpPr>
+        <p:spPr/>
+        <p:txBody>
+          <a:bodyPr/>
+          <a:lstStyle/>
+          <a:p>
+            <a:pPr lvl="0" indent="0">
+              <a:buNone/>
+            </a:pPr>
+            <a:r>
+              <a:rPr>
+                <a:solidFill>
+                  <a:srgbClr val="5E5E5E"/>
+                </a:solidFill>
+                <a:latin typeface="Courier"/>
+              </a:rPr>
+              <a:t># scale_fill_manual() assigns exact colors to exact groups</a:t>
+            </a:r>
+            <a:br/>
+            <a:r>
+              <a:rPr>
+                <a:solidFill>
+                  <a:srgbClr val="003B4F"/>
+                </a:solidFill>
+                <a:latin typeface="Courier"/>
+              </a:rPr>
+              <a:t>leaf_df </a:t>
+            </a:r>
+            <a:r>
+              <a:rPr>
+                <a:solidFill>
+                  <a:srgbClr val="5E5E5E"/>
+                </a:solidFill>
+                <a:latin typeface="Courier"/>
+              </a:rPr>
+              <a:t>%&gt;%</a:t>
+            </a:r>
+            <a:br/>
+            <a:r>
+              <a:rPr>
+                <a:solidFill>
+                  <a:srgbClr val="003B4F"/>
+                </a:solidFill>
+                <a:latin typeface="Courier"/>
+              </a:rPr>
+              <a:t>  </a:t>
+            </a:r>
+            <a:r>
+              <a:rPr>
+                <a:solidFill>
+                  <a:srgbClr val="4758AB"/>
+                </a:solidFill>
+                <a:latin typeface="Courier"/>
+              </a:rPr>
+              <a:t>ggplot</a:t>
+            </a:r>
+            <a:r>
+              <a:rPr>
+                <a:solidFill>
+                  <a:srgbClr val="003B4F"/>
+                </a:solidFill>
+                <a:latin typeface="Courier"/>
+              </a:rPr>
+              <a:t>(</a:t>
+            </a:r>
+            <a:r>
+              <a:rPr>
+                <a:solidFill>
+                  <a:srgbClr val="4758AB"/>
+                </a:solidFill>
+                <a:latin typeface="Courier"/>
+              </a:rPr>
+              <a:t>aes</a:t>
+            </a:r>
+            <a:r>
+              <a:rPr>
+                <a:solidFill>
+                  <a:srgbClr val="003B4F"/>
+                </a:solidFill>
+                <a:latin typeface="Courier"/>
+              </a:rPr>
+              <a:t>(</a:t>
+            </a:r>
+            <a:r>
+              <a:rPr>
+                <a:solidFill>
+                  <a:srgbClr val="657422"/>
+                </a:solidFill>
+                <a:latin typeface="Courier"/>
+              </a:rPr>
+              <a:t>x =</a:t>
+            </a:r>
+            <a:r>
+              <a:rPr>
+                <a:solidFill>
+                  <a:srgbClr val="003B4F"/>
+                </a:solidFill>
+                <a:latin typeface="Courier"/>
+              </a:rPr>
+              <a:t> shade, </a:t>
+            </a:r>
+            <a:r>
+              <a:rPr>
+                <a:solidFill>
+                  <a:srgbClr val="657422"/>
+                </a:solidFill>
+                <a:latin typeface="Courier"/>
+              </a:rPr>
+              <a:t>y =</a:t>
+            </a:r>
+            <a:r>
+              <a:rPr>
+                <a:solidFill>
+                  <a:srgbClr val="003B4F"/>
+                </a:solidFill>
+                <a:latin typeface="Courier"/>
+              </a:rPr>
+              <a:t> mass_g, </a:t>
+            </a:r>
+            <a:r>
+              <a:rPr>
+                <a:solidFill>
+                  <a:srgbClr val="657422"/>
+                </a:solidFill>
+                <a:latin typeface="Courier"/>
+              </a:rPr>
+              <a:t>fill =</a:t>
+            </a:r>
+            <a:r>
+              <a:rPr>
+                <a:solidFill>
+                  <a:srgbClr val="003B4F"/>
+                </a:solidFill>
+                <a:latin typeface="Courier"/>
+              </a:rPr>
+              <a:t> shade)) </a:t>
+            </a:r>
+            <a:r>
+              <a:rPr>
+                <a:solidFill>
+                  <a:srgbClr val="5E5E5E"/>
+                </a:solidFill>
+                <a:latin typeface="Courier"/>
+              </a:rPr>
+              <a:t>+</a:t>
+            </a:r>
+            <a:br/>
+            <a:r>
+              <a:rPr>
+                <a:solidFill>
+                  <a:srgbClr val="003B4F"/>
+                </a:solidFill>
+                <a:latin typeface="Courier"/>
+              </a:rPr>
+              <a:t>  </a:t>
+            </a:r>
+            <a:r>
+              <a:rPr>
+                <a:solidFill>
+                  <a:srgbClr val="4758AB"/>
+                </a:solidFill>
+                <a:latin typeface="Courier"/>
+              </a:rPr>
+              <a:t>geom_boxplot</a:t>
+            </a:r>
+            <a:r>
+              <a:rPr>
+                <a:solidFill>
+                  <a:srgbClr val="003B4F"/>
+                </a:solidFill>
+                <a:latin typeface="Courier"/>
+              </a:rPr>
+              <a:t>(</a:t>
+            </a:r>
+            <a:r>
+              <a:rPr>
+                <a:solidFill>
+                  <a:srgbClr val="657422"/>
+                </a:solidFill>
+                <a:latin typeface="Courier"/>
+              </a:rPr>
+              <a:t>alpha =</a:t>
+            </a:r>
+            <a:r>
+              <a:rPr>
+                <a:solidFill>
+                  <a:srgbClr val="003B4F"/>
+                </a:solidFill>
+                <a:latin typeface="Courier"/>
+              </a:rPr>
+              <a:t> </a:t>
+            </a:r>
+            <a:r>
+              <a:rPr>
+                <a:solidFill>
+                  <a:srgbClr val="AD0000"/>
+                </a:solidFill>
+                <a:latin typeface="Courier"/>
+              </a:rPr>
+              <a:t>0.6</a:t>
+            </a:r>
+            <a:r>
+              <a:rPr>
+                <a:solidFill>
+                  <a:srgbClr val="003B4F"/>
+                </a:solidFill>
+                <a:latin typeface="Courier"/>
+              </a:rPr>
+              <a:t>, </a:t>
+            </a:r>
+            <a:r>
+              <a:rPr>
+                <a:solidFill>
+                  <a:srgbClr val="657422"/>
+                </a:solidFill>
+                <a:latin typeface="Courier"/>
+              </a:rPr>
+              <a:t>outlier.shape =</a:t>
+            </a:r>
+            <a:r>
+              <a:rPr>
+                <a:solidFill>
+                  <a:srgbClr val="003B4F"/>
+                </a:solidFill>
+                <a:latin typeface="Courier"/>
+              </a:rPr>
+              <a:t> </a:t>
+            </a:r>
+            <a:r>
+              <a:rPr>
+                <a:solidFill>
+                  <a:srgbClr val="8F5902"/>
+                </a:solidFill>
+                <a:latin typeface="Courier"/>
+              </a:rPr>
+              <a:t>NA</a:t>
+            </a:r>
+            <a:r>
+              <a:rPr>
+                <a:solidFill>
+                  <a:srgbClr val="003B4F"/>
+                </a:solidFill>
+                <a:latin typeface="Courier"/>
+              </a:rPr>
+              <a:t>) </a:t>
+            </a:r>
+            <a:r>
+              <a:rPr>
+                <a:solidFill>
+                  <a:srgbClr val="5E5E5E"/>
+                </a:solidFill>
+                <a:latin typeface="Courier"/>
+              </a:rPr>
+              <a:t>+</a:t>
+            </a:r>
+            <a:br/>
+            <a:r>
+              <a:rPr>
+                <a:solidFill>
+                  <a:srgbClr val="003B4F"/>
+                </a:solidFill>
+                <a:latin typeface="Courier"/>
+              </a:rPr>
+              <a:t>  </a:t>
+            </a:r>
+            <a:r>
+              <a:rPr>
+                <a:solidFill>
+                  <a:srgbClr val="4758AB"/>
+                </a:solidFill>
+                <a:latin typeface="Courier"/>
+              </a:rPr>
+              <a:t>geom_jitter</a:t>
+            </a:r>
+            <a:r>
+              <a:rPr>
+                <a:solidFill>
+                  <a:srgbClr val="003B4F"/>
+                </a:solidFill>
+                <a:latin typeface="Courier"/>
+              </a:rPr>
+              <a:t>(</a:t>
+            </a:r>
+            <a:r>
+              <a:rPr>
+                <a:solidFill>
+                  <a:srgbClr val="657422"/>
+                </a:solidFill>
+                <a:latin typeface="Courier"/>
+              </a:rPr>
+              <a:t>width =</a:t>
+            </a:r>
+            <a:r>
+              <a:rPr>
+                <a:solidFill>
+                  <a:srgbClr val="003B4F"/>
+                </a:solidFill>
+                <a:latin typeface="Courier"/>
+              </a:rPr>
+              <a:t> </a:t>
+            </a:r>
+            <a:r>
+              <a:rPr>
+                <a:solidFill>
+                  <a:srgbClr val="AD0000"/>
+                </a:solidFill>
+                <a:latin typeface="Courier"/>
+              </a:rPr>
+              <a:t>0.15</a:t>
+            </a:r>
+            <a:r>
+              <a:rPr>
+                <a:solidFill>
+                  <a:srgbClr val="003B4F"/>
+                </a:solidFill>
+                <a:latin typeface="Courier"/>
+              </a:rPr>
+              <a:t>, </a:t>
+            </a:r>
+            <a:r>
+              <a:rPr>
+                <a:solidFill>
+                  <a:srgbClr val="657422"/>
+                </a:solidFill>
+                <a:latin typeface="Courier"/>
+              </a:rPr>
+              <a:t>alpha =</a:t>
+            </a:r>
+            <a:r>
+              <a:rPr>
+                <a:solidFill>
+                  <a:srgbClr val="003B4F"/>
+                </a:solidFill>
+                <a:latin typeface="Courier"/>
+              </a:rPr>
+              <a:t> </a:t>
+            </a:r>
+            <a:r>
+              <a:rPr>
+                <a:solidFill>
+                  <a:srgbClr val="AD0000"/>
+                </a:solidFill>
+                <a:latin typeface="Courier"/>
+              </a:rPr>
+              <a:t>0.6</a:t>
+            </a:r>
+            <a:r>
+              <a:rPr>
+                <a:solidFill>
+                  <a:srgbClr val="003B4F"/>
+                </a:solidFill>
+                <a:latin typeface="Courier"/>
+              </a:rPr>
+              <a:t>) </a:t>
+            </a:r>
+            <a:r>
+              <a:rPr>
+                <a:solidFill>
+                  <a:srgbClr val="5E5E5E"/>
+                </a:solidFill>
+                <a:latin typeface="Courier"/>
+              </a:rPr>
+              <a:t>+</a:t>
+            </a:r>
+            <a:br/>
+            <a:r>
+              <a:rPr>
+                <a:solidFill>
+                  <a:srgbClr val="003B4F"/>
+                </a:solidFill>
+                <a:latin typeface="Courier"/>
+              </a:rPr>
+              <a:t>  </a:t>
+            </a:r>
+            <a:r>
+              <a:rPr>
+                <a:solidFill>
+                  <a:srgbClr val="4758AB"/>
+                </a:solidFill>
+                <a:latin typeface="Courier"/>
+              </a:rPr>
+              <a:t>scale_fill_manual</a:t>
+            </a:r>
+            <a:r>
+              <a:rPr>
+                <a:solidFill>
+                  <a:srgbClr val="003B4F"/>
+                </a:solidFill>
+                <a:latin typeface="Courier"/>
+              </a:rPr>
+              <a:t>(</a:t>
+            </a:r>
+            <a:r>
+              <a:rPr>
+                <a:solidFill>
+                  <a:srgbClr val="657422"/>
+                </a:solidFill>
+                <a:latin typeface="Courier"/>
+              </a:rPr>
+              <a:t>values =</a:t>
+            </a:r>
+            <a:r>
+              <a:rPr>
+                <a:solidFill>
+                  <a:srgbClr val="003B4F"/>
+                </a:solidFill>
+                <a:latin typeface="Courier"/>
+              </a:rPr>
+              <a:t> </a:t>
+            </a:r>
+            <a:r>
+              <a:rPr>
+                <a:solidFill>
+                  <a:srgbClr val="4758AB"/>
+                </a:solidFill>
+                <a:latin typeface="Courier"/>
+              </a:rPr>
+              <a:t>c</a:t>
+            </a:r>
+            <a:r>
+              <a:rPr>
+                <a:solidFill>
+                  <a:srgbClr val="003B4F"/>
+                </a:solidFill>
+                <a:latin typeface="Courier"/>
+              </a:rPr>
+              <a:t>(</a:t>
+            </a:r>
+            <a:br/>
+            <a:r>
+              <a:rPr>
+                <a:solidFill>
+                  <a:srgbClr val="003B4F"/>
+                </a:solidFill>
+                <a:latin typeface="Courier"/>
+              </a:rPr>
+              <a:t>    </a:t>
+            </a:r>
+            <a:r>
+              <a:rPr>
+                <a:solidFill>
+                  <a:srgbClr val="20794D"/>
+                </a:solidFill>
+                <a:latin typeface="Courier"/>
+              </a:rPr>
+              <a:t>"sunny"</a:t>
+            </a:r>
+            <a:r>
+              <a:rPr>
+                <a:solidFill>
+                  <a:srgbClr val="003B4F"/>
+                </a:solidFill>
+                <a:latin typeface="Courier"/>
+              </a:rPr>
+              <a:t> = </a:t>
+            </a:r>
+            <a:r>
+              <a:rPr>
+                <a:solidFill>
+                  <a:srgbClr val="20794D"/>
+                </a:solidFill>
+                <a:latin typeface="Courier"/>
+              </a:rPr>
+              <a:t>"goldenrod"</a:t>
+            </a:r>
+            <a:r>
+              <a:rPr>
+                <a:solidFill>
+                  <a:srgbClr val="003B4F"/>
+                </a:solidFill>
+                <a:latin typeface="Courier"/>
+              </a:rPr>
+              <a:t>,</a:t>
+            </a:r>
+            <a:br/>
+            <a:r>
+              <a:rPr>
+                <a:solidFill>
+                  <a:srgbClr val="003B4F"/>
+                </a:solidFill>
+                <a:latin typeface="Courier"/>
+              </a:rPr>
+              <a:t>    </a:t>
+            </a:r>
+            <a:r>
+              <a:rPr>
+                <a:solidFill>
+                  <a:srgbClr val="20794D"/>
+                </a:solidFill>
+                <a:latin typeface="Courier"/>
+              </a:rPr>
+              <a:t>"shady"</a:t>
+            </a:r>
+            <a:r>
+              <a:rPr>
+                <a:solidFill>
+                  <a:srgbClr val="003B4F"/>
+                </a:solidFill>
+                <a:latin typeface="Courier"/>
+              </a:rPr>
+              <a:t> = </a:t>
+            </a:r>
+            <a:r>
+              <a:rPr>
+                <a:solidFill>
+                  <a:srgbClr val="20794D"/>
+                </a:solidFill>
+                <a:latin typeface="Courier"/>
+              </a:rPr>
+              <a:t>"forestgreen"</a:t>
+            </a:r>
+            <a:br/>
+            <a:r>
+              <a:rPr>
+                <a:solidFill>
+                  <a:srgbClr val="003B4F"/>
+                </a:solidFill>
+                <a:latin typeface="Courier"/>
+              </a:rPr>
+              <a:t>  )) </a:t>
+            </a:r>
+            <a:r>
+              <a:rPr>
+                <a:solidFill>
+                  <a:srgbClr val="5E5E5E"/>
+                </a:solidFill>
+                <a:latin typeface="Courier"/>
+              </a:rPr>
+              <a:t>+</a:t>
+            </a:r>
+            <a:br/>
+            <a:r>
+              <a:rPr>
+                <a:solidFill>
+                  <a:srgbClr val="003B4F"/>
+                </a:solidFill>
+                <a:latin typeface="Courier"/>
+              </a:rPr>
+              <a:t>  </a:t>
+            </a:r>
+            <a:r>
+              <a:rPr>
+                <a:solidFill>
+                  <a:srgbClr val="4758AB"/>
+                </a:solidFill>
+                <a:latin typeface="Courier"/>
+              </a:rPr>
+              <a:t>labs</a:t>
+            </a:r>
+            <a:r>
+              <a:rPr>
+                <a:solidFill>
+                  <a:srgbClr val="003B4F"/>
+                </a:solidFill>
+                <a:latin typeface="Courier"/>
+              </a:rPr>
+              <a:t>(</a:t>
+            </a:r>
+            <a:br/>
+            <a:r>
+              <a:rPr>
+                <a:solidFill>
+                  <a:srgbClr val="003B4F"/>
+                </a:solidFill>
+                <a:latin typeface="Courier"/>
+              </a:rPr>
+              <a:t>    </a:t>
+            </a:r>
+            <a:r>
+              <a:rPr>
+                <a:solidFill>
+                  <a:srgbClr val="657422"/>
+                </a:solidFill>
+                <a:latin typeface="Courier"/>
+              </a:rPr>
+              <a:t>title =</a:t>
+            </a:r>
+            <a:r>
+              <a:rPr>
+                <a:solidFill>
+                  <a:srgbClr val="003B4F"/>
+                </a:solidFill>
+                <a:latin typeface="Courier"/>
+              </a:rPr>
+              <a:t> </a:t>
+            </a:r>
+            <a:r>
+              <a:rPr>
+                <a:solidFill>
+                  <a:srgbClr val="20794D"/>
+                </a:solidFill>
+                <a:latin typeface="Courier"/>
+              </a:rPr>
+              <a:t>"Leaf Mass by Shade"</a:t>
+            </a:r>
+            <a:r>
+              <a:rPr>
+                <a:solidFill>
+                  <a:srgbClr val="003B4F"/>
+                </a:solidFill>
+                <a:latin typeface="Courier"/>
+              </a:rPr>
+              <a:t>,</a:t>
+            </a:r>
+            <a:br/>
+            <a:r>
+              <a:rPr>
+                <a:solidFill>
+                  <a:srgbClr val="003B4F"/>
+                </a:solidFill>
+                <a:latin typeface="Courier"/>
+              </a:rPr>
+              <a:t>    </a:t>
+            </a:r>
+            <a:r>
+              <a:rPr>
+                <a:solidFill>
+                  <a:srgbClr val="657422"/>
+                </a:solidFill>
+                <a:latin typeface="Courier"/>
+              </a:rPr>
+              <a:t>x =</a:t>
+            </a:r>
+            <a:r>
+              <a:rPr>
+                <a:solidFill>
+                  <a:srgbClr val="003B4F"/>
+                </a:solidFill>
+                <a:latin typeface="Courier"/>
+              </a:rPr>
+              <a:t> </a:t>
+            </a:r>
+            <a:r>
+              <a:rPr>
+                <a:solidFill>
+                  <a:srgbClr val="20794D"/>
+                </a:solidFill>
+                <a:latin typeface="Courier"/>
+              </a:rPr>
+              <a:t>"Shade"</a:t>
+            </a:r>
+            <a:r>
+              <a:rPr>
+                <a:solidFill>
+                  <a:srgbClr val="003B4F"/>
+                </a:solidFill>
+                <a:latin typeface="Courier"/>
+              </a:rPr>
+              <a:t>,</a:t>
+            </a:r>
+            <a:br/>
+            <a:r>
+              <a:rPr>
+                <a:solidFill>
+                  <a:srgbClr val="003B4F"/>
+                </a:solidFill>
+                <a:latin typeface="Courier"/>
+              </a:rPr>
+              <a:t>    </a:t>
+            </a:r>
+            <a:r>
+              <a:rPr>
+                <a:solidFill>
+                  <a:srgbClr val="657422"/>
+                </a:solidFill>
+                <a:latin typeface="Courier"/>
+              </a:rPr>
+              <a:t>y =</a:t>
+            </a:r>
+            <a:r>
+              <a:rPr>
+                <a:solidFill>
+                  <a:srgbClr val="003B4F"/>
+                </a:solidFill>
+                <a:latin typeface="Courier"/>
+              </a:rPr>
+              <a:t> </a:t>
+            </a:r>
+            <a:r>
+              <a:rPr>
+                <a:solidFill>
+                  <a:srgbClr val="20794D"/>
+                </a:solidFill>
+                <a:latin typeface="Courier"/>
+              </a:rPr>
+              <a:t>"Leaf Mass (g)"</a:t>
+            </a:r>
+            <a:r>
+              <a:rPr>
+                <a:solidFill>
+                  <a:srgbClr val="003B4F"/>
+                </a:solidFill>
+                <a:latin typeface="Courier"/>
+              </a:rPr>
+              <a:t>,</a:t>
+            </a:r>
+            <a:br/>
+            <a:r>
+              <a:rPr>
+                <a:solidFill>
+                  <a:srgbClr val="003B4F"/>
+                </a:solidFill>
+                <a:latin typeface="Courier"/>
+              </a:rPr>
+              <a:t>    </a:t>
+            </a:r>
+            <a:r>
+              <a:rPr>
+                <a:solidFill>
+                  <a:srgbClr val="657422"/>
+                </a:solidFill>
+                <a:latin typeface="Courier"/>
+              </a:rPr>
+              <a:t>fill =</a:t>
+            </a:r>
+            <a:r>
+              <a:rPr>
+                <a:solidFill>
+                  <a:srgbClr val="003B4F"/>
+                </a:solidFill>
+                <a:latin typeface="Courier"/>
+              </a:rPr>
+              <a:t> </a:t>
+            </a:r>
+            <a:r>
+              <a:rPr>
+                <a:solidFill>
+                  <a:srgbClr val="20794D"/>
+                </a:solidFill>
+                <a:latin typeface="Courier"/>
+              </a:rPr>
+              <a:t>"Shade"</a:t>
+            </a:r>
+            <a:br/>
+            <a:r>
+              <a:rPr>
+                <a:solidFill>
+                  <a:srgbClr val="003B4F"/>
+                </a:solidFill>
+                <a:latin typeface="Courier"/>
+              </a:rPr>
+              <a:t>  ) </a:t>
+            </a:r>
+            <a:r>
+              <a:rPr>
+                <a:solidFill>
+                  <a:srgbClr val="5E5E5E"/>
+                </a:solidFill>
+                <a:latin typeface="Courier"/>
+              </a:rPr>
+              <a:t>+</a:t>
+            </a:r>
+            <a:br/>
+            <a:r>
+              <a:rPr>
+                <a:solidFill>
+                  <a:srgbClr val="003B4F"/>
+                </a:solidFill>
+                <a:latin typeface="Courier"/>
+              </a:rPr>
+              <a:t>  </a:t>
+            </a:r>
+            <a:r>
+              <a:rPr>
+                <a:solidFill>
+                  <a:srgbClr val="4758AB"/>
+                </a:solidFill>
+                <a:latin typeface="Courier"/>
+              </a:rPr>
+              <a:t>theme_minimal</a:t>
+            </a:r>
+            <a:r>
+              <a:rPr>
+                <a:solidFill>
+                  <a:srgbClr val="003B4F"/>
+                </a:solidFill>
+                <a:latin typeface="Courier"/>
+              </a:rPr>
+              <a:t>() </a:t>
+            </a:r>
+            <a:r>
+              <a:rPr>
+                <a:solidFill>
+                  <a:srgbClr val="5E5E5E"/>
+                </a:solidFill>
+                <a:latin typeface="Courier"/>
+              </a:rPr>
+              <a:t>+</a:t>
+            </a:r>
+            <a:br/>
+            <a:r>
+              <a:rPr>
+                <a:solidFill>
+                  <a:srgbClr val="003B4F"/>
+                </a:solidFill>
+                <a:latin typeface="Courier"/>
+              </a:rPr>
+              <a:t>  </a:t>
+            </a:r>
+            <a:r>
+              <a:rPr>
+                <a:solidFill>
+                  <a:srgbClr val="4758AB"/>
+                </a:solidFill>
+                <a:latin typeface="Courier"/>
+              </a:rPr>
+              <a:t>theme</a:t>
+            </a:r>
+            <a:r>
+              <a:rPr>
+                <a:solidFill>
+                  <a:srgbClr val="003B4F"/>
+                </a:solidFill>
+                <a:latin typeface="Courier"/>
+              </a:rPr>
+              <a:t>(</a:t>
+            </a:r>
+            <a:r>
+              <a:rPr>
+                <a:solidFill>
+                  <a:srgbClr val="657422"/>
+                </a:solidFill>
+                <a:latin typeface="Courier"/>
+              </a:rPr>
+              <a:t>legend.position =</a:t>
+            </a:r>
+            <a:r>
+              <a:rPr>
+                <a:solidFill>
+                  <a:srgbClr val="003B4F"/>
+                </a:solidFill>
+                <a:latin typeface="Courier"/>
+              </a:rPr>
+              <a:t> </a:t>
+            </a:r>
+            <a:r>
+              <a:rPr>
+                <a:solidFill>
+                  <a:srgbClr val="20794D"/>
+                </a:solidFill>
+                <a:latin typeface="Courier"/>
+              </a:rPr>
+              <a:t>"none"</a:t>
+            </a:r>
+            <a:r>
+              <a:rPr>
+                <a:solidFill>
+                  <a:srgbClr val="003B4F"/>
+                </a:solidFill>
+                <a:latin typeface="Courier"/>
+              </a:rPr>
+              <a:t>)</a:t>
+            </a:r>
+          </a:p>
+        </p:txBody>
+      </p:sp>
+      <p:pic>
+        <p:nvPicPr>
+          <p:cNvPr descr="ggplot_1_lecture_files/figure-pptx/scale-manual-demo-1.png" id="0" name="Picture 1"/>
+          <p:cNvPicPr>
+            <a:picLocks noGrp="1" noChangeAspect="1"/>
+          </p:cNvPicPr>
+          <p:nvPr/>
+        </p:nvPicPr>
+        <p:blipFill>
+          <a:blip r:embed="rId2"/>
+          <a:stretch>
+            <a:fillRect/>
+          </a:stretch>
+        </p:blipFill>
+        <p:spPr bwMode="auto">
+          <a:xfrm>
+            <a:off x="127000" y="1562100"/>
+            <a:ext cx="4432300" cy="2730500"/>
+          </a:xfrm>
+          <a:prstGeom prst="rect">
+            <a:avLst/>
+          </a:prstGeom>
+          <a:noFill/>
+          <a:ln w="9525">
+            <a:noFill/>
+            <a:headEnd/>
+            <a:tailEnd/>
+          </a:ln>
+        </p:spPr>
+      </p:pic>
+      <p:sp>
+        <p:nvSpPr>
+          <p:cNvPr id="5" name="Text Placeholder 4"/>
+          <p:cNvSpPr>
+            <a:spLocks noGrp="1"/>
+          </p:cNvSpPr>
+          <p:nvPr>
+            <p:ph idx="3" sz="quarter" type="body"/>
+          </p:nvPr>
+        </p:nvSpPr>
+        <p:spPr/>
+        <p:txBody>
+          <a:bodyPr/>
+          <a:lstStyle/>
+          <a:p>
+            <a:pPr lvl="0"/>
+            <a:r>
+              <a:rPr>
+                <a:latin typeface="Courier"/>
+              </a:rPr>
+              <a:t>scale_fill_manual()</a:t>
+            </a:r>
+            <a:r>
+              <a:rPr/>
+              <a:t> — for </a:t>
+            </a:r>
+            <a:r>
+              <a:rPr>
+                <a:latin typeface="Courier"/>
+              </a:rPr>
+              <a:t>fill =</a:t>
+            </a:r>
+            <a:r>
+              <a:rPr/>
+              <a:t> aesthetics (boxes, bars, columns)</a:t>
+            </a:r>
+          </a:p>
+          <a:p>
+            <a:pPr lvl="0"/>
+            <a:r>
+              <a:rPr>
+                <a:latin typeface="Courier"/>
+              </a:rPr>
+              <a:t>scale_color_manual()</a:t>
+            </a:r>
+            <a:r>
+              <a:rPr/>
+              <a:t> — for </a:t>
+            </a:r>
+            <a:r>
+              <a:rPr>
+                <a:latin typeface="Courier"/>
+              </a:rPr>
+              <a:t>color =</a:t>
+            </a:r>
+            <a:r>
+              <a:rPr/>
+              <a:t> aesthetics (points, lines)</a:t>
+            </a:r>
+          </a:p>
+          <a:p>
+            <a:pPr lvl="0"/>
+            <a:r>
+              <a:rPr/>
+              <a:t>The </a:t>
+            </a:r>
+            <a:r>
+              <a:rPr b="1"/>
+              <a:t>names inside </a:t>
+            </a:r>
+            <a:r>
+              <a:rPr b="1">
+                <a:latin typeface="Courier"/>
+              </a:rPr>
+              <a:t>c()</a:t>
+            </a:r>
+            <a:r>
+              <a:rPr b="1"/>
+              <a:t> must exactly match</a:t>
+            </a:r>
+            <a:r>
+              <a:rPr/>
+              <a:t> the values in your data (</a:t>
+            </a:r>
+            <a:r>
+              <a:rPr>
+                <a:latin typeface="Courier"/>
+              </a:rPr>
+              <a:t>"sunny"</a:t>
+            </a:r>
+            <a:r>
+              <a:rPr/>
+              <a:t>, </a:t>
+            </a:r>
+            <a:r>
+              <a:rPr>
+                <a:latin typeface="Courier"/>
+              </a:rPr>
+              <a:t>"shady"</a:t>
+            </a:r>
+            <a:r>
+              <a:rPr/>
+              <a:t>) — case and spelling both count</a:t>
+            </a:r>
+          </a:p>
+          <a:p>
+            <a:pPr lvl="0" indent="0" marL="1270000">
+              <a:buNone/>
+            </a:pPr>
+            <a:r>
+              <a:rPr sz="2000" b="1"/>
+              <a:t>Warning</a:t>
+            </a:r>
+          </a:p>
+          <a:p>
+            <a:pPr lvl="0" indent="0" marL="1270000">
+              <a:buNone/>
+            </a:pPr>
+            <a:r>
+              <a:rPr sz="2000" b="1"/>
+              <a:t>⚠️ Watch out!</a:t>
+            </a:r>
+          </a:p>
+          <a:p>
+            <a:pPr lvl="0" indent="0" marL="1270000">
+              <a:buNone/>
+            </a:pPr>
+            <a:r>
+              <a:rPr sz="2000"/>
+              <a:t>If a name in </a:t>
+            </a:r>
+            <a:r>
+              <a:rPr sz="2000">
+                <a:latin typeface="Courier"/>
+              </a:rPr>
+              <a:t>values = c(...)</a:t>
+            </a:r>
+            <a:r>
+              <a:rPr sz="2000"/>
+              <a:t> doesn’t match a value in your data exactly, that group’s color falls back to grey and ggplot prints a warning.</a:t>
             </a:r>
           </a:p>
         </p:txBody>

</xml_diff>

<commit_message>
fiizxed warp of code chunks to 65 characters
</commit_message>
<xml_diff>
--- a/docs/content/ggplot_1/ggplot_1_lecture.pptx
+++ b/docs/content/ggplot_1/ggplot_1_lecture.pptx
@@ -4037,52 +4037,162 @@
                 </a:solidFill>
                 <a:latin typeface="Courier"/>
               </a:rPr>
+              <a:t>,</a:t>
+            </a:r>
+            <a:br/>
+            <a:r>
+              <a:rPr>
+                <a:solidFill>
+                  <a:srgbClr val="003B4F"/>
+                </a:solidFill>
+                <a:latin typeface="Courier"/>
+              </a:rPr>
+              <a:t>                               </a:t>
+            </a:r>
+            <a:r>
+              <a:rPr>
+                <a:solidFill>
+                  <a:srgbClr val="20794D"/>
+                </a:solidFill>
+                <a:latin typeface="Courier"/>
+              </a:rPr>
+              <a:t>"shady"</a:t>
+            </a:r>
+            <a:r>
+              <a:rPr>
+                <a:solidFill>
+                  <a:srgbClr val="003B4F"/>
+                </a:solidFill>
+                <a:latin typeface="Courier"/>
+              </a:rPr>
+              <a:t> = </a:t>
+            </a:r>
+            <a:r>
+              <a:rPr>
+                <a:solidFill>
+                  <a:srgbClr val="20794D"/>
+                </a:solidFill>
+                <a:latin typeface="Courier"/>
+              </a:rPr>
+              <a:t>"forestgreen"</a:t>
+            </a:r>
+            <a:r>
+              <a:rPr>
+                <a:solidFill>
+                  <a:srgbClr val="003B4F"/>
+                </a:solidFill>
+                <a:latin typeface="Courier"/>
+              </a:rPr>
+              <a:t>)) </a:t>
+            </a:r>
+            <a:r>
+              <a:rPr>
+                <a:solidFill>
+                  <a:srgbClr val="5E5E5E"/>
+                </a:solidFill>
+                <a:latin typeface="Courier"/>
+              </a:rPr>
+              <a:t>+</a:t>
+            </a:r>
+            <a:br/>
+            <a:r>
+              <a:rPr>
+                <a:solidFill>
+                  <a:srgbClr val="003B4F"/>
+                </a:solidFill>
+                <a:latin typeface="Courier"/>
+              </a:rPr>
+              <a:t>  </a:t>
+            </a:r>
+            <a:r>
+              <a:rPr>
+                <a:solidFill>
+                  <a:srgbClr val="4758AB"/>
+                </a:solidFill>
+                <a:latin typeface="Courier"/>
+              </a:rPr>
+              <a:t>labs</a:t>
+            </a:r>
+            <a:r>
+              <a:rPr>
+                <a:solidFill>
+                  <a:srgbClr val="003B4F"/>
+                </a:solidFill>
+                <a:latin typeface="Courier"/>
+              </a:rPr>
+              <a:t>(</a:t>
+            </a:r>
+            <a:r>
+              <a:rPr>
+                <a:solidFill>
+                  <a:srgbClr val="657422"/>
+                </a:solidFill>
+                <a:latin typeface="Courier"/>
+              </a:rPr>
+              <a:t>x =</a:t>
+            </a:r>
+            <a:r>
+              <a:rPr>
+                <a:solidFill>
+                  <a:srgbClr val="003B4F"/>
+                </a:solidFill>
+                <a:latin typeface="Courier"/>
+              </a:rPr>
+              <a:t> </a:t>
+            </a:r>
+            <a:r>
+              <a:rPr>
+                <a:solidFill>
+                  <a:srgbClr val="20794D"/>
+                </a:solidFill>
+                <a:latin typeface="Courier"/>
+              </a:rPr>
+              <a:t>"Leaf Mass (g)"</a:t>
+            </a:r>
+            <a:r>
+              <a:rPr>
+                <a:solidFill>
+                  <a:srgbClr val="003B4F"/>
+                </a:solidFill>
+                <a:latin typeface="Courier"/>
+              </a:rPr>
               <a:t>, </a:t>
             </a:r>
             <a:r>
               <a:rPr>
                 <a:solidFill>
+                  <a:srgbClr val="657422"/>
+                </a:solidFill>
+                <a:latin typeface="Courier"/>
+              </a:rPr>
+              <a:t>y =</a:t>
+            </a:r>
+            <a:r>
+              <a:rPr>
+                <a:solidFill>
+                  <a:srgbClr val="003B4F"/>
+                </a:solidFill>
+                <a:latin typeface="Courier"/>
+              </a:rPr>
+              <a:t> </a:t>
+            </a:r>
+            <a:r>
+              <a:rPr>
+                <a:solidFill>
                   <a:srgbClr val="20794D"/>
                 </a:solidFill>
                 <a:latin typeface="Courier"/>
               </a:rPr>
-              <a:t>"shady"</a:t>
-            </a:r>
-            <a:r>
-              <a:rPr>
-                <a:solidFill>
-                  <a:srgbClr val="003B4F"/>
-                </a:solidFill>
-                <a:latin typeface="Courier"/>
-              </a:rPr>
-              <a:t> = </a:t>
-            </a:r>
-            <a:r>
-              <a:rPr>
-                <a:solidFill>
-                  <a:srgbClr val="20794D"/>
-                </a:solidFill>
-                <a:latin typeface="Courier"/>
-              </a:rPr>
-              <a:t>"forestgreen"</a:t>
-            </a:r>
-            <a:r>
-              <a:rPr>
-                <a:solidFill>
-                  <a:srgbClr val="003B4F"/>
-                </a:solidFill>
-                <a:latin typeface="Courier"/>
-              </a:rPr>
-              <a:t>)) </a:t>
-            </a:r>
-            <a:r>
-              <a:rPr>
-                <a:solidFill>
-                  <a:srgbClr val="5E5E5E"/>
-                </a:solidFill>
-                <a:latin typeface="Courier"/>
-              </a:rPr>
-              <a:t>+</a:t>
+              <a:t>"Count"</a:t>
+            </a:r>
+            <a:r>
+              <a:rPr>
+                <a:solidFill>
+                  <a:srgbClr val="003B4F"/>
+                </a:solidFill>
+                <a:latin typeface="Courier"/>
+              </a:rPr>
+              <a:t>,</a:t>
             </a:r>
             <a:br/>
             <a:r>
@@ -4092,97 +4202,7 @@
                 </a:solidFill>
                 <a:latin typeface="Courier"/>
               </a:rPr>
-              <a:t>  </a:t>
-            </a:r>
-            <a:r>
-              <a:rPr>
-                <a:solidFill>
-                  <a:srgbClr val="4758AB"/>
-                </a:solidFill>
-                <a:latin typeface="Courier"/>
-              </a:rPr>
-              <a:t>labs</a:t>
-            </a:r>
-            <a:r>
-              <a:rPr>
-                <a:solidFill>
-                  <a:srgbClr val="003B4F"/>
-                </a:solidFill>
-                <a:latin typeface="Courier"/>
-              </a:rPr>
-              <a:t>(</a:t>
-            </a:r>
-            <a:r>
-              <a:rPr>
-                <a:solidFill>
-                  <a:srgbClr val="657422"/>
-                </a:solidFill>
-                <a:latin typeface="Courier"/>
-              </a:rPr>
-              <a:t>x =</a:t>
-            </a:r>
-            <a:r>
-              <a:rPr>
-                <a:solidFill>
-                  <a:srgbClr val="003B4F"/>
-                </a:solidFill>
-                <a:latin typeface="Courier"/>
-              </a:rPr>
-              <a:t> </a:t>
-            </a:r>
-            <a:r>
-              <a:rPr>
-                <a:solidFill>
-                  <a:srgbClr val="20794D"/>
-                </a:solidFill>
-                <a:latin typeface="Courier"/>
-              </a:rPr>
-              <a:t>"Leaf Mass (g)"</a:t>
-            </a:r>
-            <a:r>
-              <a:rPr>
-                <a:solidFill>
-                  <a:srgbClr val="003B4F"/>
-                </a:solidFill>
-                <a:latin typeface="Courier"/>
-              </a:rPr>
-              <a:t>, </a:t>
-            </a:r>
-            <a:r>
-              <a:rPr>
-                <a:solidFill>
-                  <a:srgbClr val="657422"/>
-                </a:solidFill>
-                <a:latin typeface="Courier"/>
-              </a:rPr>
-              <a:t>y =</a:t>
-            </a:r>
-            <a:r>
-              <a:rPr>
-                <a:solidFill>
-                  <a:srgbClr val="003B4F"/>
-                </a:solidFill>
-                <a:latin typeface="Courier"/>
-              </a:rPr>
-              <a:t> </a:t>
-            </a:r>
-            <a:r>
-              <a:rPr>
-                <a:solidFill>
-                  <a:srgbClr val="20794D"/>
-                </a:solidFill>
-                <a:latin typeface="Courier"/>
-              </a:rPr>
-              <a:t>"Count"</a:t>
-            </a:r>
-            <a:r>
-              <a:rPr>
-                <a:solidFill>
-                  <a:srgbClr val="003B4F"/>
-                </a:solidFill>
-                <a:latin typeface="Courier"/>
-              </a:rPr>
-              <a:t>, </a:t>
+              <a:t>       </a:t>
             </a:r>
             <a:r>
               <a:rPr>
@@ -4910,7 +4930,17 @@
                 </a:solidFill>
                 <a:latin typeface="Courier"/>
               </a:rPr>
-              <a:t>, </a:t>
+              <a:t>,</a:t>
+            </a:r>
+            <a:br/>
+            <a:r>
+              <a:rPr>
+                <a:solidFill>
+                  <a:srgbClr val="003B4F"/>
+                </a:solidFill>
+                <a:latin typeface="Courier"/>
+              </a:rPr>
+              <a:t>                               </a:t>
             </a:r>
             <a:r>
               <a:rPr>
@@ -6048,7 +6078,17 @@
                 </a:solidFill>
                 <a:latin typeface="Courier"/>
               </a:rPr>
-              <a:t>, </a:t>
+              <a:t>,</a:t>
+            </a:r>
+            <a:br/>
+            <a:r>
+              <a:rPr>
+                <a:solidFill>
+                  <a:srgbClr val="003B4F"/>
+                </a:solidFill>
+                <a:latin typeface="Courier"/>
+              </a:rPr>
+              <a:t>               </a:t>
             </a:r>
             <a:r>
               <a:rPr>
@@ -6193,7 +6233,17 @@
                 </a:solidFill>
                 <a:latin typeface="Courier"/>
               </a:rPr>
-              <a:t>, </a:t>
+              <a:t>,</a:t>
+            </a:r>
+            <a:br/>
+            <a:r>
+              <a:rPr>
+                <a:solidFill>
+                  <a:srgbClr val="003B4F"/>
+                </a:solidFill>
+                <a:latin typeface="Courier"/>
+              </a:rPr>
+              <a:t>                                </a:t>
             </a:r>
             <a:r>
               <a:rPr>
@@ -7525,7 +7575,17 @@
                 </a:solidFill>
                 <a:latin typeface="Courier"/>
               </a:rPr>
-              <a:t>, </a:t>
+              <a:t>,</a:t>
+            </a:r>
+            <a:br/>
+            <a:r>
+              <a:rPr>
+                <a:solidFill>
+                  <a:srgbClr val="003B4F"/>
+                </a:solidFill>
+                <a:latin typeface="Courier"/>
+              </a:rPr>
+              <a:t>                                </a:t>
             </a:r>
             <a:r>
               <a:rPr>
@@ -9417,7 +9477,17 @@
                 </a:solidFill>
                 <a:latin typeface="Courier"/>
               </a:rPr>
-              <a:t>leaf_df &lt;- </a:t>
+              <a:t>leaf_df &lt;-</a:t>
+            </a:r>
+            <a:br/>
+            <a:r>
+              <a:rPr>
+                <a:solidFill>
+                  <a:srgbClr val="003B4F"/>
+                </a:solidFill>
+                <a:latin typeface="Courier"/>
+              </a:rPr>
+              <a:t>  </a:t>
             </a:r>
             <a:r>
               <a:rPr>
@@ -9523,14 +9593,14 @@
               </a:rPr>
               <a:t>Rows: 53
 Columns: 8
-$ twig_id      &lt;chr&gt; NA, NA, NA, NA, NA, NA, NA, NA, NA, NA, NA, NA, "twig_1",…
-$ leaf_id      &lt;chr&gt; NA, NA, NA, NA, NA, NA, NA, NA, NA, NA, NA, NA, "l07", "l…
-$ teams        &lt;chr&gt; "12345", "12345", "12345", "12345", "12345", "12345", "12…
-$ shade        &lt;chr&gt; "sunny", "sunny", "sunny", "sunny", "sunny", "sunny", "sh…
-$ mass_g       &lt;dbl&gt; 0.4000, 0.4800, 0.3400, 0.6500, 0.2700, 0.4300, 0.3900, 0…
-$ petiole_mm   &lt;dbl&gt; 79.0000, 63.0000, 68.0000, 35.0000, 34.0000, 40.0000, 40.…
-$ thickness_mm &lt;dbl&gt; 0.15, 0.14, 0.14, 0.15, 0.11, 0.16, 0.14, 0.15, 0.12, 0.1…
-$ paper_mass_g &lt;dbl&gt; 0.2100, 0.2100, 0.2100, 0.2400, 0.1500, 0.3400, 0.2900, 0…</a:t>
+$ twig_id      &lt;chr&gt; NA, NA, NA, NA, NA, NA, NA, NA, NA, NA, NA…
+$ leaf_id      &lt;chr&gt; NA, NA, NA, NA, NA, NA, NA, NA, NA, NA, NA…
+$ teams        &lt;chr&gt; "12345", "12345", "12345", "12345", "12345…
+$ shade        &lt;chr&gt; "sunny", "sunny", "sunny", "sunny", "sunny…
+$ mass_g       &lt;dbl&gt; 0.4000, 0.4800, 0.3400, 0.6500, 0.2700, 0.…
+$ petiole_mm   &lt;dbl&gt; 79.0000, 63.0000, 68.0000, 35.0000, 34.000…
+$ thickness_mm &lt;dbl&gt; 0.15, 0.14, 0.14, 0.15, 0.11, 0.16, 0.14, …
+$ paper_mass_g &lt;dbl&gt; 0.2100, 0.2100, 0.2100, 0.2400, 0.1500, 0.…</a:t>
             </a:r>
           </a:p>
         </p:txBody>

</xml_diff>

<commit_message>
fixed to weather 2
</commit_message>
<xml_diff>
--- a/docs/content/ggplot_1/ggplot_1_lecture.pptx
+++ b/docs/content/ggplot_1/ggplot_1_lecture.pptx
@@ -24,7 +24,6 @@
     <p:sldId id="272" r:id="rId18"/>
     <p:sldId id="273" r:id="rId19"/>
     <p:sldId id="274" r:id="rId20"/>
-    <p:sldId id="275" r:id="rId21"/>
   </p:sldIdLst>
   <p:sldSz cx="9144000" cy="5143500" type="screen16x9"/>
   <p:notesSz cx="6858000" cy="9144000"/>
@@ -3359,7 +3358,7 @@
             </a:pPr>
             <a:r>
               <a:rPr/>
-              <a:t>2026-10-01</a:t>
+              <a:t>2026-10-05</a:t>
             </a:r>
           </a:p>
         </p:txBody>
@@ -6318,6 +6317,42 @@
               </a:rPr>
               <a:t>(</a:t>
             </a:r>
+            <a:r>
+              <a:rPr>
+                <a:solidFill>
+                  <a:srgbClr val="657422"/>
+                </a:solidFill>
+                <a:latin typeface="Courier"/>
+              </a:rPr>
+              <a:t>title =</a:t>
+            </a:r>
+            <a:r>
+              <a:rPr>
+                <a:solidFill>
+                  <a:srgbClr val="003B4F"/>
+                </a:solidFill>
+                <a:latin typeface="Courier"/>
+              </a:rPr>
+              <a:t> </a:t>
+            </a:r>
+            <a:r>
+              <a:rPr>
+                <a:solidFill>
+                  <a:srgbClr val="20794D"/>
+                </a:solidFill>
+                <a:latin typeface="Courier"/>
+              </a:rPr>
+              <a:t>"Leaf Mass with Group Means"</a:t>
+            </a:r>
+            <a:r>
+              <a:rPr>
+                <a:solidFill>
+                  <a:srgbClr val="003B4F"/>
+                </a:solidFill>
+                <a:latin typeface="Courier"/>
+              </a:rPr>
+              <a:t>,</a:t>
+            </a:r>
             <a:br/>
             <a:r>
               <a:rPr>
@@ -6326,7 +6361,7 @@
                 </a:solidFill>
                 <a:latin typeface="Courier"/>
               </a:rPr>
-              <a:t>    </a:t>
+              <a:t>       </a:t>
             </a:r>
             <a:r>
               <a:rPr>
@@ -6335,7 +6370,7 @@
                 </a:solidFill>
                 <a:latin typeface="Courier"/>
               </a:rPr>
-              <a:t>title =</a:t>
+              <a:t>x =</a:t>
             </a:r>
             <a:r>
               <a:rPr>
@@ -6353,26 +6388,16 @@
                 </a:solidFill>
                 <a:latin typeface="Courier"/>
               </a:rPr>
-              <a:t>"Leaf Mass with Group Means"</a:t>
-            </a:r>
-            <a:r>
-              <a:rPr>
-                <a:solidFill>
-                  <a:srgbClr val="003B4F"/>
-                </a:solidFill>
-                <a:latin typeface="Courier"/>
-              </a:rPr>
-              <a:t>,</a:t>
-            </a:r>
-            <a:br/>
-            <a:r>
-              <a:rPr>
-                <a:solidFill>
-                  <a:srgbClr val="003B4F"/>
-                </a:solidFill>
-                <a:latin typeface="Courier"/>
-              </a:rPr>
-              <a:t>    </a:t>
+              <a:t>"Shade"</a:t>
+            </a:r>
+            <a:r>
+              <a:rPr>
+                <a:solidFill>
+                  <a:srgbClr val="003B4F"/>
+                </a:solidFill>
+                <a:latin typeface="Courier"/>
+              </a:rPr>
+              <a:t>, </a:t>
             </a:r>
             <a:r>
               <a:rPr>
@@ -6381,7 +6406,7 @@
                 </a:solidFill>
                 <a:latin typeface="Courier"/>
               </a:rPr>
-              <a:t>x =</a:t>
+              <a:t>y =</a:t>
             </a:r>
             <a:r>
               <a:rPr>
@@ -6399,53 +6424,16 @@
                 </a:solidFill>
                 <a:latin typeface="Courier"/>
               </a:rPr>
-              <a:t>"Shade"</a:t>
-            </a:r>
-            <a:r>
-              <a:rPr>
-                <a:solidFill>
-                  <a:srgbClr val="003B4F"/>
-                </a:solidFill>
-                <a:latin typeface="Courier"/>
-              </a:rPr>
-              <a:t>, </a:t>
-            </a:r>
-            <a:r>
-              <a:rPr>
-                <a:solidFill>
-                  <a:srgbClr val="657422"/>
-                </a:solidFill>
-                <a:latin typeface="Courier"/>
-              </a:rPr>
-              <a:t>y =</a:t>
-            </a:r>
-            <a:r>
-              <a:rPr>
-                <a:solidFill>
-                  <a:srgbClr val="003B4F"/>
-                </a:solidFill>
-                <a:latin typeface="Courier"/>
-              </a:rPr>
-              <a:t> </a:t>
-            </a:r>
-            <a:r>
-              <a:rPr>
-                <a:solidFill>
-                  <a:srgbClr val="20794D"/>
-                </a:solidFill>
-                <a:latin typeface="Courier"/>
-              </a:rPr>
               <a:t>"Leaf Mass (g)"</a:t>
             </a:r>
-            <a:br/>
-            <a:r>
-              <a:rPr>
-                <a:solidFill>
-                  <a:srgbClr val="003B4F"/>
-                </a:solidFill>
-                <a:latin typeface="Courier"/>
-              </a:rPr>
-              <a:t>  ) </a:t>
+            <a:r>
+              <a:rPr>
+                <a:solidFill>
+                  <a:srgbClr val="003B4F"/>
+                </a:solidFill>
+                <a:latin typeface="Courier"/>
+              </a:rPr>
+              <a:t>) </a:t>
             </a:r>
             <a:r>
               <a:rPr>
@@ -6607,14 +6595,8 @@
           <a:p>
             <a:pPr lvl="0"/>
             <a:r>
-              <a:rPr>
-                <a:latin typeface="Courier"/>
-              </a:rPr>
-              <a:t>stat_summary()</a:t>
-            </a:r>
-            <a:r>
-              <a:rPr/>
-              <a:t> computes a statistic </a:t>
+              <a:rPr/>
+              <a:t>Computes a statistic </a:t>
             </a:r>
             <a:r>
               <a:rPr b="1"/>
@@ -6622,7 +6604,7 @@
             </a:r>
             <a:r>
               <a:rPr/>
-              <a:t> and draws it — no pre-built summary table needed</a:t>
+              <a:t> — no summary table needed</a:t>
             </a:r>
           </a:p>
           <a:p>
@@ -6635,13 +6617,13 @@
             </a:r>
             <a:r>
               <a:rPr/>
-              <a:t> — any function that returns one number (</a:t>
-            </a:r>
-            <a:r>
-              <a:rPr>
-                <a:latin typeface="Courier"/>
-              </a:rPr>
-              <a:t>mean</a:t>
+              <a:t> — any function returning one number (</a:t>
+            </a:r>
+            <a:r>
+              <a:rPr>
+                <a:latin typeface="Courier"/>
+              </a:rPr>
+              <a:t>median</a:t>
             </a:r>
             <a:r>
               <a:rPr/>
@@ -6651,16 +6633,6 @@
               <a:rPr>
                 <a:latin typeface="Courier"/>
               </a:rPr>
-              <a:t>median</a:t>
-            </a:r>
-            <a:r>
-              <a:rPr/>
-              <a:t>, </a:t>
-            </a:r>
-            <a:r>
-              <a:rPr>
-                <a:latin typeface="Courier"/>
-              </a:rPr>
               <a:t>max</a:t>
             </a:r>
             <a:r>
@@ -6678,7 +6650,7 @@
             </a:r>
             <a:r>
               <a:rPr/>
-              <a:t> — draw that number as a point</a:t>
+              <a:t> — draw it as a point</a:t>
             </a:r>
           </a:p>
           <a:p>
@@ -6713,7 +6685,7 @@
             </a:r>
             <a:r>
               <a:rPr/>
-              <a:t> so the mean sits on top of the raw points, not buried under them</a:t>
+              <a:t> so the mean sits on top</a:t>
             </a:r>
           </a:p>
         </p:txBody>
@@ -6752,8 +6724,8 @@
         </p:nvSpPr>
         <p:spPr>
           <a:xfrm>
-            <a:off x="0" y="0"/>
-            <a:ext cx="9144000" cy="582780"/>
+            <a:off x="139485" y="78119"/>
+            <a:ext cx="8229600" cy="607682"/>
           </a:xfrm>
         </p:spPr>
         <p:txBody>
@@ -6776,76 +6748,6 @@
           </a:p>
         </p:txBody>
       </p:sp>
-      <p:sp>
-        <p:nvSpPr>
-          <p:cNvPr id="3" name="Content Placeholder 2"/>
-          <p:cNvSpPr>
-            <a:spLocks noGrp="1"/>
-          </p:cNvSpPr>
-          <p:nvPr>
-            <p:ph idx="1"/>
-          </p:nvPr>
-        </p:nvSpPr>
-        <p:spPr/>
-        <p:txBody>
-          <a:bodyPr/>
-          <a:lstStyle/>
-          <a:p>
-            <a:pPr lvl="0" indent="0" marL="1270000">
-              <a:buNone/>
-            </a:pPr>
-            <a:r>
-              <a:rPr sz="2000" b="1"/>
-              <a:t>Note</a:t>
-            </a:r>
-          </a:p>
-          <a:p>
-            <a:pPr lvl="0" indent="0" marL="1270000">
-              <a:buNone/>
-            </a:pPr>
-            <a:r>
-              <a:rPr sz="2000" b="1"/>
-              <a:t>🔮 Predict first:</a:t>
-            </a:r>
-            <a:r>
-              <a:rPr sz="2000"/>
-              <a:t> </a:t>
-            </a:r>
-            <a:r>
-              <a:rPr sz="2000">
-                <a:latin typeface="Courier"/>
-              </a:rPr>
-              <a:t>fun.data = mean_se</a:t>
-            </a:r>
-            <a:r>
-              <a:rPr sz="2000"/>
-              <a:t> returns three numbers per group instead of one (the mean, and the bar’s top and bottom). What do you think those three are called?</a:t>
-            </a:r>
-          </a:p>
-        </p:txBody>
-      </p:sp>
-    </p:spTree>
-  </p:cSld>
-</p:sld>
-</file>
-
-<file path=ppt/slides/slide18.xml><?xml version="1.0" encoding="utf-8"?>
-<p:sld xmlns:a="http://schemas.openxmlformats.org/drawingml/2006/main" xmlns:r="http://schemas.openxmlformats.org/officeDocument/2006/relationships" xmlns:p="http://schemas.openxmlformats.org/presentationml/2006/main">
-  <p:cSld>
-    <p:spTree>
-      <p:nvGrpSpPr>
-        <p:cNvPr id="1" name=""/>
-        <p:cNvGrpSpPr/>
-        <p:nvPr/>
-      </p:nvGrpSpPr>
-      <p:grpSpPr>
-        <a:xfrm>
-          <a:off x="0" y="0"/>
-          <a:ext cx="0" cy="0"/>
-          <a:chOff x="0" y="0"/>
-          <a:chExt cx="0" cy="0"/>
-        </a:xfrm>
-      </p:grpSpPr>
       <p:sp>
         <p:nvSpPr>
           <p:cNvPr id="3" name="Text Placeholder 2"/>
@@ -7301,6 +7203,60 @@
               </a:rPr>
               <a:t>(</a:t>
             </a:r>
+            <a:r>
+              <a:rPr>
+                <a:solidFill>
+                  <a:srgbClr val="657422"/>
+                </a:solidFill>
+                <a:latin typeface="Courier"/>
+              </a:rPr>
+              <a:t>fun.data =</a:t>
+            </a:r>
+            <a:r>
+              <a:rPr>
+                <a:solidFill>
+                  <a:srgbClr val="003B4F"/>
+                </a:solidFill>
+                <a:latin typeface="Courier"/>
+              </a:rPr>
+              <a:t> mean_se, </a:t>
+            </a:r>
+            <a:r>
+              <a:rPr>
+                <a:solidFill>
+                  <a:srgbClr val="657422"/>
+                </a:solidFill>
+                <a:latin typeface="Courier"/>
+              </a:rPr>
+              <a:t>geom =</a:t>
+            </a:r>
+            <a:r>
+              <a:rPr>
+                <a:solidFill>
+                  <a:srgbClr val="003B4F"/>
+                </a:solidFill>
+                <a:latin typeface="Courier"/>
+              </a:rPr>
+              <a:t> </a:t>
+            </a:r>
+            <a:r>
+              <a:rPr>
+                <a:solidFill>
+                  <a:srgbClr val="20794D"/>
+                </a:solidFill>
+                <a:latin typeface="Courier"/>
+              </a:rPr>
+              <a:t>"errorbar"</a:t>
+            </a:r>
+            <a:r>
+              <a:rPr>
+                <a:solidFill>
+                  <a:srgbClr val="003B4F"/>
+                </a:solidFill>
+                <a:latin typeface="Courier"/>
+              </a:rPr>
+              <a:t>,</a:t>
+            </a:r>
             <a:br/>
             <a:r>
               <a:rPr>
@@ -7309,7 +7265,7 @@
                 </a:solidFill>
                 <a:latin typeface="Courier"/>
               </a:rPr>
-              <a:t>    </a:t>
+              <a:t>               </a:t>
             </a:r>
             <a:r>
               <a:rPr>
@@ -7318,16 +7274,79 @@
                 </a:solidFill>
                 <a:latin typeface="Courier"/>
               </a:rPr>
-              <a:t>fun.data =</a:t>
-            </a:r>
-            <a:r>
-              <a:rPr>
-                <a:solidFill>
-                  <a:srgbClr val="003B4F"/>
-                </a:solidFill>
-                <a:latin typeface="Courier"/>
-              </a:rPr>
-              <a:t> mean_se,</a:t>
+              <a:t>width =</a:t>
+            </a:r>
+            <a:r>
+              <a:rPr>
+                <a:solidFill>
+                  <a:srgbClr val="003B4F"/>
+                </a:solidFill>
+                <a:latin typeface="Courier"/>
+              </a:rPr>
+              <a:t> </a:t>
+            </a:r>
+            <a:r>
+              <a:rPr>
+                <a:solidFill>
+                  <a:srgbClr val="AD0000"/>
+                </a:solidFill>
+                <a:latin typeface="Courier"/>
+              </a:rPr>
+              <a:t>0.15</a:t>
+            </a:r>
+            <a:r>
+              <a:rPr>
+                <a:solidFill>
+                  <a:srgbClr val="003B4F"/>
+                </a:solidFill>
+                <a:latin typeface="Courier"/>
+              </a:rPr>
+              <a:t>, </a:t>
+            </a:r>
+            <a:r>
+              <a:rPr>
+                <a:solidFill>
+                  <a:srgbClr val="657422"/>
+                </a:solidFill>
+                <a:latin typeface="Courier"/>
+              </a:rPr>
+              <a:t>linewidth =</a:t>
+            </a:r>
+            <a:r>
+              <a:rPr>
+                <a:solidFill>
+                  <a:srgbClr val="003B4F"/>
+                </a:solidFill>
+                <a:latin typeface="Courier"/>
+              </a:rPr>
+              <a:t> </a:t>
+            </a:r>
+            <a:r>
+              <a:rPr>
+                <a:solidFill>
+                  <a:srgbClr val="AD0000"/>
+                </a:solidFill>
+                <a:latin typeface="Courier"/>
+              </a:rPr>
+              <a:t>0.9</a:t>
+            </a:r>
+            <a:r>
+              <a:rPr>
+                <a:solidFill>
+                  <a:srgbClr val="003B4F"/>
+                </a:solidFill>
+                <a:latin typeface="Courier"/>
+              </a:rPr>
+              <a:t>) </a:t>
+            </a:r>
+            <a:r>
+              <a:rPr>
+                <a:solidFill>
+                  <a:srgbClr val="5E5E5E"/>
+                </a:solidFill>
+                <a:latin typeface="Courier"/>
+              </a:rPr>
+              <a:t>+</a:t>
             </a:r>
             <a:br/>
             <a:r>
@@ -7337,7 +7356,25 @@
                 </a:solidFill>
                 <a:latin typeface="Courier"/>
               </a:rPr>
-              <a:t>    </a:t>
+              <a:t>  </a:t>
+            </a:r>
+            <a:r>
+              <a:rPr>
+                <a:solidFill>
+                  <a:srgbClr val="4758AB"/>
+                </a:solidFill>
+                <a:latin typeface="Courier"/>
+              </a:rPr>
+              <a:t>scale_color_manual</a:t>
+            </a:r>
+            <a:r>
+              <a:rPr>
+                <a:solidFill>
+                  <a:srgbClr val="003B4F"/>
+                </a:solidFill>
+                <a:latin typeface="Courier"/>
+              </a:rPr>
+              <a:t>(</a:t>
             </a:r>
             <a:r>
               <a:rPr>
@@ -7346,7 +7383,7 @@
                 </a:solidFill>
                 <a:latin typeface="Courier"/>
               </a:rPr>
-              <a:t>geom =</a:t>
+              <a:t>values =</a:t>
             </a:r>
             <a:r>
               <a:rPr>
@@ -7360,11 +7397,47 @@
             <a:r>
               <a:rPr>
                 <a:solidFill>
+                  <a:srgbClr val="4758AB"/>
+                </a:solidFill>
+                <a:latin typeface="Courier"/>
+              </a:rPr>
+              <a:t>c</a:t>
+            </a:r>
+            <a:r>
+              <a:rPr>
+                <a:solidFill>
+                  <a:srgbClr val="003B4F"/>
+                </a:solidFill>
+                <a:latin typeface="Courier"/>
+              </a:rPr>
+              <a:t>(</a:t>
+            </a:r>
+            <a:r>
+              <a:rPr>
+                <a:solidFill>
                   <a:srgbClr val="20794D"/>
                 </a:solidFill>
                 <a:latin typeface="Courier"/>
               </a:rPr>
-              <a:t>"errorbar"</a:t>
+              <a:t>"sunny"</a:t>
+            </a:r>
+            <a:r>
+              <a:rPr>
+                <a:solidFill>
+                  <a:srgbClr val="003B4F"/>
+                </a:solidFill>
+                <a:latin typeface="Courier"/>
+              </a:rPr>
+              <a:t> = </a:t>
+            </a:r>
+            <a:r>
+              <a:rPr>
+                <a:solidFill>
+                  <a:srgbClr val="20794D"/>
+                </a:solidFill>
+                <a:latin typeface="Courier"/>
+              </a:rPr>
+              <a:t>"goldenrod"</a:t>
             </a:r>
             <a:r>
               <a:rPr>
@@ -7383,7 +7456,80 @@
                 </a:solidFill>
                 <a:latin typeface="Courier"/>
               </a:rPr>
-              <a:t>    </a:t>
+              <a:t>                                </a:t>
+            </a:r>
+            <a:r>
+              <a:rPr>
+                <a:solidFill>
+                  <a:srgbClr val="20794D"/>
+                </a:solidFill>
+                <a:latin typeface="Courier"/>
+              </a:rPr>
+              <a:t>"shady"</a:t>
+            </a:r>
+            <a:r>
+              <a:rPr>
+                <a:solidFill>
+                  <a:srgbClr val="003B4F"/>
+                </a:solidFill>
+                <a:latin typeface="Courier"/>
+              </a:rPr>
+              <a:t> = </a:t>
+            </a:r>
+            <a:r>
+              <a:rPr>
+                <a:solidFill>
+                  <a:srgbClr val="20794D"/>
+                </a:solidFill>
+                <a:latin typeface="Courier"/>
+              </a:rPr>
+              <a:t>"forestgreen"</a:t>
+            </a:r>
+            <a:r>
+              <a:rPr>
+                <a:solidFill>
+                  <a:srgbClr val="003B4F"/>
+                </a:solidFill>
+                <a:latin typeface="Courier"/>
+              </a:rPr>
+              <a:t>)) </a:t>
+            </a:r>
+            <a:r>
+              <a:rPr>
+                <a:solidFill>
+                  <a:srgbClr val="5E5E5E"/>
+                </a:solidFill>
+                <a:latin typeface="Courier"/>
+              </a:rPr>
+              <a:t>+</a:t>
+            </a:r>
+            <a:br/>
+            <a:r>
+              <a:rPr>
+                <a:solidFill>
+                  <a:srgbClr val="003B4F"/>
+                </a:solidFill>
+                <a:latin typeface="Courier"/>
+              </a:rPr>
+              <a:t>  </a:t>
+            </a:r>
+            <a:r>
+              <a:rPr>
+                <a:solidFill>
+                  <a:srgbClr val="4758AB"/>
+                </a:solidFill>
+                <a:latin typeface="Courier"/>
+              </a:rPr>
+              <a:t>labs</a:t>
+            </a:r>
+            <a:r>
+              <a:rPr>
+                <a:solidFill>
+                  <a:srgbClr val="003B4F"/>
+                </a:solidFill>
+                <a:latin typeface="Courier"/>
+              </a:rPr>
+              <a:t>(</a:t>
             </a:r>
             <a:r>
               <a:rPr>
@@ -7392,7 +7538,7 @@
                 </a:solidFill>
                 <a:latin typeface="Courier"/>
               </a:rPr>
-              <a:t>width =</a:t>
+              <a:t>title =</a:t>
             </a:r>
             <a:r>
               <a:rPr>
@@ -7406,11 +7552,11 @@
             <a:r>
               <a:rPr>
                 <a:solidFill>
-                  <a:srgbClr val="AD0000"/>
-                </a:solidFill>
-                <a:latin typeface="Courier"/>
-              </a:rPr>
-              <a:t>0.15</a:t>
+                  <a:srgbClr val="20794D"/>
+                </a:solidFill>
+                <a:latin typeface="Courier"/>
+              </a:rPr>
+              <a:t>"Mean ± SE Leaf Mass by Shade"</a:t>
             </a:r>
             <a:r>
               <a:rPr>
@@ -7429,7 +7575,7 @@
                 </a:solidFill>
                 <a:latin typeface="Courier"/>
               </a:rPr>
-              <a:t>    </a:t>
+              <a:t>       </a:t>
             </a:r>
             <a:r>
               <a:rPr>
@@ -7438,7 +7584,7 @@
                 </a:solidFill>
                 <a:latin typeface="Courier"/>
               </a:rPr>
-              <a:t>linewidth =</a:t>
+              <a:t>x =</a:t>
             </a:r>
             <a:r>
               <a:rPr>
@@ -7452,58 +7598,20 @@
             <a:r>
               <a:rPr>
                 <a:solidFill>
-                  <a:srgbClr val="AD0000"/>
-                </a:solidFill>
-                <a:latin typeface="Courier"/>
-              </a:rPr>
-              <a:t>0.9</a:t>
-            </a:r>
-            <a:br/>
-            <a:r>
-              <a:rPr>
-                <a:solidFill>
-                  <a:srgbClr val="003B4F"/>
-                </a:solidFill>
-                <a:latin typeface="Courier"/>
-              </a:rPr>
-              <a:t>  ) </a:t>
-            </a:r>
-            <a:r>
-              <a:rPr>
-                <a:solidFill>
-                  <a:srgbClr val="5E5E5E"/>
-                </a:solidFill>
-                <a:latin typeface="Courier"/>
-              </a:rPr>
-              <a:t>+</a:t>
-            </a:r>
-            <a:br/>
-            <a:r>
-              <a:rPr>
-                <a:solidFill>
-                  <a:srgbClr val="003B4F"/>
-                </a:solidFill>
-                <a:latin typeface="Courier"/>
-              </a:rPr>
-              <a:t>  </a:t>
-            </a:r>
-            <a:r>
-              <a:rPr>
-                <a:solidFill>
-                  <a:srgbClr val="4758AB"/>
-                </a:solidFill>
-                <a:latin typeface="Courier"/>
-              </a:rPr>
-              <a:t>scale_color_manual</a:t>
-            </a:r>
-            <a:r>
-              <a:rPr>
-                <a:solidFill>
-                  <a:srgbClr val="003B4F"/>
-                </a:solidFill>
-                <a:latin typeface="Courier"/>
-              </a:rPr>
-              <a:t>(</a:t>
+                  <a:srgbClr val="20794D"/>
+                </a:solidFill>
+                <a:latin typeface="Courier"/>
+              </a:rPr>
+              <a:t>"Shade"</a:t>
+            </a:r>
+            <a:r>
+              <a:rPr>
+                <a:solidFill>
+                  <a:srgbClr val="003B4F"/>
+                </a:solidFill>
+                <a:latin typeface="Courier"/>
+              </a:rPr>
+              <a:t>, </a:t>
             </a:r>
             <a:r>
               <a:rPr>
@@ -7512,7 +7620,7 @@
                 </a:solidFill>
                 <a:latin typeface="Courier"/>
               </a:rPr>
-              <a:t>values =</a:t>
+              <a:t>y =</a:t>
             </a:r>
             <a:r>
               <a:rPr>
@@ -7526,268 +7634,20 @@
             <a:r>
               <a:rPr>
                 <a:solidFill>
-                  <a:srgbClr val="4758AB"/>
-                </a:solidFill>
-                <a:latin typeface="Courier"/>
-              </a:rPr>
-              <a:t>c</a:t>
-            </a:r>
-            <a:r>
-              <a:rPr>
-                <a:solidFill>
-                  <a:srgbClr val="003B4F"/>
-                </a:solidFill>
-                <a:latin typeface="Courier"/>
-              </a:rPr>
-              <a:t>(</a:t>
-            </a:r>
-            <a:r>
-              <a:rPr>
-                <a:solidFill>
                   <a:srgbClr val="20794D"/>
                 </a:solidFill>
                 <a:latin typeface="Courier"/>
               </a:rPr>
-              <a:t>"sunny"</a:t>
-            </a:r>
-            <a:r>
-              <a:rPr>
-                <a:solidFill>
-                  <a:srgbClr val="003B4F"/>
-                </a:solidFill>
-                <a:latin typeface="Courier"/>
-              </a:rPr>
-              <a:t> = </a:t>
-            </a:r>
-            <a:r>
-              <a:rPr>
-                <a:solidFill>
-                  <a:srgbClr val="20794D"/>
-                </a:solidFill>
-                <a:latin typeface="Courier"/>
-              </a:rPr>
-              <a:t>"goldenrod"</a:t>
-            </a:r>
-            <a:r>
-              <a:rPr>
-                <a:solidFill>
-                  <a:srgbClr val="003B4F"/>
-                </a:solidFill>
-                <a:latin typeface="Courier"/>
-              </a:rPr>
-              <a:t>,</a:t>
-            </a:r>
-            <a:br/>
-            <a:r>
-              <a:rPr>
-                <a:solidFill>
-                  <a:srgbClr val="003B4F"/>
-                </a:solidFill>
-                <a:latin typeface="Courier"/>
-              </a:rPr>
-              <a:t>                                </a:t>
-            </a:r>
-            <a:r>
-              <a:rPr>
-                <a:solidFill>
-                  <a:srgbClr val="20794D"/>
-                </a:solidFill>
-                <a:latin typeface="Courier"/>
-              </a:rPr>
-              <a:t>"shady"</a:t>
-            </a:r>
-            <a:r>
-              <a:rPr>
-                <a:solidFill>
-                  <a:srgbClr val="003B4F"/>
-                </a:solidFill>
-                <a:latin typeface="Courier"/>
-              </a:rPr>
-              <a:t> = </a:t>
-            </a:r>
-            <a:r>
-              <a:rPr>
-                <a:solidFill>
-                  <a:srgbClr val="20794D"/>
-                </a:solidFill>
-                <a:latin typeface="Courier"/>
-              </a:rPr>
-              <a:t>"forestgreen"</a:t>
-            </a:r>
-            <a:r>
-              <a:rPr>
-                <a:solidFill>
-                  <a:srgbClr val="003B4F"/>
-                </a:solidFill>
-                <a:latin typeface="Courier"/>
-              </a:rPr>
-              <a:t>)) </a:t>
-            </a:r>
-            <a:r>
-              <a:rPr>
-                <a:solidFill>
-                  <a:srgbClr val="5E5E5E"/>
-                </a:solidFill>
-                <a:latin typeface="Courier"/>
-              </a:rPr>
-              <a:t>+</a:t>
-            </a:r>
-            <a:br/>
-            <a:r>
-              <a:rPr>
-                <a:solidFill>
-                  <a:srgbClr val="003B4F"/>
-                </a:solidFill>
-                <a:latin typeface="Courier"/>
-              </a:rPr>
-              <a:t>  </a:t>
-            </a:r>
-            <a:r>
-              <a:rPr>
-                <a:solidFill>
-                  <a:srgbClr val="4758AB"/>
-                </a:solidFill>
-                <a:latin typeface="Courier"/>
-              </a:rPr>
-              <a:t>labs</a:t>
-            </a:r>
-            <a:r>
-              <a:rPr>
-                <a:solidFill>
-                  <a:srgbClr val="003B4F"/>
-                </a:solidFill>
-                <a:latin typeface="Courier"/>
-              </a:rPr>
-              <a:t>(</a:t>
-            </a:r>
-            <a:br/>
-            <a:r>
-              <a:rPr>
-                <a:solidFill>
-                  <a:srgbClr val="003B4F"/>
-                </a:solidFill>
-                <a:latin typeface="Courier"/>
-              </a:rPr>
-              <a:t>    </a:t>
-            </a:r>
-            <a:r>
-              <a:rPr>
-                <a:solidFill>
-                  <a:srgbClr val="657422"/>
-                </a:solidFill>
-                <a:latin typeface="Courier"/>
-              </a:rPr>
-              <a:t>title =</a:t>
-            </a:r>
-            <a:r>
-              <a:rPr>
-                <a:solidFill>
-                  <a:srgbClr val="003B4F"/>
-                </a:solidFill>
-                <a:latin typeface="Courier"/>
-              </a:rPr>
-              <a:t> </a:t>
-            </a:r>
-            <a:r>
-              <a:rPr>
-                <a:solidFill>
-                  <a:srgbClr val="20794D"/>
-                </a:solidFill>
-                <a:latin typeface="Courier"/>
-              </a:rPr>
-              <a:t>"Mean ± SE Leaf Mass by Shade"</a:t>
-            </a:r>
-            <a:r>
-              <a:rPr>
-                <a:solidFill>
-                  <a:srgbClr val="003B4F"/>
-                </a:solidFill>
-                <a:latin typeface="Courier"/>
-              </a:rPr>
-              <a:t>,</a:t>
-            </a:r>
-            <a:br/>
-            <a:r>
-              <a:rPr>
-                <a:solidFill>
-                  <a:srgbClr val="003B4F"/>
-                </a:solidFill>
-                <a:latin typeface="Courier"/>
-              </a:rPr>
-              <a:t>    </a:t>
-            </a:r>
-            <a:r>
-              <a:rPr>
-                <a:solidFill>
-                  <a:srgbClr val="657422"/>
-                </a:solidFill>
-                <a:latin typeface="Courier"/>
-              </a:rPr>
-              <a:t>x =</a:t>
-            </a:r>
-            <a:r>
-              <a:rPr>
-                <a:solidFill>
-                  <a:srgbClr val="003B4F"/>
-                </a:solidFill>
-                <a:latin typeface="Courier"/>
-              </a:rPr>
-              <a:t> </a:t>
-            </a:r>
-            <a:r>
-              <a:rPr>
-                <a:solidFill>
-                  <a:srgbClr val="20794D"/>
-                </a:solidFill>
-                <a:latin typeface="Courier"/>
-              </a:rPr>
-              <a:t>"Shade"</a:t>
-            </a:r>
-            <a:r>
-              <a:rPr>
-                <a:solidFill>
-                  <a:srgbClr val="003B4F"/>
-                </a:solidFill>
-                <a:latin typeface="Courier"/>
-              </a:rPr>
-              <a:t>, </a:t>
-            </a:r>
-            <a:r>
-              <a:rPr>
-                <a:solidFill>
-                  <a:srgbClr val="657422"/>
-                </a:solidFill>
-                <a:latin typeface="Courier"/>
-              </a:rPr>
-              <a:t>y =</a:t>
-            </a:r>
-            <a:r>
-              <a:rPr>
-                <a:solidFill>
-                  <a:srgbClr val="003B4F"/>
-                </a:solidFill>
-                <a:latin typeface="Courier"/>
-              </a:rPr>
-              <a:t> </a:t>
-            </a:r>
-            <a:r>
-              <a:rPr>
-                <a:solidFill>
-                  <a:srgbClr val="20794D"/>
-                </a:solidFill>
-                <a:latin typeface="Courier"/>
-              </a:rPr>
               <a:t>"Leaf Mass (g)"</a:t>
             </a:r>
-            <a:br/>
-            <a:r>
-              <a:rPr>
-                <a:solidFill>
-                  <a:srgbClr val="003B4F"/>
-                </a:solidFill>
-                <a:latin typeface="Courier"/>
-              </a:rPr>
-              <a:t>  ) </a:t>
+            <a:r>
+              <a:rPr>
+                <a:solidFill>
+                  <a:srgbClr val="003B4F"/>
+                </a:solidFill>
+                <a:latin typeface="Courier"/>
+              </a:rPr>
+              <a:t>) </a:t>
             </a:r>
             <a:r>
               <a:rPr>
@@ -7957,6 +7817,29 @@
         <p:txBody>
           <a:bodyPr/>
           <a:lstStyle/>
+          <a:p>
+            <a:pPr lvl="0" indent="0" marL="0">
+              <a:buNone/>
+            </a:pPr>
+            <a:r>
+              <a:rPr b="1"/>
+              <a:t>🔮 Predict first:</a:t>
+            </a:r>
+            <a:r>
+              <a:rPr/>
+              <a:t> </a:t>
+            </a:r>
+            <a:r>
+              <a:rPr>
+                <a:latin typeface="Courier"/>
+              </a:rPr>
+              <a:t>fun.data = mean_se</a:t>
+            </a:r>
+            <a:r>
+              <a:rPr/>
+              <a:t> returns three numbers per group, not one — what are they?</a:t>
+            </a:r>
+          </a:p>
           <a:p>
             <a:pPr lvl="0" indent="0" marL="0">
               <a:buNone/>
@@ -8134,35 +8017,15 @@
             </a:r>
             <a:r>
               <a:rPr/>
-              <a:t> (</a:t>
-            </a:r>
-            <a:r>
-              <a:rPr>
-                <a:latin typeface="Courier"/>
-              </a:rPr>
-              <a:t>alpha = 0.35</a:t>
-            </a:r>
-            <a:r>
-              <a:rPr/>
-              <a:t>)</a:t>
-            </a:r>
-          </a:p>
-          <a:p>
-            <a:pPr lvl="0"/>
-            <a:r>
-              <a:rPr/>
-              <a:t>Mean as a </a:t>
+              <a:t>, mean as a </a:t>
             </a:r>
             <a:r>
               <a:rPr b="1"/>
-              <a:t>larger foreground point</a:t>
-            </a:r>
-          </a:p>
-          <a:p>
-            <a:pPr lvl="0"/>
-            <a:r>
-              <a:rPr/>
-              <a:t>Error bars = </a:t>
+              <a:t>larger point</a:t>
+            </a:r>
+            <a:r>
+              <a:rPr/>
+              <a:t>, bars = </a:t>
             </a:r>
             <a:r>
               <a:rPr b="1"/>
@@ -8180,6 +8043,102 @@
             <a:r>
               <a:rPr i="1"/>
               <a:t>Describing Data</a:t>
+            </a:r>
+          </a:p>
+        </p:txBody>
+      </p:sp>
+    </p:spTree>
+  </p:cSld>
+</p:sld>
+</file>
+
+<file path=ppt/slides/slide18.xml><?xml version="1.0" encoding="utf-8"?>
+<p:sld xmlns:a="http://schemas.openxmlformats.org/drawingml/2006/main" xmlns:r="http://schemas.openxmlformats.org/officeDocument/2006/relationships" xmlns:p="http://schemas.openxmlformats.org/presentationml/2006/main">
+  <p:cSld>
+    <p:spTree>
+      <p:nvGrpSpPr>
+        <p:cNvPr id="1" name=""/>
+        <p:cNvGrpSpPr/>
+        <p:nvPr/>
+      </p:nvGrpSpPr>
+      <p:grpSpPr>
+        <a:xfrm>
+          <a:off x="0" y="0"/>
+          <a:ext cx="0" cy="0"/>
+          <a:chOff x="0" y="0"/>
+          <a:chExt cx="0" cy="0"/>
+        </a:xfrm>
+      </p:grpSpPr>
+      <p:sp>
+        <p:nvSpPr>
+          <p:cNvPr id="2" name="Title 1"/>
+          <p:cNvSpPr>
+            <a:spLocks noGrp="1"/>
+          </p:cNvSpPr>
+          <p:nvPr>
+            <p:ph type="title"/>
+          </p:nvPr>
+        </p:nvSpPr>
+        <p:spPr>
+          <a:xfrm>
+            <a:off x="0" y="0"/>
+            <a:ext cx="9144000" cy="582780"/>
+          </a:xfrm>
+        </p:spPr>
+        <p:txBody>
+          <a:bodyPr/>
+          <a:lstStyle/>
+          <a:p>
+            <a:pPr lvl="0" indent="0" marL="0">
+              <a:buNone/>
+            </a:pPr>
+            <a:r>
+              <a:rPr/>
+              <a:t>→ ACTIVITY 3 Parts 4–5 now</a:t>
+            </a:r>
+          </a:p>
+        </p:txBody>
+      </p:sp>
+      <p:sp>
+        <p:nvSpPr>
+          <p:cNvPr id="3" name="Content Placeholder 2"/>
+          <p:cNvSpPr>
+            <a:spLocks noGrp="1"/>
+          </p:cNvSpPr>
+          <p:nvPr>
+            <p:ph idx="1"/>
+          </p:nvPr>
+        </p:nvSpPr>
+        <p:spPr/>
+        <p:txBody>
+          <a:bodyPr/>
+          <a:lstStyle/>
+          <a:p>
+            <a:pPr lvl="0" indent="0" marL="0">
+              <a:buNone/>
+            </a:pPr>
+            <a:r>
+              <a:rPr b="1"/>
+              <a:t>🛑 Go to Activity 3 — Parts 4–5</a:t>
+            </a:r>
+          </a:p>
+          <a:p>
+            <a:pPr lvl="0" indent="0" marL="0">
+              <a:buNone/>
+            </a:pPr>
+            <a:r>
+              <a:rPr/>
+              <a:t>Close the slides. Build your own mean ± SE plot, then save it to </a:t>
+            </a:r>
+            <a:r>
+              <a:rPr>
+                <a:latin typeface="Courier"/>
+              </a:rPr>
+              <a:t>figures/</a:t>
+            </a:r>
+            <a:r>
+              <a:rPr/>
+              <a:t>.</a:t>
             </a:r>
           </a:p>
         </p:txBody>
@@ -8219,8 +8178,11 @@
         <p:spPr>
           <a:xfrm>
             <a:off x="0" y="0"/>
-            <a:ext cx="9144000" cy="582780"/>
+            <a:ext cx="9144000" cy="602780"/>
           </a:xfrm>
+          <a:solidFill>
+            <a:srgbClr val="1A1A2E"/>
+          </a:solidFill>
         </p:spPr>
         <p:txBody>
           <a:bodyPr/>
@@ -8231,7 +8193,7 @@
             </a:pPr>
             <a:r>
               <a:rPr/>
-              <a:t>→ ACTIVITY 3 Parts 4–5 now</a:t>
+              <a:t>What We Learned Today</a:t>
             </a:r>
           </a:p>
         </p:txBody>
@@ -8243,7 +8205,7 @@
             <a:spLocks noGrp="1"/>
           </p:cNvSpPr>
           <p:nvPr>
-            <p:ph idx="1"/>
+            <p:ph idx="1" sz="half"/>
           </p:nvPr>
         </p:nvSpPr>
         <p:spPr/>
@@ -8251,12 +8213,148 @@
           <a:bodyPr/>
           <a:lstStyle/>
           <a:p>
+            <a:pPr lvl="0"/>
+            <a:r>
+              <a:rPr/>
+              <a:t>Pipe straight into a plot: </a:t>
+            </a:r>
+            <a:r>
+              <a:rPr>
+                <a:latin typeface="Courier"/>
+              </a:rPr>
+              <a:t>leaf_df %&gt;% ggplot(...)</a:t>
+            </a:r>
+          </a:p>
+          <a:p>
+            <a:pPr lvl="0"/>
+            <a:r>
+              <a:rPr>
+                <a:latin typeface="Courier"/>
+              </a:rPr>
+              <a:t>scale_color_manual()</a:t>
+            </a:r>
+            <a:r>
+              <a:rPr/>
+              <a:t> / </a:t>
+            </a:r>
+            <a:r>
+              <a:rPr>
+                <a:latin typeface="Courier"/>
+              </a:rPr>
+              <a:t>scale_fill_manual()</a:t>
+            </a:r>
+            <a:r>
+              <a:rPr/>
+              <a:t> — colors you choose, not colors ggplot guesses</a:t>
+            </a:r>
+          </a:p>
+          <a:p>
+            <a:pPr lvl="0"/>
+            <a:r>
+              <a:rPr>
+                <a:latin typeface="Courier"/>
+              </a:rPr>
+              <a:t>facet_wrap(~var)</a:t>
+            </a:r>
+            <a:r>
+              <a:rPr/>
+              <a:t> — one panel per group, wraps automatically</a:t>
+            </a:r>
+          </a:p>
+          <a:p>
+            <a:pPr lvl="0"/>
+            <a:r>
+              <a:rPr>
+                <a:latin typeface="Courier"/>
+              </a:rPr>
+              <a:t>facet_grid(rows ~ cols)</a:t>
+            </a:r>
+            <a:r>
+              <a:rPr/>
+              <a:t> — strict grid, best with two grouping variables</a:t>
+            </a:r>
+          </a:p>
+          <a:p>
+            <a:pPr lvl="0"/>
+            <a:r>
+              <a:rPr>
+                <a:latin typeface="Courier"/>
+              </a:rPr>
+              <a:t>stat_summary()</a:t>
+            </a:r>
+            <a:r>
+              <a:rPr/>
+              <a:t> — mean and mean ± SE, drawn directly from raw data</a:t>
+            </a:r>
+          </a:p>
+        </p:txBody>
+      </p:sp>
+      <p:sp>
+        <p:nvSpPr>
+          <p:cNvPr id="4" name="Content Placeholder 3"/>
+          <p:cNvSpPr>
+            <a:spLocks noGrp="1"/>
+          </p:cNvSpPr>
+          <p:nvPr>
+            <p:ph idx="2" sz="half"/>
+          </p:nvPr>
+        </p:nvSpPr>
+        <p:spPr/>
+        <p:txBody>
+          <a:bodyPr/>
+          <a:lstStyle/>
+          <a:p>
             <a:pPr lvl="0" indent="0" marL="0">
               <a:buNone/>
             </a:pPr>
             <a:r>
               <a:rPr b="1"/>
-              <a:t>🛑 Go to Activity 3 — Parts 4–5</a:t>
+              <a:t>References:</a:t>
+            </a:r>
+          </a:p>
+          <a:p>
+            <a:pPr lvl="0"/>
+            <a:r>
+              <a:rPr/>
+              <a:t>📖 Whitlock &amp; Schluter, Ch. 2 — </a:t>
+            </a:r>
+            <a:r>
+              <a:rPr i="1"/>
+              <a:t>Displaying Data</a:t>
+            </a:r>
+          </a:p>
+          <a:p>
+            <a:pPr lvl="0"/>
+            <a:r>
+              <a:rPr/>
+              <a:t>📖 </a:t>
+            </a:r>
+            <a:r>
+              <a:rPr>
+                <a:hlinkClick r:id="rId2"/>
+              </a:rPr>
+              <a:t>R4DS Ch 1</a:t>
+            </a:r>
+            <a:r>
+              <a:rPr/>
+              <a:t> — Data Visualization</a:t>
+            </a:r>
+          </a:p>
+          <a:p>
+            <a:pPr lvl="0"/>
+            <a:r>
+              <a:rPr/>
+              <a:t>📖 </a:t>
+            </a:r>
+            <a:r>
+              <a:rPr>
+                <a:hlinkClick r:id="rId3"/>
+              </a:rPr>
+              <a:t>R4DS Ch 9</a:t>
+            </a:r>
+            <a:r>
+              <a:rPr/>
+              <a:t> — Layers</a:t>
             </a:r>
           </a:p>
           <a:p>
@@ -8264,18 +8362,47 @@
               <a:buNone/>
             </a:pPr>
             <a:r>
-              <a:rPr/>
-              <a:t>Close the slides. Build your own mean ± SE plot, then save it to </a:t>
-            </a:r>
-            <a:r>
-              <a:rPr>
-                <a:latin typeface="Courier"/>
-              </a:rPr>
-              <a:t>figures/</a:t>
-            </a:r>
-            <a:r>
-              <a:rPr/>
-              <a:t>.</a:t>
+              <a:rPr b="1"/>
+              <a:t>Up next — Lecture 04, GGPlot II:</a:t>
+            </a:r>
+          </a:p>
+          <a:p>
+            <a:pPr lvl="0"/>
+            <a:r>
+              <a:rPr/>
+              <a:t>Practicing on a brand-new dataset</a:t>
+            </a:r>
+          </a:p>
+          <a:p>
+            <a:pPr lvl="0"/>
+            <a:r>
+              <a:rPr>
+                <a:latin typeface="Courier"/>
+              </a:rPr>
+              <a:t>coord_cartesian()</a:t>
+            </a:r>
+            <a:r>
+              <a:rPr/>
+              <a:t> vs. </a:t>
+            </a:r>
+            <a:r>
+              <a:rPr>
+                <a:latin typeface="Courier"/>
+              </a:rPr>
+              <a:t>ylim()</a:t>
+            </a:r>
+          </a:p>
+          <a:p>
+            <a:pPr lvl="0"/>
+            <a:r>
+              <a:rPr/>
+              <a:t>Histograms, density plots, themes, and </a:t>
+            </a:r>
+            <a:r>
+              <a:rPr>
+                <a:latin typeface="Courier"/>
+              </a:rPr>
+              <a:t>patchwork</a:t>
             </a:r>
           </a:p>
         </p:txBody>
@@ -8514,270 +8641,6 @@
             <a:r>
               <a:rPr sz="2000"/>
               <a:t>You can already load data and make one honest point on a page. Today that one geom becomes a whole toolkit: custom colors, side-by-side panels, and a proper mean ± SE summary.</a:t>
-            </a:r>
-          </a:p>
-        </p:txBody>
-      </p:sp>
-    </p:spTree>
-  </p:cSld>
-</p:sld>
-</file>
-
-<file path=ppt/slides/slide20.xml><?xml version="1.0" encoding="utf-8"?>
-<p:sld xmlns:a="http://schemas.openxmlformats.org/drawingml/2006/main" xmlns:r="http://schemas.openxmlformats.org/officeDocument/2006/relationships" xmlns:p="http://schemas.openxmlformats.org/presentationml/2006/main">
-  <p:cSld>
-    <p:spTree>
-      <p:nvGrpSpPr>
-        <p:cNvPr id="1" name=""/>
-        <p:cNvGrpSpPr/>
-        <p:nvPr/>
-      </p:nvGrpSpPr>
-      <p:grpSpPr>
-        <a:xfrm>
-          <a:off x="0" y="0"/>
-          <a:ext cx="0" cy="0"/>
-          <a:chOff x="0" y="0"/>
-          <a:chExt cx="0" cy="0"/>
-        </a:xfrm>
-      </p:grpSpPr>
-      <p:sp>
-        <p:nvSpPr>
-          <p:cNvPr id="2" name="Title 1"/>
-          <p:cNvSpPr>
-            <a:spLocks noGrp="1"/>
-          </p:cNvSpPr>
-          <p:nvPr>
-            <p:ph type="title"/>
-          </p:nvPr>
-        </p:nvSpPr>
-        <p:spPr>
-          <a:xfrm>
-            <a:off x="0" y="0"/>
-            <a:ext cx="9144000" cy="602780"/>
-          </a:xfrm>
-          <a:solidFill>
-            <a:srgbClr val="1A1A2E"/>
-          </a:solidFill>
-        </p:spPr>
-        <p:txBody>
-          <a:bodyPr/>
-          <a:lstStyle/>
-          <a:p>
-            <a:pPr lvl="0" indent="0" marL="0">
-              <a:buNone/>
-            </a:pPr>
-            <a:r>
-              <a:rPr/>
-              <a:t>What We Learned Today</a:t>
-            </a:r>
-          </a:p>
-        </p:txBody>
-      </p:sp>
-      <p:sp>
-        <p:nvSpPr>
-          <p:cNvPr id="3" name="Content Placeholder 2"/>
-          <p:cNvSpPr>
-            <a:spLocks noGrp="1"/>
-          </p:cNvSpPr>
-          <p:nvPr>
-            <p:ph idx="1" sz="half"/>
-          </p:nvPr>
-        </p:nvSpPr>
-        <p:spPr/>
-        <p:txBody>
-          <a:bodyPr/>
-          <a:lstStyle/>
-          <a:p>
-            <a:pPr lvl="0"/>
-            <a:r>
-              <a:rPr/>
-              <a:t>Pipe straight into a plot: </a:t>
-            </a:r>
-            <a:r>
-              <a:rPr>
-                <a:latin typeface="Courier"/>
-              </a:rPr>
-              <a:t>leaf_df %&gt;% ggplot(...)</a:t>
-            </a:r>
-          </a:p>
-          <a:p>
-            <a:pPr lvl="0"/>
-            <a:r>
-              <a:rPr>
-                <a:latin typeface="Courier"/>
-              </a:rPr>
-              <a:t>scale_color_manual()</a:t>
-            </a:r>
-            <a:r>
-              <a:rPr/>
-              <a:t> / </a:t>
-            </a:r>
-            <a:r>
-              <a:rPr>
-                <a:latin typeface="Courier"/>
-              </a:rPr>
-              <a:t>scale_fill_manual()</a:t>
-            </a:r>
-            <a:r>
-              <a:rPr/>
-              <a:t> — colors you choose, not colors ggplot guesses</a:t>
-            </a:r>
-          </a:p>
-          <a:p>
-            <a:pPr lvl="0"/>
-            <a:r>
-              <a:rPr>
-                <a:latin typeface="Courier"/>
-              </a:rPr>
-              <a:t>facet_wrap(~var)</a:t>
-            </a:r>
-            <a:r>
-              <a:rPr/>
-              <a:t> — one panel per group, wraps automatically</a:t>
-            </a:r>
-          </a:p>
-          <a:p>
-            <a:pPr lvl="0"/>
-            <a:r>
-              <a:rPr>
-                <a:latin typeface="Courier"/>
-              </a:rPr>
-              <a:t>facet_grid(rows ~ cols)</a:t>
-            </a:r>
-            <a:r>
-              <a:rPr/>
-              <a:t> — strict grid, best with two grouping variables</a:t>
-            </a:r>
-          </a:p>
-          <a:p>
-            <a:pPr lvl="0"/>
-            <a:r>
-              <a:rPr>
-                <a:latin typeface="Courier"/>
-              </a:rPr>
-              <a:t>stat_summary()</a:t>
-            </a:r>
-            <a:r>
-              <a:rPr/>
-              <a:t> — mean and mean ± SE, drawn directly from raw data</a:t>
-            </a:r>
-          </a:p>
-        </p:txBody>
-      </p:sp>
-      <p:sp>
-        <p:nvSpPr>
-          <p:cNvPr id="4" name="Content Placeholder 3"/>
-          <p:cNvSpPr>
-            <a:spLocks noGrp="1"/>
-          </p:cNvSpPr>
-          <p:nvPr>
-            <p:ph idx="2" sz="half"/>
-          </p:nvPr>
-        </p:nvSpPr>
-        <p:spPr/>
-        <p:txBody>
-          <a:bodyPr/>
-          <a:lstStyle/>
-          <a:p>
-            <a:pPr lvl="0" indent="0" marL="0">
-              <a:buNone/>
-            </a:pPr>
-            <a:r>
-              <a:rPr b="1"/>
-              <a:t>References:</a:t>
-            </a:r>
-          </a:p>
-          <a:p>
-            <a:pPr lvl="0"/>
-            <a:r>
-              <a:rPr/>
-              <a:t>📖 Whitlock &amp; Schluter, Ch. 2 — </a:t>
-            </a:r>
-            <a:r>
-              <a:rPr i="1"/>
-              <a:t>Displaying Data</a:t>
-            </a:r>
-          </a:p>
-          <a:p>
-            <a:pPr lvl="0"/>
-            <a:r>
-              <a:rPr/>
-              <a:t>📖 </a:t>
-            </a:r>
-            <a:r>
-              <a:rPr>
-                <a:hlinkClick r:id="rId2"/>
-              </a:rPr>
-              <a:t>R4DS Ch 1</a:t>
-            </a:r>
-            <a:r>
-              <a:rPr/>
-              <a:t> — Data Visualization</a:t>
-            </a:r>
-          </a:p>
-          <a:p>
-            <a:pPr lvl="0"/>
-            <a:r>
-              <a:rPr/>
-              <a:t>📖 </a:t>
-            </a:r>
-            <a:r>
-              <a:rPr>
-                <a:hlinkClick r:id="rId3"/>
-              </a:rPr>
-              <a:t>R4DS Ch 9</a:t>
-            </a:r>
-            <a:r>
-              <a:rPr/>
-              <a:t> — Layers</a:t>
-            </a:r>
-          </a:p>
-          <a:p>
-            <a:pPr lvl="0" indent="0" marL="0">
-              <a:buNone/>
-            </a:pPr>
-            <a:r>
-              <a:rPr b="1"/>
-              <a:t>Up next — Lecture 04, GGPlot II:</a:t>
-            </a:r>
-          </a:p>
-          <a:p>
-            <a:pPr lvl="0"/>
-            <a:r>
-              <a:rPr/>
-              <a:t>Practicing on a brand-new dataset</a:t>
-            </a:r>
-          </a:p>
-          <a:p>
-            <a:pPr lvl="0"/>
-            <a:r>
-              <a:rPr>
-                <a:latin typeface="Courier"/>
-              </a:rPr>
-              <a:t>coord_cartesian()</a:t>
-            </a:r>
-            <a:r>
-              <a:rPr/>
-              <a:t> vs. </a:t>
-            </a:r>
-            <a:r>
-              <a:rPr>
-                <a:latin typeface="Courier"/>
-              </a:rPr>
-              <a:t>ylim()</a:t>
-            </a:r>
-          </a:p>
-          <a:p>
-            <a:pPr lvl="0"/>
-            <a:r>
-              <a:rPr/>
-              <a:t>Histograms, density plots, themes, and </a:t>
-            </a:r>
-            <a:r>
-              <a:rPr>
-                <a:latin typeface="Courier"/>
-              </a:rPr>
-              <a:t>patchwork</a:t>
             </a:r>
           </a:p>
         </p:txBody>
@@ -10158,6 +10021,78 @@
               </a:rPr>
               <a:t>(</a:t>
             </a:r>
+            <a:r>
+              <a:rPr>
+                <a:solidFill>
+                  <a:srgbClr val="657422"/>
+                </a:solidFill>
+                <a:latin typeface="Courier"/>
+              </a:rPr>
+              <a:t>title =</a:t>
+            </a:r>
+            <a:r>
+              <a:rPr>
+                <a:solidFill>
+                  <a:srgbClr val="003B4F"/>
+                </a:solidFill>
+                <a:latin typeface="Courier"/>
+              </a:rPr>
+              <a:t> </a:t>
+            </a:r>
+            <a:r>
+              <a:rPr>
+                <a:solidFill>
+                  <a:srgbClr val="20794D"/>
+                </a:solidFill>
+                <a:latin typeface="Courier"/>
+              </a:rPr>
+              <a:t>"Leaf Mass by Shade"</a:t>
+            </a:r>
+            <a:r>
+              <a:rPr>
+                <a:solidFill>
+                  <a:srgbClr val="003B4F"/>
+                </a:solidFill>
+                <a:latin typeface="Courier"/>
+              </a:rPr>
+              <a:t>, </a:t>
+            </a:r>
+            <a:r>
+              <a:rPr>
+                <a:solidFill>
+                  <a:srgbClr val="657422"/>
+                </a:solidFill>
+                <a:latin typeface="Courier"/>
+              </a:rPr>
+              <a:t>x =</a:t>
+            </a:r>
+            <a:r>
+              <a:rPr>
+                <a:solidFill>
+                  <a:srgbClr val="003B4F"/>
+                </a:solidFill>
+                <a:latin typeface="Courier"/>
+              </a:rPr>
+              <a:t> </a:t>
+            </a:r>
+            <a:r>
+              <a:rPr>
+                <a:solidFill>
+                  <a:srgbClr val="20794D"/>
+                </a:solidFill>
+                <a:latin typeface="Courier"/>
+              </a:rPr>
+              <a:t>"Shade"</a:t>
+            </a:r>
+            <a:r>
+              <a:rPr>
+                <a:solidFill>
+                  <a:srgbClr val="003B4F"/>
+                </a:solidFill>
+                <a:latin typeface="Courier"/>
+              </a:rPr>
+              <a:t>,</a:t>
+            </a:r>
             <a:br/>
             <a:r>
               <a:rPr>
@@ -10166,7 +10101,7 @@
                 </a:solidFill>
                 <a:latin typeface="Courier"/>
               </a:rPr>
-              <a:t>    </a:t>
+              <a:t>       </a:t>
             </a:r>
             <a:r>
               <a:rPr>
@@ -10175,7 +10110,7 @@
                 </a:solidFill>
                 <a:latin typeface="Courier"/>
               </a:rPr>
-              <a:t>title =</a:t>
+              <a:t>y =</a:t>
             </a:r>
             <a:r>
               <a:rPr>
@@ -10193,26 +10128,16 @@
                 </a:solidFill>
                 <a:latin typeface="Courier"/>
               </a:rPr>
-              <a:t>"Leaf Mass by Shade"</a:t>
-            </a:r>
-            <a:r>
-              <a:rPr>
-                <a:solidFill>
-                  <a:srgbClr val="003B4F"/>
-                </a:solidFill>
-                <a:latin typeface="Courier"/>
-              </a:rPr>
-              <a:t>,</a:t>
-            </a:r>
-            <a:br/>
-            <a:r>
-              <a:rPr>
-                <a:solidFill>
-                  <a:srgbClr val="003B4F"/>
-                </a:solidFill>
-                <a:latin typeface="Courier"/>
-              </a:rPr>
-              <a:t>    </a:t>
+              <a:t>"Leaf Mass (g)"</a:t>
+            </a:r>
+            <a:r>
+              <a:rPr>
+                <a:solidFill>
+                  <a:srgbClr val="003B4F"/>
+                </a:solidFill>
+                <a:latin typeface="Courier"/>
+              </a:rPr>
+              <a:t>, </a:t>
             </a:r>
             <a:r>
               <a:rPr>
@@ -10221,7 +10146,7 @@
                 </a:solidFill>
                 <a:latin typeface="Courier"/>
               </a:rPr>
-              <a:t>x =</a:t>
+              <a:t>fill =</a:t>
             </a:r>
             <a:r>
               <a:rPr>
@@ -10248,100 +10173,7 @@
                 </a:solidFill>
                 <a:latin typeface="Courier"/>
               </a:rPr>
-              <a:t>,</a:t>
-            </a:r>
-            <a:br/>
-            <a:r>
-              <a:rPr>
-                <a:solidFill>
-                  <a:srgbClr val="003B4F"/>
-                </a:solidFill>
-                <a:latin typeface="Courier"/>
-              </a:rPr>
-              <a:t>    </a:t>
-            </a:r>
-            <a:r>
-              <a:rPr>
-                <a:solidFill>
-                  <a:srgbClr val="657422"/>
-                </a:solidFill>
-                <a:latin typeface="Courier"/>
-              </a:rPr>
-              <a:t>y =</a:t>
-            </a:r>
-            <a:r>
-              <a:rPr>
-                <a:solidFill>
-                  <a:srgbClr val="003B4F"/>
-                </a:solidFill>
-                <a:latin typeface="Courier"/>
-              </a:rPr>
-              <a:t> </a:t>
-            </a:r>
-            <a:r>
-              <a:rPr>
-                <a:solidFill>
-                  <a:srgbClr val="20794D"/>
-                </a:solidFill>
-                <a:latin typeface="Courier"/>
-              </a:rPr>
-              <a:t>"Leaf Mass (g)"</a:t>
-            </a:r>
-            <a:r>
-              <a:rPr>
-                <a:solidFill>
-                  <a:srgbClr val="003B4F"/>
-                </a:solidFill>
-                <a:latin typeface="Courier"/>
-              </a:rPr>
-              <a:t>,</a:t>
-            </a:r>
-            <a:br/>
-            <a:r>
-              <a:rPr>
-                <a:solidFill>
-                  <a:srgbClr val="003B4F"/>
-                </a:solidFill>
-                <a:latin typeface="Courier"/>
-              </a:rPr>
-              <a:t>    </a:t>
-            </a:r>
-            <a:r>
-              <a:rPr>
-                <a:solidFill>
-                  <a:srgbClr val="657422"/>
-                </a:solidFill>
-                <a:latin typeface="Courier"/>
-              </a:rPr>
-              <a:t>fill =</a:t>
-            </a:r>
-            <a:r>
-              <a:rPr>
-                <a:solidFill>
-                  <a:srgbClr val="003B4F"/>
-                </a:solidFill>
-                <a:latin typeface="Courier"/>
-              </a:rPr>
-              <a:t> </a:t>
-            </a:r>
-            <a:r>
-              <a:rPr>
-                <a:solidFill>
-                  <a:srgbClr val="20794D"/>
-                </a:solidFill>
-                <a:latin typeface="Courier"/>
-              </a:rPr>
-              <a:t>"Shade"</a:t>
-            </a:r>
-            <a:br/>
-            <a:r>
-              <a:rPr>
-                <a:solidFill>
-                  <a:srgbClr val="003B4F"/>
-                </a:solidFill>
-                <a:latin typeface="Courier"/>
-              </a:rPr>
-              <a:t>  ) </a:t>
+              <a:t>) </a:t>
             </a:r>
             <a:r>
               <a:rPr>
@@ -10437,7 +10269,7 @@
             </a:r>
             <a:r>
               <a:rPr/>
-              <a:t> reads as </a:t>
+              <a:t> = </a:t>
             </a:r>
             <a:r>
               <a:rPr i="1"/>
@@ -10453,10 +10285,6 @@
               <a:rPr i="1"/>
               <a:t>, then plot it”</a:t>
             </a:r>
-            <a:r>
-              <a:rPr/>
-              <a:t> — the same pipe you’ve already used</a:t>
-            </a:r>
           </a:p>
           <a:p>
             <a:pPr lvl="0"/>
@@ -10489,14 +10317,6 @@
                 <a:latin typeface="Courier"/>
               </a:rPr>
               <a:t>%&gt;%</a:t>
-            </a:r>
-            <a:r>
-              <a:rPr/>
-              <a:t> — </a:t>
-            </a:r>
-            <a:r>
-              <a:rPr b="1"/>
-              <a:t>ggplot layers use plus, pipelines use the pipe</a:t>
             </a:r>
           </a:p>
           <a:p>
@@ -10517,15 +10337,7 @@
             </a:r>
             <a:r>
               <a:rPr/>
-              <a:t> to color — ggplot chooses the colors </a:t>
-            </a:r>
-            <a:r>
-              <a:rPr i="1"/>
-              <a:t>for</a:t>
-            </a:r>
-            <a:r>
-              <a:rPr/>
-              <a:t> you</a:t>
+              <a:t> to color — ggplot picks the colors</a:t>
             </a:r>
           </a:p>
           <a:p>
@@ -10674,27 +10486,7 @@
             </a:r>
             <a:r>
               <a:rPr sz="2000"/>
-              <a:t> needs one color per group. We have two groups (</a:t>
-            </a:r>
-            <a:r>
-              <a:rPr sz="2000">
-                <a:latin typeface="Courier"/>
-              </a:rPr>
-              <a:t>sunny</a:t>
-            </a:r>
-            <a:r>
-              <a:rPr sz="2000"/>
-              <a:t>, </a:t>
-            </a:r>
-            <a:r>
-              <a:rPr sz="2000">
-                <a:latin typeface="Courier"/>
-              </a:rPr>
-              <a:t>shady</a:t>
-            </a:r>
-            <a:r>
-              <a:rPr sz="2000"/>
-              <a:t>). How many colors do we need to supply?</a:t>
+              <a:t> needs one color per group. We have two groups — how many colors do we supply?</a:t>
             </a:r>
           </a:p>
         </p:txBody>
@@ -11158,6 +10950,42 @@
               </a:rPr>
               <a:t>(</a:t>
             </a:r>
+            <a:r>
+              <a:rPr>
+                <a:solidFill>
+                  <a:srgbClr val="20794D"/>
+                </a:solidFill>
+                <a:latin typeface="Courier"/>
+              </a:rPr>
+              <a:t>"sunny"</a:t>
+            </a:r>
+            <a:r>
+              <a:rPr>
+                <a:solidFill>
+                  <a:srgbClr val="003B4F"/>
+                </a:solidFill>
+                <a:latin typeface="Courier"/>
+              </a:rPr>
+              <a:t> = </a:t>
+            </a:r>
+            <a:r>
+              <a:rPr>
+                <a:solidFill>
+                  <a:srgbClr val="20794D"/>
+                </a:solidFill>
+                <a:latin typeface="Courier"/>
+              </a:rPr>
+              <a:t>"goldenrod"</a:t>
+            </a:r>
+            <a:r>
+              <a:rPr>
+                <a:solidFill>
+                  <a:srgbClr val="003B4F"/>
+                </a:solidFill>
+                <a:latin typeface="Courier"/>
+              </a:rPr>
+              <a:t>,</a:t>
+            </a:r>
             <a:br/>
             <a:r>
               <a:rPr>
@@ -11166,7 +10994,7 @@
                 </a:solidFill>
                 <a:latin typeface="Courier"/>
               </a:rPr>
-              <a:t>    </a:t>
+              <a:t>                               </a:t>
             </a:r>
             <a:r>
               <a:rPr>
@@ -11175,7 +11003,7 @@
                 </a:solidFill>
                 <a:latin typeface="Courier"/>
               </a:rPr>
-              <a:t>"sunny"</a:t>
+              <a:t>"shady"</a:t>
             </a:r>
             <a:r>
               <a:rPr>
@@ -11193,7 +11021,116 @@
                 </a:solidFill>
                 <a:latin typeface="Courier"/>
               </a:rPr>
-              <a:t>"goldenrod"</a:t>
+              <a:t>"forestgreen"</a:t>
+            </a:r>
+            <a:r>
+              <a:rPr>
+                <a:solidFill>
+                  <a:srgbClr val="003B4F"/>
+                </a:solidFill>
+                <a:latin typeface="Courier"/>
+              </a:rPr>
+              <a:t>)) </a:t>
+            </a:r>
+            <a:r>
+              <a:rPr>
+                <a:solidFill>
+                  <a:srgbClr val="5E5E5E"/>
+                </a:solidFill>
+                <a:latin typeface="Courier"/>
+              </a:rPr>
+              <a:t>+</a:t>
+            </a:r>
+            <a:br/>
+            <a:r>
+              <a:rPr>
+                <a:solidFill>
+                  <a:srgbClr val="003B4F"/>
+                </a:solidFill>
+                <a:latin typeface="Courier"/>
+              </a:rPr>
+              <a:t>  </a:t>
+            </a:r>
+            <a:r>
+              <a:rPr>
+                <a:solidFill>
+                  <a:srgbClr val="4758AB"/>
+                </a:solidFill>
+                <a:latin typeface="Courier"/>
+              </a:rPr>
+              <a:t>labs</a:t>
+            </a:r>
+            <a:r>
+              <a:rPr>
+                <a:solidFill>
+                  <a:srgbClr val="003B4F"/>
+                </a:solidFill>
+                <a:latin typeface="Courier"/>
+              </a:rPr>
+              <a:t>(</a:t>
+            </a:r>
+            <a:r>
+              <a:rPr>
+                <a:solidFill>
+                  <a:srgbClr val="657422"/>
+                </a:solidFill>
+                <a:latin typeface="Courier"/>
+              </a:rPr>
+              <a:t>title =</a:t>
+            </a:r>
+            <a:r>
+              <a:rPr>
+                <a:solidFill>
+                  <a:srgbClr val="003B4F"/>
+                </a:solidFill>
+                <a:latin typeface="Courier"/>
+              </a:rPr>
+              <a:t> </a:t>
+            </a:r>
+            <a:r>
+              <a:rPr>
+                <a:solidFill>
+                  <a:srgbClr val="20794D"/>
+                </a:solidFill>
+                <a:latin typeface="Courier"/>
+              </a:rPr>
+              <a:t>"Leaf Mass by Shade"</a:t>
+            </a:r>
+            <a:r>
+              <a:rPr>
+                <a:solidFill>
+                  <a:srgbClr val="003B4F"/>
+                </a:solidFill>
+                <a:latin typeface="Courier"/>
+              </a:rPr>
+              <a:t>, </a:t>
+            </a:r>
+            <a:r>
+              <a:rPr>
+                <a:solidFill>
+                  <a:srgbClr val="657422"/>
+                </a:solidFill>
+                <a:latin typeface="Courier"/>
+              </a:rPr>
+              <a:t>x =</a:t>
+            </a:r>
+            <a:r>
+              <a:rPr>
+                <a:solidFill>
+                  <a:srgbClr val="003B4F"/>
+                </a:solidFill>
+                <a:latin typeface="Courier"/>
+              </a:rPr>
+              <a:t> </a:t>
+            </a:r>
+            <a:r>
+              <a:rPr>
+                <a:solidFill>
+                  <a:srgbClr val="20794D"/>
+                </a:solidFill>
+                <a:latin typeface="Courier"/>
+              </a:rPr>
+              <a:t>"Shade"</a:t>
             </a:r>
             <a:r>
               <a:rPr>
@@ -11212,7 +11149,25 @@
                 </a:solidFill>
                 <a:latin typeface="Courier"/>
               </a:rPr>
-              <a:t>    </a:t>
+              <a:t>       </a:t>
+            </a:r>
+            <a:r>
+              <a:rPr>
+                <a:solidFill>
+                  <a:srgbClr val="657422"/>
+                </a:solidFill>
+                <a:latin typeface="Courier"/>
+              </a:rPr>
+              <a:t>y =</a:t>
+            </a:r>
+            <a:r>
+              <a:rPr>
+                <a:solidFill>
+                  <a:srgbClr val="003B4F"/>
+                </a:solidFill>
+                <a:latin typeface="Courier"/>
+              </a:rPr>
+              <a:t> </a:t>
             </a:r>
             <a:r>
               <a:rPr>
@@ -11221,16 +11176,34 @@
                 </a:solidFill>
                 <a:latin typeface="Courier"/>
               </a:rPr>
-              <a:t>"shady"</a:t>
-            </a:r>
-            <a:r>
-              <a:rPr>
-                <a:solidFill>
-                  <a:srgbClr val="003B4F"/>
-                </a:solidFill>
-                <a:latin typeface="Courier"/>
-              </a:rPr>
-              <a:t> = </a:t>
+              <a:t>"Leaf Mass (g)"</a:t>
+            </a:r>
+            <a:r>
+              <a:rPr>
+                <a:solidFill>
+                  <a:srgbClr val="003B4F"/>
+                </a:solidFill>
+                <a:latin typeface="Courier"/>
+              </a:rPr>
+              <a:t>, </a:t>
+            </a:r>
+            <a:r>
+              <a:rPr>
+                <a:solidFill>
+                  <a:srgbClr val="657422"/>
+                </a:solidFill>
+                <a:latin typeface="Courier"/>
+              </a:rPr>
+              <a:t>fill =</a:t>
+            </a:r>
+            <a:r>
+              <a:rPr>
+                <a:solidFill>
+                  <a:srgbClr val="003B4F"/>
+                </a:solidFill>
+                <a:latin typeface="Courier"/>
+              </a:rPr>
+              <a:t> </a:t>
             </a:r>
             <a:r>
               <a:rPr>
@@ -11239,136 +11212,6 @@
                 </a:solidFill>
                 <a:latin typeface="Courier"/>
               </a:rPr>
-              <a:t>"forestgreen"</a:t>
-            </a:r>
-            <a:br/>
-            <a:r>
-              <a:rPr>
-                <a:solidFill>
-                  <a:srgbClr val="003B4F"/>
-                </a:solidFill>
-                <a:latin typeface="Courier"/>
-              </a:rPr>
-              <a:t>  )) </a:t>
-            </a:r>
-            <a:r>
-              <a:rPr>
-                <a:solidFill>
-                  <a:srgbClr val="5E5E5E"/>
-                </a:solidFill>
-                <a:latin typeface="Courier"/>
-              </a:rPr>
-              <a:t>+</a:t>
-            </a:r>
-            <a:br/>
-            <a:r>
-              <a:rPr>
-                <a:solidFill>
-                  <a:srgbClr val="003B4F"/>
-                </a:solidFill>
-                <a:latin typeface="Courier"/>
-              </a:rPr>
-              <a:t>  </a:t>
-            </a:r>
-            <a:r>
-              <a:rPr>
-                <a:solidFill>
-                  <a:srgbClr val="4758AB"/>
-                </a:solidFill>
-                <a:latin typeface="Courier"/>
-              </a:rPr>
-              <a:t>labs</a:t>
-            </a:r>
-            <a:r>
-              <a:rPr>
-                <a:solidFill>
-                  <a:srgbClr val="003B4F"/>
-                </a:solidFill>
-                <a:latin typeface="Courier"/>
-              </a:rPr>
-              <a:t>(</a:t>
-            </a:r>
-            <a:br/>
-            <a:r>
-              <a:rPr>
-                <a:solidFill>
-                  <a:srgbClr val="003B4F"/>
-                </a:solidFill>
-                <a:latin typeface="Courier"/>
-              </a:rPr>
-              <a:t>    </a:t>
-            </a:r>
-            <a:r>
-              <a:rPr>
-                <a:solidFill>
-                  <a:srgbClr val="657422"/>
-                </a:solidFill>
-                <a:latin typeface="Courier"/>
-              </a:rPr>
-              <a:t>title =</a:t>
-            </a:r>
-            <a:r>
-              <a:rPr>
-                <a:solidFill>
-                  <a:srgbClr val="003B4F"/>
-                </a:solidFill>
-                <a:latin typeface="Courier"/>
-              </a:rPr>
-              <a:t> </a:t>
-            </a:r>
-            <a:r>
-              <a:rPr>
-                <a:solidFill>
-                  <a:srgbClr val="20794D"/>
-                </a:solidFill>
-                <a:latin typeface="Courier"/>
-              </a:rPr>
-              <a:t>"Leaf Mass by Shade"</a:t>
-            </a:r>
-            <a:r>
-              <a:rPr>
-                <a:solidFill>
-                  <a:srgbClr val="003B4F"/>
-                </a:solidFill>
-                <a:latin typeface="Courier"/>
-              </a:rPr>
-              <a:t>,</a:t>
-            </a:r>
-            <a:br/>
-            <a:r>
-              <a:rPr>
-                <a:solidFill>
-                  <a:srgbClr val="003B4F"/>
-                </a:solidFill>
-                <a:latin typeface="Courier"/>
-              </a:rPr>
-              <a:t>    </a:t>
-            </a:r>
-            <a:r>
-              <a:rPr>
-                <a:solidFill>
-                  <a:srgbClr val="657422"/>
-                </a:solidFill>
-                <a:latin typeface="Courier"/>
-              </a:rPr>
-              <a:t>x =</a:t>
-            </a:r>
-            <a:r>
-              <a:rPr>
-                <a:solidFill>
-                  <a:srgbClr val="003B4F"/>
-                </a:solidFill>
-                <a:latin typeface="Courier"/>
-              </a:rPr>
-              <a:t> </a:t>
-            </a:r>
-            <a:r>
-              <a:rPr>
-                <a:solidFill>
-                  <a:srgbClr val="20794D"/>
-                </a:solidFill>
-                <a:latin typeface="Courier"/>
-              </a:rPr>
               <a:t>"Shade"</a:t>
             </a:r>
             <a:r>
@@ -11378,100 +11221,7 @@
                 </a:solidFill>
                 <a:latin typeface="Courier"/>
               </a:rPr>
-              <a:t>,</a:t>
-            </a:r>
-            <a:br/>
-            <a:r>
-              <a:rPr>
-                <a:solidFill>
-                  <a:srgbClr val="003B4F"/>
-                </a:solidFill>
-                <a:latin typeface="Courier"/>
-              </a:rPr>
-              <a:t>    </a:t>
-            </a:r>
-            <a:r>
-              <a:rPr>
-                <a:solidFill>
-                  <a:srgbClr val="657422"/>
-                </a:solidFill>
-                <a:latin typeface="Courier"/>
-              </a:rPr>
-              <a:t>y =</a:t>
-            </a:r>
-            <a:r>
-              <a:rPr>
-                <a:solidFill>
-                  <a:srgbClr val="003B4F"/>
-                </a:solidFill>
-                <a:latin typeface="Courier"/>
-              </a:rPr>
-              <a:t> </a:t>
-            </a:r>
-            <a:r>
-              <a:rPr>
-                <a:solidFill>
-                  <a:srgbClr val="20794D"/>
-                </a:solidFill>
-                <a:latin typeface="Courier"/>
-              </a:rPr>
-              <a:t>"Leaf Mass (g)"</a:t>
-            </a:r>
-            <a:r>
-              <a:rPr>
-                <a:solidFill>
-                  <a:srgbClr val="003B4F"/>
-                </a:solidFill>
-                <a:latin typeface="Courier"/>
-              </a:rPr>
-              <a:t>,</a:t>
-            </a:r>
-            <a:br/>
-            <a:r>
-              <a:rPr>
-                <a:solidFill>
-                  <a:srgbClr val="003B4F"/>
-                </a:solidFill>
-                <a:latin typeface="Courier"/>
-              </a:rPr>
-              <a:t>    </a:t>
-            </a:r>
-            <a:r>
-              <a:rPr>
-                <a:solidFill>
-                  <a:srgbClr val="657422"/>
-                </a:solidFill>
-                <a:latin typeface="Courier"/>
-              </a:rPr>
-              <a:t>fill =</a:t>
-            </a:r>
-            <a:r>
-              <a:rPr>
-                <a:solidFill>
-                  <a:srgbClr val="003B4F"/>
-                </a:solidFill>
-                <a:latin typeface="Courier"/>
-              </a:rPr>
-              <a:t> </a:t>
-            </a:r>
-            <a:r>
-              <a:rPr>
-                <a:solidFill>
-                  <a:srgbClr val="20794D"/>
-                </a:solidFill>
-                <a:latin typeface="Courier"/>
-              </a:rPr>
-              <a:t>"Shade"</a:t>
-            </a:r>
-            <a:br/>
-            <a:r>
-              <a:rPr>
-                <a:solidFill>
-                  <a:srgbClr val="003B4F"/>
-                </a:solidFill>
-                <a:latin typeface="Courier"/>
-              </a:rPr>
-              <a:t>  ) </a:t>
+              <a:t>) </a:t>
             </a:r>
             <a:r>
               <a:rPr>
@@ -11684,7 +11434,7 @@
             </a:r>
             <a:r>
               <a:rPr b="1"/>
-              <a:t>names inside </a:t>
+              <a:t>names in </a:t>
             </a:r>
             <a:r>
               <a:rPr b="1">
@@ -11698,27 +11448,7 @@
             </a:r>
             <a:r>
               <a:rPr/>
-              <a:t> the values in your data (</a:t>
-            </a:r>
-            <a:r>
-              <a:rPr>
-                <a:latin typeface="Courier"/>
-              </a:rPr>
-              <a:t>"sunny"</a:t>
-            </a:r>
-            <a:r>
-              <a:rPr/>
-              <a:t>, </a:t>
-            </a:r>
-            <a:r>
-              <a:rPr>
-                <a:latin typeface="Courier"/>
-              </a:rPr>
-              <a:t>"shady"</a:t>
-            </a:r>
-            <a:r>
-              <a:rPr/>
-              <a:t>) — case and spelling both count</a:t>
+              <a:t> your data’s values — case and spelling count</a:t>
             </a:r>
           </a:p>
           <a:p>
@@ -11738,24 +11468,9 @@
               <a:rPr sz="2000" b="1"/>
               <a:t>⚠️ Watch out!</a:t>
             </a:r>
-          </a:p>
-          <a:p>
-            <a:pPr lvl="0" indent="0" marL="1270000">
-              <a:buNone/>
-            </a:pPr>
             <a:r>
               <a:rPr sz="2000"/>
-              <a:t>If a name in </a:t>
-            </a:r>
-            <a:r>
-              <a:rPr sz="2000">
-                <a:latin typeface="Courier"/>
-              </a:rPr>
-              <a:t>values = c(...)</a:t>
-            </a:r>
-            <a:r>
-              <a:rPr sz="2000"/>
-              <a:t> doesn’t match a value in your data exactly, that group’s color falls back to grey and ggplot prints a warning.</a:t>
+              <a:t> A name that doesn’t match falls back to grey, with a warning.</a:t>
             </a:r>
           </a:p>
         </p:txBody>

</xml_diff>